<commit_message>
Replace the add-gene deck with an English Dan / Jesse / final-decision version.
Co-authored-by: Cursor <cursoragent@cursor.com>
</commit_message>
<xml_diff>
--- a/v3/outputs/Add_genes_Jesse_Allen_Dan_4slides.pptx
+++ b/v3/outputs/Add_genes_Jesse_Allen_Dan_4slides.pptx
@@ -8,7 +8,6 @@
     <p:sldId id="256" r:id="rId7"/>
     <p:sldId id="257" r:id="rId8"/>
     <p:sldId id="258" r:id="rId9"/>
-    <p:sldId id="259" r:id="rId10"/>
   </p:sldIdLst>
   <p:sldSz cx="12191695" cy="6858000" type="screen4x3"/>
   <p:notesSz cx="6858000" cy="9144000"/>
@@ -3106,7 +3105,7 @@
             <a:avLst/>
           </a:prstGeom>
           <a:solidFill>
-            <a:srgbClr val="1D4E89"/>
+            <a:srgbClr val="2A6F97"/>
           </a:solidFill>
           <a:ln>
             <a:noFill/>
@@ -3143,7 +3142,7 @@
         <p:spPr>
           <a:xfrm>
             <a:off x="411480" y="201168"/>
-            <a:ext cx="11338560" cy="420624"/>
+            <a:ext cx="11338560" cy="402336"/>
           </a:xfrm>
           <a:prstGeom prst="rect">
             <a:avLst/>
@@ -3157,14 +3156,13 @@
           <a:lstStyle/>
           <a:p>
             <a:r>
-              <a:rPr sz="2400" b="1">
+              <a:rPr sz="2600" b="1">
                 <a:solidFill>
                   <a:srgbClr val="1D4E89"/>
                 </a:solidFill>
-                <a:latin typeface="Malgun Gothic"/>
-                <a:ea typeface="Malgun Gothic"/>
+                <a:latin typeface="Calibri"/>
               </a:rPr>
-              <a:t>추가할 유전자 — Dan + Jesse + Allen</a:t>
+              <a:t>Dan  |  genes considered, and why</a:t>
             </a:r>
           </a:p>
         </p:txBody>
@@ -3192,14 +3190,13 @@
           <a:lstStyle/>
           <a:p>
             <a:r>
-              <a:rPr sz="1300" b="0">
+              <a:rPr sz="1400" b="0">
                 <a:solidFill>
                   <a:srgbClr val="6B6B6B"/>
                 </a:solidFill>
-                <a:latin typeface="Malgun Gothic"/>
-                <a:ea typeface="Malgun Gothic"/>
+                <a:latin typeface="Calibri"/>
               </a:rPr>
-              <a:t>세포타입 144는 유지. Dan 14는 이미 MSGS111. Jesse는 Allen 절대량으로 걸렀다. 106,122 ORBm 세포.</a:t>
+              <a:t>GSE283418  ·  Berg / Scherrer  ·  Resolve 98-gene smFISH in amygdala  ·  re-scored in our Allen BMAp ROI</a:t>
             </a:r>
           </a:p>
         </p:txBody>
@@ -3213,321 +3210,7 @@
         <p:spPr>
           <a:xfrm>
             <a:off x="365760" y="1005840"/>
-            <a:ext cx="3794760" cy="5212080"/>
-          </a:xfrm>
-          <a:prstGeom prst="roundRect">
-            <a:avLst/>
-          </a:prstGeom>
-          <a:solidFill>
-            <a:srgbClr val="FFFFFF"/>
-          </a:solidFill>
-          <a:ln>
-            <a:solidFill>
-              <a:srgbClr val="C44536"/>
-            </a:solidFill>
-          </a:ln>
-        </p:spPr>
-        <p:style>
-          <a:lnRef idx="1">
-            <a:schemeClr val="accent1"/>
-          </a:lnRef>
-          <a:fillRef idx="3">
-            <a:schemeClr val="accent1"/>
-          </a:fillRef>
-          <a:effectRef idx="2">
-            <a:schemeClr val="accent1"/>
-          </a:effectRef>
-          <a:fontRef idx="minor">
-            <a:schemeClr val="lt1"/>
-          </a:fontRef>
-        </p:style>
-        <p:txBody>
-          <a:bodyPr rtlCol="0" anchor="ctr"/>
-          <a:lstStyle/>
-          <a:p>
-            <a:pPr algn="ctr"/>
-          </a:p>
-        </p:txBody>
-      </p:sp>
-      <p:sp>
-        <p:nvSpPr>
-          <p:cNvPr id="6" name="Rectangle 5"/>
-          <p:cNvSpPr/>
-          <p:nvPr/>
-        </p:nvSpPr>
-        <p:spPr>
-          <a:xfrm>
-            <a:off x="365760" y="1005840"/>
-            <a:ext cx="3794760" cy="347472"/>
-          </a:xfrm>
-          <a:prstGeom prst="rect">
-            <a:avLst/>
-          </a:prstGeom>
-          <a:solidFill>
-            <a:srgbClr val="C44536"/>
-          </a:solidFill>
-          <a:ln>
-            <a:noFill/>
-          </a:ln>
-        </p:spPr>
-        <p:style>
-          <a:lnRef idx="1">
-            <a:schemeClr val="accent1"/>
-          </a:lnRef>
-          <a:fillRef idx="3">
-            <a:schemeClr val="accent1"/>
-          </a:fillRef>
-          <a:effectRef idx="2">
-            <a:schemeClr val="accent1"/>
-          </a:effectRef>
-          <a:fontRef idx="minor">
-            <a:schemeClr val="lt1"/>
-          </a:fontRef>
-        </p:style>
-        <p:txBody>
-          <a:bodyPr rtlCol="0" anchor="ctr"/>
-          <a:lstStyle/>
-          <a:p>
-            <a:pPr algn="ctr"/>
-          </a:p>
-        </p:txBody>
-      </p:sp>
-      <p:sp>
-        <p:nvSpPr>
-          <p:cNvPr id="7" name="TextBox 6"/>
-          <p:cNvSpPr txBox="1"/>
-          <p:nvPr/>
-        </p:nvSpPr>
-        <p:spPr>
-          <a:xfrm>
-            <a:off x="457200" y="1051560"/>
-            <a:ext cx="3630168" cy="274320"/>
-          </a:xfrm>
-          <a:prstGeom prst="rect">
-            <a:avLst/>
-          </a:prstGeom>
-          <a:noFill/>
-        </p:spPr>
-        <p:txBody>
-          <a:bodyPr wrap="none">
-            <a:spAutoFit/>
-          </a:bodyPr>
-          <a:lstStyle/>
-          <a:p>
-            <a:r>
-              <a:rPr sz="1200" b="1">
-                <a:solidFill>
-                  <a:srgbClr val="FFFFFF"/>
-                </a:solidFill>
-                <a:latin typeface="Malgun Gothic"/>
-                <a:ea typeface="Malgun Gothic"/>
-              </a:rPr>
-              <a:t>지금 올려라</a:t>
-            </a:r>
-          </a:p>
-        </p:txBody>
-      </p:sp>
-      <p:sp>
-        <p:nvSpPr>
-          <p:cNvPr id="8" name="TextBox 7"/>
-          <p:cNvSpPr txBox="1"/>
-          <p:nvPr/>
-        </p:nvSpPr>
-        <p:spPr>
-          <a:xfrm>
-            <a:off x="475488" y="1426464"/>
-            <a:ext cx="3575304" cy="4700016"/>
-          </a:xfrm>
-          <a:prstGeom prst="rect">
-            <a:avLst/>
-          </a:prstGeom>
-          <a:noFill/>
-        </p:spPr>
-        <p:txBody>
-          <a:bodyPr wrap="square">
-            <a:spAutoFit/>
-          </a:bodyPr>
-          <a:lstStyle/>
-          <a:p>
-            <a:r>
-              <a:rPr sz="1200" b="0">
-                <a:solidFill>
-                  <a:srgbClr val="2C2C2C"/>
-                </a:solidFill>
-                <a:latin typeface="Malgun Gothic"/>
-                <a:ea typeface="Malgun Gothic"/>
-              </a:rPr>
-              <a:t>무료</a:t>
-            </a:r>
-          </a:p>
-          <a:p>
-            <a:r>
-              <a:rPr sz="1200" b="0">
-                <a:solidFill>
-                  <a:srgbClr val="2C2C2C"/>
-                </a:solidFill>
-                <a:latin typeface="Malgun Gothic"/>
-                <a:ea typeface="Malgun Gothic"/>
-              </a:rPr>
-              <a:t>  Rxfp1   (베이스 패널)</a:t>
-            </a:r>
-          </a:p>
-          <a:p>
-            <a:r>
-              <a:rPr sz="1200" b="0">
-                <a:solidFill>
-                  <a:srgbClr val="2C2C2C"/>
-                </a:solidFill>
-                <a:latin typeface="Malgun Gothic"/>
-                <a:ea typeface="Malgun Gothic"/>
-              </a:rPr>
-              <a:t/>
-            </a:r>
-          </a:p>
-          <a:p>
-            <a:r>
-              <a:rPr sz="1200" b="0">
-                <a:solidFill>
-                  <a:srgbClr val="2C2C2C"/>
-                </a:solidFill>
-                <a:latin typeface="Malgun Gothic"/>
-                <a:ea typeface="Malgun Gothic"/>
-              </a:rPr>
-              <a:t>커스텀  모르핀 상태</a:t>
-            </a:r>
-          </a:p>
-          <a:p>
-            <a:r>
-              <a:rPr sz="1200" b="0">
-                <a:solidFill>
-                  <a:srgbClr val="2C2C2C"/>
-                </a:solidFill>
-                <a:latin typeface="Malgun Gothic"/>
-                <a:ea typeface="Malgun Gothic"/>
-              </a:rPr>
-              <a:t>  Per2   Pcsk1   Per1</a:t>
-            </a:r>
-          </a:p>
-          <a:p>
-            <a:r>
-              <a:rPr sz="1200" b="0">
-                <a:solidFill>
-                  <a:srgbClr val="2C2C2C"/>
-                </a:solidFill>
-                <a:latin typeface="Malgun Gothic"/>
-                <a:ea typeface="Malgun Gothic"/>
-              </a:rPr>
-              <a:t/>
-            </a:r>
-          </a:p>
-          <a:p>
-            <a:r>
-              <a:rPr sz="1200" b="0">
-                <a:solidFill>
-                  <a:srgbClr val="2C2C2C"/>
-                </a:solidFill>
-                <a:latin typeface="Malgun Gothic"/>
-                <a:ea typeface="Malgun Gothic"/>
-              </a:rPr>
-              <a:t>커스텀  ORBm GPCR</a:t>
-            </a:r>
-          </a:p>
-          <a:p>
-            <a:r>
-              <a:rPr sz="1200" b="0">
-                <a:solidFill>
-                  <a:srgbClr val="2C2C2C"/>
-                </a:solidFill>
-                <a:latin typeface="Malgun Gothic"/>
-                <a:ea typeface="Malgun Gothic"/>
-              </a:rPr>
-              <a:t>  Chrm1   Grm8</a:t>
-            </a:r>
-          </a:p>
-          <a:p>
-            <a:r>
-              <a:rPr sz="1200" b="0">
-                <a:solidFill>
-                  <a:srgbClr val="2C2C2C"/>
-                </a:solidFill>
-                <a:latin typeface="Malgun Gothic"/>
-                <a:ea typeface="Malgun Gothic"/>
-              </a:rPr>
-              <a:t/>
-            </a:r>
-          </a:p>
-          <a:p>
-            <a:r>
-              <a:rPr sz="1200" b="0">
-                <a:solidFill>
-                  <a:srgbClr val="2C2C2C"/>
-                </a:solidFill>
-                <a:latin typeface="Malgun Gothic"/>
-                <a:ea typeface="Malgun Gothic"/>
-              </a:rPr>
-              <a:t>Allen 최대 %</a:t>
-            </a:r>
-          </a:p>
-          <a:p>
-            <a:r>
-              <a:rPr sz="1200" b="0">
-                <a:solidFill>
-                  <a:srgbClr val="2C2C2C"/>
-                </a:solidFill>
-                <a:latin typeface="Malgun Gothic"/>
-                <a:ea typeface="Malgun Gothic"/>
-              </a:rPr>
-              <a:t>  Chrm1 92%  ·  Grm8 99%</a:t>
-            </a:r>
-          </a:p>
-          <a:p>
-            <a:r>
-              <a:rPr sz="1200" b="0">
-                <a:solidFill>
-                  <a:srgbClr val="2C2C2C"/>
-                </a:solidFill>
-                <a:latin typeface="Malgun Gothic"/>
-                <a:ea typeface="Malgun Gothic"/>
-              </a:rPr>
-              <a:t>  Per1 63%  ·  Rxfp1 34%</a:t>
-            </a:r>
-          </a:p>
-          <a:p>
-            <a:r>
-              <a:rPr sz="1200" b="0">
-                <a:solidFill>
-                  <a:srgbClr val="2C2C2C"/>
-                </a:solidFill>
-                <a:latin typeface="Malgun Gothic"/>
-                <a:ea typeface="Malgun Gothic"/>
-              </a:rPr>
-              <a:t/>
-            </a:r>
-          </a:p>
-          <a:p>
-            <a:r>
-              <a:rPr sz="1200" b="0">
-                <a:solidFill>
-                  <a:srgbClr val="2C2C2C"/>
-                </a:solidFill>
-                <a:latin typeface="Malgun Gothic"/>
-                <a:ea typeface="Malgun Gothic"/>
-              </a:rPr>
-              <a:t>슬롯 +5  (Dan 유지 시 119)</a:t>
-            </a:r>
-          </a:p>
-        </p:txBody>
-      </p:sp>
-      <p:sp>
-        <p:nvSpPr>
-          <p:cNvPr id="9" name="Rounded Rectangle 8"/>
-          <p:cNvSpPr/>
-          <p:nvPr/>
-        </p:nvSpPr>
-        <p:spPr>
-          <a:xfrm>
-            <a:off x="4297680" y="1005840"/>
-            <a:ext cx="3794760" cy="5212080"/>
+            <a:ext cx="3840480" cy="5212080"/>
           </a:xfrm>
           <a:prstGeom prst="roundRect">
             <a:avLst/>
@@ -3565,14 +3248,14 @@
       </p:sp>
       <p:sp>
         <p:nvSpPr>
-          <p:cNvPr id="10" name="Rectangle 9"/>
+          <p:cNvPr id="6" name="Rectangle 5"/>
           <p:cNvSpPr/>
           <p:nvPr/>
         </p:nvSpPr>
         <p:spPr>
           <a:xfrm>
-            <a:off x="4297680" y="1005840"/>
-            <a:ext cx="3794760" cy="347472"/>
+            <a:off x="365760" y="1005840"/>
+            <a:ext cx="3840480" cy="365760"/>
           </a:xfrm>
           <a:prstGeom prst="rect">
             <a:avLst/>
@@ -3608,14 +3291,14 @@
       </p:sp>
       <p:sp>
         <p:nvSpPr>
-          <p:cNvPr id="11" name="TextBox 10"/>
+          <p:cNvPr id="7" name="TextBox 6"/>
           <p:cNvSpPr txBox="1"/>
           <p:nvPr/>
         </p:nvSpPr>
         <p:spPr>
           <a:xfrm>
-            <a:off x="4389120" y="1051560"/>
-            <a:ext cx="3630168" cy="274320"/>
+            <a:off x="475488" y="1060704"/>
+            <a:ext cx="3657600" cy="274320"/>
           </a:xfrm>
           <a:prstGeom prst="rect">
             <a:avLst/>
@@ -3629,28 +3312,27 @@
           <a:lstStyle/>
           <a:p>
             <a:r>
-              <a:rPr sz="1200" b="1">
+              <a:rPr sz="1300" b="1">
                 <a:solidFill>
                   <a:srgbClr val="FFFFFF"/>
                 </a:solidFill>
-                <a:latin typeface="Malgun Gothic"/>
-                <a:ea typeface="Malgun Gothic"/>
+                <a:latin typeface="Calibri"/>
               </a:rPr>
-              <a:t>여유 있으면</a:t>
-            </a:r>
-          </a:p>
-        </p:txBody>
-      </p:sp>
-      <p:sp>
-        <p:nvSpPr>
-          <p:cNvPr id="12" name="TextBox 11"/>
+              <a:t>What the data are</a:t>
+            </a:r>
+          </a:p>
+        </p:txBody>
+      </p:sp>
+      <p:sp>
+        <p:nvSpPr>
+          <p:cNvPr id="8" name="TextBox 7"/>
           <p:cNvSpPr txBox="1"/>
           <p:nvPr/>
         </p:nvSpPr>
         <p:spPr>
           <a:xfrm>
-            <a:off x="4407408" y="1426464"/>
-            <a:ext cx="3575304" cy="4700016"/>
+            <a:off x="493776" y="1463040"/>
+            <a:ext cx="3584448" cy="4663440"/>
           </a:xfrm>
           <a:prstGeom prst="rect">
             <a:avLst/>
@@ -3664,122 +3346,466 @@
           <a:lstStyle/>
           <a:p>
             <a:r>
-              <a:rPr sz="1200" b="0">
+              <a:rPr sz="1300" b="0">
                 <a:solidFill>
                   <a:srgbClr val="2C2C2C"/>
                 </a:solidFill>
-                <a:latin typeface="Malgun Gothic"/>
-                <a:ea typeface="Malgun Gothic"/>
+                <a:latin typeface="Calibri"/>
               </a:rPr>
-              <a:t>Gpr26    IT 86%</a:t>
-            </a:r>
-          </a:p>
-          <a:p>
-            <a:r>
-              <a:rPr sz="1200" b="0">
+              <a:t>Not a cell-type atlas.</a:t>
+            </a:r>
+          </a:p>
+          <a:p>
+            <a:r>
+              <a:rPr sz="1300" b="0">
                 <a:solidFill>
                   <a:srgbClr val="2C2C2C"/>
                 </a:solidFill>
-                <a:latin typeface="Malgun Gothic"/>
-                <a:ea typeface="Malgun Gothic"/>
+                <a:latin typeface="Calibri"/>
               </a:rPr>
-              <a:t>Mas1     L5 ET 45%</a:t>
-            </a:r>
-          </a:p>
-          <a:p>
-            <a:r>
-              <a:rPr sz="1200" b="0">
+              <a:t>A spatial 98-gene panel from</a:t>
+            </a:r>
+          </a:p>
+          <a:p>
+            <a:r>
+              <a:rPr sz="1300" b="0">
                 <a:solidFill>
                   <a:srgbClr val="2C2C2C"/>
                 </a:solidFill>
-                <a:latin typeface="Malgun Gothic"/>
-                <a:ea typeface="Malgun Gothic"/>
+                <a:latin typeface="Calibri"/>
               </a:rPr>
-              <a:t>Camk2g   전역 93%  (Down)</a:t>
-            </a:r>
-          </a:p>
-          <a:p>
-            <a:r>
-              <a:rPr sz="1200" b="0">
+              <a:t>amygdala sections.</a:t>
+            </a:r>
+          </a:p>
+          <a:p>
+            <a:r>
+              <a:rPr sz="1300" b="0">
                 <a:solidFill>
                   <a:srgbClr val="2C2C2C"/>
                 </a:solidFill>
-                <a:latin typeface="Malgun Gothic"/>
-                <a:ea typeface="Malgun Gothic"/>
+                <a:latin typeface="Calibri"/>
               </a:rPr>
               <a:t/>
             </a:r>
           </a:p>
           <a:p>
             <a:r>
-              <a:rPr sz="1200" b="0">
+              <a:rPr sz="1300" b="0">
                 <a:solidFill>
                   <a:srgbClr val="2C2C2C"/>
                 </a:solidFill>
-                <a:latin typeface="Malgun Gothic"/>
-                <a:ea typeface="Malgun Gothic"/>
+                <a:latin typeface="Calibri"/>
               </a:rPr>
-              <a:t>Gpr26 / Mas1 = ORB 주소</a:t>
-            </a:r>
-          </a:p>
-          <a:p>
-            <a:r>
-              <a:rPr sz="1200" b="0">
+              <a:t>38 / 98 were already on our</a:t>
+            </a:r>
+          </a:p>
+          <a:p>
+            <a:r>
+              <a:rPr sz="1300" b="0">
                 <a:solidFill>
                   <a:srgbClr val="2C2C2C"/>
                 </a:solidFill>
-                <a:latin typeface="Malgun Gothic"/>
-                <a:ea typeface="Malgun Gothic"/>
+                <a:latin typeface="Calibri"/>
               </a:rPr>
-              <a:t>Camk2g = 모르핀이 끄는</a:t>
-            </a:r>
-          </a:p>
-          <a:p>
-            <a:r>
-              <a:rPr sz="1200" b="0">
+              <a:t>shared 144 (Foxp2, Cartpt,</a:t>
+            </a:r>
+          </a:p>
+          <a:p>
+            <a:r>
+              <a:rPr sz="1300" b="0">
                 <a:solidFill>
                   <a:srgbClr val="2C2C2C"/>
                 </a:solidFill>
-                <a:latin typeface="Malgun Gothic"/>
-                <a:ea typeface="Malgun Gothic"/>
+                <a:latin typeface="Calibri"/>
               </a:rPr>
-              <a:t>가소성 유전자. 전 세포에서</a:t>
-            </a:r>
-          </a:p>
-          <a:p>
-            <a:r>
-              <a:rPr sz="1200" b="0">
+              <a:t>Pdyn, Oprm1, Slc17a7…).</a:t>
+            </a:r>
+          </a:p>
+          <a:p>
+            <a:r>
+              <a:rPr sz="1300" b="0">
                 <a:solidFill>
                   <a:srgbClr val="2C2C2C"/>
                 </a:solidFill>
-                <a:latin typeface="Malgun Gothic"/>
-                <a:ea typeface="Malgun Gothic"/>
-              </a:rPr>
-              <a:t>이미 높다.</a:t>
-            </a:r>
-          </a:p>
-          <a:p>
-            <a:r>
-              <a:rPr sz="1200" b="0">
-                <a:solidFill>
-                  <a:srgbClr val="2C2C2C"/>
-                </a:solidFill>
-                <a:latin typeface="Malgun Gothic"/>
-                <a:ea typeface="Malgun Gothic"/>
+                <a:latin typeface="Calibri"/>
               </a:rPr>
               <a:t/>
             </a:r>
           </a:p>
           <a:p>
             <a:r>
-              <a:rPr sz="1200" b="0">
+              <a:rPr sz="1300" b="0">
                 <a:solidFill>
                   <a:srgbClr val="2C2C2C"/>
                 </a:solidFill>
-                <a:latin typeface="Malgun Gothic"/>
-                <a:ea typeface="Malgun Gothic"/>
+                <a:latin typeface="Calibri"/>
               </a:rPr>
-              <a:t>슬롯 +3 더</a:t>
+              <a:t>We asked: which of the</a:t>
+            </a:r>
+          </a:p>
+          <a:p>
+            <a:r>
+              <a:rPr sz="1300" b="0">
+                <a:solidFill>
+                  <a:srgbClr val="2C2C2C"/>
+                </a:solidFill>
+                <a:latin typeface="Calibri"/>
+              </a:rPr>
+              <a:t>remaining genes are still</a:t>
+            </a:r>
+          </a:p>
+          <a:p>
+            <a:r>
+              <a:rPr sz="1300" b="0">
+                <a:solidFill>
+                  <a:srgbClr val="2C2C2C"/>
+                </a:solidFill>
+                <a:latin typeface="Calibri"/>
+              </a:rPr>
+              <a:t>informative in our BMAp</a:t>
+            </a:r>
+          </a:p>
+          <a:p>
+            <a:r>
+              <a:rPr sz="1300" b="0">
+                <a:solidFill>
+                  <a:srgbClr val="2C2C2C"/>
+                </a:solidFill>
+                <a:latin typeface="Calibri"/>
+              </a:rPr>
+              <a:t>mapped cells?</a:t>
+            </a:r>
+          </a:p>
+        </p:txBody>
+      </p:sp>
+      <p:sp>
+        <p:nvSpPr>
+          <p:cNvPr id="9" name="Rounded Rectangle 8"/>
+          <p:cNvSpPr/>
+          <p:nvPr/>
+        </p:nvSpPr>
+        <p:spPr>
+          <a:xfrm>
+            <a:off x="4343400" y="1005840"/>
+            <a:ext cx="3840480" cy="5212080"/>
+          </a:xfrm>
+          <a:prstGeom prst="roundRect">
+            <a:avLst/>
+          </a:prstGeom>
+          <a:solidFill>
+            <a:srgbClr val="FFFFFF"/>
+          </a:solidFill>
+          <a:ln>
+            <a:solidFill>
+              <a:srgbClr val="2A6F97"/>
+            </a:solidFill>
+          </a:ln>
+        </p:spPr>
+        <p:style>
+          <a:lnRef idx="1">
+            <a:schemeClr val="accent1"/>
+          </a:lnRef>
+          <a:fillRef idx="3">
+            <a:schemeClr val="accent1"/>
+          </a:fillRef>
+          <a:effectRef idx="2">
+            <a:schemeClr val="accent1"/>
+          </a:effectRef>
+          <a:fontRef idx="minor">
+            <a:schemeClr val="lt1"/>
+          </a:fontRef>
+        </p:style>
+        <p:txBody>
+          <a:bodyPr rtlCol="0" anchor="ctr"/>
+          <a:lstStyle/>
+          <a:p>
+            <a:pPr algn="ctr"/>
+          </a:p>
+        </p:txBody>
+      </p:sp>
+      <p:sp>
+        <p:nvSpPr>
+          <p:cNvPr id="10" name="Rectangle 9"/>
+          <p:cNvSpPr/>
+          <p:nvPr/>
+        </p:nvSpPr>
+        <p:spPr>
+          <a:xfrm>
+            <a:off x="4343400" y="1005840"/>
+            <a:ext cx="3840480" cy="365760"/>
+          </a:xfrm>
+          <a:prstGeom prst="rect">
+            <a:avLst/>
+          </a:prstGeom>
+          <a:solidFill>
+            <a:srgbClr val="2A6F97"/>
+          </a:solidFill>
+          <a:ln>
+            <a:noFill/>
+          </a:ln>
+        </p:spPr>
+        <p:style>
+          <a:lnRef idx="1">
+            <a:schemeClr val="accent1"/>
+          </a:lnRef>
+          <a:fillRef idx="3">
+            <a:schemeClr val="accent1"/>
+          </a:fillRef>
+          <a:effectRef idx="2">
+            <a:schemeClr val="accent1"/>
+          </a:effectRef>
+          <a:fontRef idx="minor">
+            <a:schemeClr val="lt1"/>
+          </a:fontRef>
+        </p:style>
+        <p:txBody>
+          <a:bodyPr rtlCol="0" anchor="ctr"/>
+          <a:lstStyle/>
+          <a:p>
+            <a:pPr algn="ctr"/>
+          </a:p>
+        </p:txBody>
+      </p:sp>
+      <p:sp>
+        <p:nvSpPr>
+          <p:cNvPr id="11" name="TextBox 10"/>
+          <p:cNvSpPr txBox="1"/>
+          <p:nvPr/>
+        </p:nvSpPr>
+        <p:spPr>
+          <a:xfrm>
+            <a:off x="4453128" y="1060704"/>
+            <a:ext cx="3657600" cy="274320"/>
+          </a:xfrm>
+          <a:prstGeom prst="rect">
+            <a:avLst/>
+          </a:prstGeom>
+          <a:noFill/>
+        </p:spPr>
+        <p:txBody>
+          <a:bodyPr wrap="none">
+            <a:spAutoFit/>
+          </a:bodyPr>
+          <a:lstStyle/>
+          <a:p>
+            <a:r>
+              <a:rPr sz="1300" b="1">
+                <a:solidFill>
+                  <a:srgbClr val="FFFFFF"/>
+                </a:solidFill>
+                <a:latin typeface="Calibri"/>
+              </a:rPr>
+              <a:t>Why these 14 were considered</a:t>
+            </a:r>
+          </a:p>
+        </p:txBody>
+      </p:sp>
+      <p:sp>
+        <p:nvSpPr>
+          <p:cNvPr id="12" name="TextBox 11"/>
+          <p:cNvSpPr txBox="1"/>
+          <p:nvPr/>
+        </p:nvSpPr>
+        <p:spPr>
+          <a:xfrm>
+            <a:off x="4471416" y="1463040"/>
+            <a:ext cx="3584448" cy="4663440"/>
+          </a:xfrm>
+          <a:prstGeom prst="rect">
+            <a:avLst/>
+          </a:prstGeom>
+          <a:noFill/>
+        </p:spPr>
+        <p:txBody>
+          <a:bodyPr wrap="square">
+            <a:spAutoFit/>
+          </a:bodyPr>
+          <a:lstStyle/>
+          <a:p>
+            <a:r>
+              <a:rPr sz="1300" b="0">
+                <a:solidFill>
+                  <a:srgbClr val="2C2C2C"/>
+                </a:solidFill>
+                <a:latin typeface="Calibri"/>
+              </a:rPr>
+              <a:t>They were missing from the</a:t>
+            </a:r>
+          </a:p>
+          <a:p>
+            <a:r>
+              <a:rPr sz="1300" b="0">
+                <a:solidFill>
+                  <a:srgbClr val="2C2C2C"/>
+                </a:solidFill>
+                <a:latin typeface="Calibri"/>
+              </a:rPr>
+              <a:t>144 and detectable in the</a:t>
+            </a:r>
+          </a:p>
+          <a:p>
+            <a:r>
+              <a:rPr sz="1300" b="0">
+                <a:solidFill>
+                  <a:srgbClr val="2C2C2C"/>
+                </a:solidFill>
+                <a:latin typeface="Calibri"/>
+              </a:rPr>
+              <a:t>Allen BMAp-mapped ROI.</a:t>
+            </a:r>
+          </a:p>
+          <a:p>
+            <a:r>
+              <a:rPr sz="1300" b="0">
+                <a:solidFill>
+                  <a:srgbClr val="2C2C2C"/>
+                </a:solidFill>
+                <a:latin typeface="Calibri"/>
+              </a:rPr>
+              <a:t/>
+            </a:r>
+          </a:p>
+          <a:p>
+            <a:r>
+              <a:rPr sz="1300" b="0">
+                <a:solidFill>
+                  <a:srgbClr val="2C2C2C"/>
+                </a:solidFill>
+                <a:latin typeface="Calibri"/>
+              </a:rPr>
+              <a:t>Closest to true BMAp</a:t>
+            </a:r>
+          </a:p>
+          <a:p>
+            <a:r>
+              <a:rPr sz="1300" b="0">
+                <a:solidFill>
+                  <a:srgbClr val="2C2C2C"/>
+                </a:solidFill>
+                <a:latin typeface="Calibri"/>
+              </a:rPr>
+              <a:t>  Lamb3   (113 Ccdc42)</a:t>
+            </a:r>
+          </a:p>
+          <a:p>
+            <a:r>
+              <a:rPr sz="1300" b="0">
+                <a:solidFill>
+                  <a:srgbClr val="2C2C2C"/>
+                </a:solidFill>
+                <a:latin typeface="Calibri"/>
+              </a:rPr>
+              <a:t/>
+            </a:r>
+          </a:p>
+          <a:p>
+            <a:r>
+              <a:rPr sz="1300" b="0">
+                <a:solidFill>
+                  <a:srgbClr val="2C2C2C"/>
+                </a:solidFill>
+                <a:latin typeface="Calibri"/>
+              </a:rPr>
+              <a:t>BMA / MEA VGLUT1 border</a:t>
+            </a:r>
+          </a:p>
+          <a:p>
+            <a:r>
+              <a:rPr sz="1300" b="0">
+                <a:solidFill>
+                  <a:srgbClr val="2C2C2C"/>
+                </a:solidFill>
+                <a:latin typeface="Calibri"/>
+              </a:rPr>
+              <a:t>  Cck  Col23a1  Slc29a4</a:t>
+            </a:r>
+          </a:p>
+          <a:p>
+            <a:r>
+              <a:rPr sz="1300" b="0">
+                <a:solidFill>
+                  <a:srgbClr val="2C2C2C"/>
+                </a:solidFill>
+                <a:latin typeface="Calibri"/>
+              </a:rPr>
+              <a:t>  Abca8a  Dnah5</a:t>
+            </a:r>
+          </a:p>
+          <a:p>
+            <a:r>
+              <a:rPr sz="1300" b="0">
+                <a:solidFill>
+                  <a:srgbClr val="2C2C2C"/>
+                </a:solidFill>
+                <a:latin typeface="Calibri"/>
+              </a:rPr>
+              <a:t/>
+            </a:r>
+          </a:p>
+          <a:p>
+            <a:r>
+              <a:rPr sz="1300" b="0">
+                <a:solidFill>
+                  <a:srgbClr val="2C2C2C"/>
+                </a:solidFill>
+                <a:latin typeface="Calibri"/>
+              </a:rPr>
+              <a:t>MEA / BST neighbors</a:t>
+            </a:r>
+          </a:p>
+          <a:p>
+            <a:r>
+              <a:rPr sz="1300" b="0">
+                <a:solidFill>
+                  <a:srgbClr val="2C2C2C"/>
+                </a:solidFill>
+                <a:latin typeface="Calibri"/>
+              </a:rPr>
+              <a:t>  Calcrl  Nos1  Oprl1</a:t>
+            </a:r>
+          </a:p>
+          <a:p>
+            <a:r>
+              <a:rPr sz="1300" b="0">
+                <a:solidFill>
+                  <a:srgbClr val="2C2C2C"/>
+                </a:solidFill>
+                <a:latin typeface="Calibri"/>
+              </a:rPr>
+              <a:t>  Gfra1  Sp8</a:t>
+            </a:r>
+          </a:p>
+          <a:p>
+            <a:r>
+              <a:rPr sz="1300" b="0">
+                <a:solidFill>
+                  <a:srgbClr val="2C2C2C"/>
+                </a:solidFill>
+                <a:latin typeface="Calibri"/>
+              </a:rPr>
+              <a:t/>
+            </a:r>
+          </a:p>
+          <a:p>
+            <a:r>
+              <a:rPr sz="1300" b="0">
+                <a:solidFill>
+                  <a:srgbClr val="2C2C2C"/>
+                </a:solidFill>
+                <a:latin typeface="Calibri"/>
+              </a:rPr>
+              <a:t>CEA / other  (weakest)</a:t>
+            </a:r>
+          </a:p>
+          <a:p>
+            <a:r>
+              <a:rPr sz="1300" b="0">
+                <a:solidFill>
+                  <a:srgbClr val="2C2C2C"/>
+                </a:solidFill>
+                <a:latin typeface="Calibri"/>
+              </a:rPr>
+              <a:t>  Syndig1l  Gabre  Tspan18</a:t>
             </a:r>
           </a:p>
         </p:txBody>
@@ -3792,8 +3818,8 @@
         </p:nvSpPr>
         <p:spPr>
           <a:xfrm>
-            <a:off x="8229600" y="1005840"/>
-            <a:ext cx="3566160" cy="5212080"/>
+            <a:off x="8321040" y="1005840"/>
+            <a:ext cx="3474720" cy="5212080"/>
           </a:xfrm>
           <a:prstGeom prst="roundRect">
             <a:avLst/>
@@ -3837,8 +3863,8 @@
         </p:nvSpPr>
         <p:spPr>
           <a:xfrm>
-            <a:off x="8229600" y="1005840"/>
-            <a:ext cx="3566160" cy="347472"/>
+            <a:off x="8321040" y="1005840"/>
+            <a:ext cx="3474720" cy="365760"/>
           </a:xfrm>
           <a:prstGeom prst="rect">
             <a:avLst/>
@@ -3880,8 +3906,8 @@
         </p:nvSpPr>
         <p:spPr>
           <a:xfrm>
-            <a:off x="8321040" y="1051560"/>
-            <a:ext cx="3401568" cy="274320"/>
+            <a:off x="8430767" y="1060704"/>
+            <a:ext cx="3291839" cy="274320"/>
           </a:xfrm>
           <a:prstGeom prst="rect">
             <a:avLst/>
@@ -3895,14 +3921,13 @@
           <a:lstStyle/>
           <a:p>
             <a:r>
-              <a:rPr sz="1200" b="1">
+              <a:rPr sz="1300" b="1">
                 <a:solidFill>
                   <a:srgbClr val="FFFFFF"/>
                 </a:solidFill>
-                <a:latin typeface="Malgun Gothic"/>
-                <a:ea typeface="Malgun Gothic"/>
+                <a:latin typeface="Calibri"/>
               </a:rPr>
-              <a:t>넣지 말 것 / 이미 있음</a:t>
+              <a:t>Status</a:t>
             </a:r>
           </a:p>
         </p:txBody>
@@ -3915,8 +3940,8 @@
         </p:nvSpPr>
         <p:spPr>
           <a:xfrm>
-            <a:off x="8339327" y="1426464"/>
-            <a:ext cx="3346704" cy="4700016"/>
+            <a:off x="8449056" y="1463040"/>
+            <a:ext cx="3218687" cy="4663440"/>
           </a:xfrm>
           <a:prstGeom prst="rect">
             <a:avLst/>
@@ -3930,146 +3955,167 @@
           <a:lstStyle/>
           <a:p>
             <a:r>
-              <a:rPr sz="1200" b="0">
+              <a:rPr sz="1300" b="0">
                 <a:solidFill>
                   <a:srgbClr val="2C2C2C"/>
                 </a:solidFill>
-                <a:latin typeface="Malgun Gothic"/>
-                <a:ea typeface="Malgun Gothic"/>
+                <a:latin typeface="Calibri"/>
               </a:rPr>
-              <a:t>이미 있음</a:t>
-            </a:r>
-          </a:p>
-          <a:p>
-            <a:r>
-              <a:rPr sz="1200" b="0">
+              <a:t>Already added to</a:t>
+            </a:r>
+          </a:p>
+          <a:p>
+            <a:r>
+              <a:rPr sz="1300" b="0">
                 <a:solidFill>
                   <a:srgbClr val="2C2C2C"/>
                 </a:solidFill>
-                <a:latin typeface="Malgun Gothic"/>
-                <a:ea typeface="Malgun Gothic"/>
+                <a:latin typeface="Calibri"/>
               </a:rPr>
-              <a:t>  Fos Arc Egr1 Junb</a:t>
-            </a:r>
-          </a:p>
-          <a:p>
-            <a:r>
-              <a:rPr sz="1200" b="0">
+              <a:t>MSGS111</a:t>
+            </a:r>
+          </a:p>
+          <a:p>
+            <a:r>
+              <a:rPr sz="1300" b="0">
                 <a:solidFill>
                   <a:srgbClr val="2C2C2C"/>
                 </a:solidFill>
-                <a:latin typeface="Malgun Gothic"/>
-                <a:ea typeface="Malgun Gothic"/>
+                <a:latin typeface="Calibri"/>
               </a:rPr>
-              <a:t>  Nr4a1 Oprm1 Cckbr</a:t>
-            </a:r>
-          </a:p>
-          <a:p>
-            <a:r>
-              <a:rPr sz="1200" b="0">
+              <a:t>ranks 145–158.</a:t>
+            </a:r>
+          </a:p>
+          <a:p>
+            <a:r>
+              <a:rPr sz="1300" b="0">
                 <a:solidFill>
                   <a:srgbClr val="2C2C2C"/>
                 </a:solidFill>
-                <a:latin typeface="Malgun Gothic"/>
-                <a:ea typeface="Malgun Gothic"/>
-              </a:rPr>
-              <a:t>  Hcrtr2 Chrm2 Grm5</a:t>
-            </a:r>
-          </a:p>
-          <a:p>
-            <a:r>
-              <a:rPr sz="1200" b="0">
-                <a:solidFill>
-                  <a:srgbClr val="2C2C2C"/>
-                </a:solidFill>
-                <a:latin typeface="Malgun Gothic"/>
-                <a:ea typeface="Malgun Gothic"/>
+                <a:latin typeface="Calibri"/>
               </a:rPr>
               <a:t/>
             </a:r>
           </a:p>
           <a:p>
             <a:r>
-              <a:rPr sz="1200" b="0">
+              <a:rPr sz="1300" b="0">
                 <a:solidFill>
                   <a:srgbClr val="2C2C2C"/>
                 </a:solidFill>
-                <a:latin typeface="Malgun Gothic"/>
-                <a:ea typeface="Malgun Gothic"/>
+                <a:latin typeface="Calibri"/>
               </a:rPr>
-              <a:t>절대량 약함</a:t>
-            </a:r>
-          </a:p>
-          <a:p>
-            <a:r>
-              <a:rPr sz="1200" b="0">
+              <a:t>They do not redo</a:t>
+            </a:r>
+          </a:p>
+          <a:p>
+            <a:r>
+              <a:rPr sz="1300" b="0">
                 <a:solidFill>
                   <a:srgbClr val="2C2C2C"/>
                 </a:solidFill>
-                <a:latin typeface="Malgun Gothic"/>
-                <a:ea typeface="Malgun Gothic"/>
+                <a:latin typeface="Calibri"/>
               </a:rPr>
-              <a:t>  Mchr1   32%  (2앵커만 ≥20%)</a:t>
-            </a:r>
-          </a:p>
-          <a:p>
-            <a:r>
-              <a:rPr sz="1200" b="0">
+              <a:t>cell-type ID.</a:t>
+            </a:r>
+          </a:p>
+          <a:p>
+            <a:r>
+              <a:rPr sz="1300" b="0">
                 <a:solidFill>
                   <a:srgbClr val="2C2C2C"/>
                 </a:solidFill>
-                <a:latin typeface="Malgun Gothic"/>
-                <a:ea typeface="Malgun Gothic"/>
+                <a:latin typeface="Calibri"/>
+              </a:rPr>
+              <a:t>They add amygdala</a:t>
+            </a:r>
+          </a:p>
+          <a:p>
+            <a:r>
+              <a:rPr sz="1300" b="0">
+                <a:solidFill>
+                  <a:srgbClr val="2C2C2C"/>
+                </a:solidFill>
+                <a:latin typeface="Calibri"/>
+              </a:rPr>
+              <a:t>spatial genes Dan</a:t>
+            </a:r>
+          </a:p>
+          <a:p>
+            <a:r>
+              <a:rPr sz="1300" b="0">
+                <a:solidFill>
+                  <a:srgbClr val="2C2C2C"/>
+                </a:solidFill>
+                <a:latin typeface="Calibri"/>
+              </a:rPr>
+              <a:t>already uses.</a:t>
+            </a:r>
+          </a:p>
+          <a:p>
+            <a:r>
+              <a:rPr sz="1300" b="0">
+                <a:solidFill>
+                  <a:srgbClr val="2C2C2C"/>
+                </a:solidFill>
+                <a:latin typeface="Calibri"/>
               </a:rPr>
               <a:t/>
             </a:r>
           </a:p>
           <a:p>
             <a:r>
-              <a:rPr sz="1200" b="0">
+              <a:rPr sz="1300" b="0">
                 <a:solidFill>
                   <a:srgbClr val="2C2C2C"/>
                 </a:solidFill>
-                <a:latin typeface="Malgun Gothic"/>
-                <a:ea typeface="Malgun Gothic"/>
+                <a:latin typeface="Calibri"/>
               </a:rPr>
-              <a:t>전역이라 정보 적음</a:t>
-            </a:r>
-          </a:p>
-          <a:p>
-            <a:r>
-              <a:rPr sz="1200" b="0">
+              <a:t>If the 100-slot cap</a:t>
+            </a:r>
+          </a:p>
+          <a:p>
+            <a:r>
+              <a:rPr sz="1300" b="0">
                 <a:solidFill>
                   <a:srgbClr val="2C2C2C"/>
                 </a:solidFill>
-                <a:latin typeface="Malgun Gothic"/>
-                <a:ea typeface="Malgun Gothic"/>
+                <a:latin typeface="Calibri"/>
               </a:rPr>
-              <a:t>  Fxr1  Vps13a</a:t>
-            </a:r>
-          </a:p>
-          <a:p>
-            <a:r>
-              <a:rPr sz="1200" b="0">
+              <a:t>is hard: keep Lamb3</a:t>
+            </a:r>
+          </a:p>
+          <a:p>
+            <a:r>
+              <a:rPr sz="1300" b="0">
                 <a:solidFill>
                   <a:srgbClr val="2C2C2C"/>
                 </a:solidFill>
-                <a:latin typeface="Malgun Gothic"/>
-                <a:ea typeface="Malgun Gothic"/>
+                <a:latin typeface="Calibri"/>
               </a:rPr>
-              <a:t/>
-            </a:r>
-          </a:p>
-          <a:p>
-            <a:r>
-              <a:rPr sz="1200" b="0">
+              <a:t>+ the 012-border set;</a:t>
+            </a:r>
+          </a:p>
+          <a:p>
+            <a:r>
+              <a:rPr sz="1300" b="0">
                 <a:solidFill>
                   <a:srgbClr val="2C2C2C"/>
                 </a:solidFill>
-                <a:latin typeface="Malgun Gothic"/>
-                <a:ea typeface="Malgun Gothic"/>
+                <a:latin typeface="Calibri"/>
               </a:rPr>
-              <a:t>TF 160개  ·  CEA/glia</a:t>
+              <a:t>cut the CEA genes</a:t>
+            </a:r>
+          </a:p>
+          <a:p>
+            <a:r>
+              <a:rPr sz="1300" b="0">
+                <a:solidFill>
+                  <a:srgbClr val="2C2C2C"/>
+                </a:solidFill>
+                <a:latin typeface="Calibri"/>
+              </a:rPr>
+              <a:t>first.</a:t>
             </a:r>
           </a:p>
         </p:txBody>
@@ -4101,10 +4147,9 @@
                 <a:solidFill>
                   <a:srgbClr val="6B6B6B"/>
                 </a:solidFill>
-                <a:latin typeface="Malgun Gothic"/>
-                <a:ea typeface="Malgun Gothic"/>
+                <a:latin typeface="Calibri"/>
               </a:rPr>
-              <a:t>Xenium ORBm + BMAp  |  Dan GSE283418  ·  Jesse PL-ILA-ORB  ·  Allen WMB-10X  |  1/4</a:t>
+              <a:t>Xenium ORBm + BMAp add-on  |  Dan GSE283418  ·  Jesse PL-ILA-ORB  ·  Allen WMB-10X  |  1/3</a:t>
             </a:r>
           </a:p>
         </p:txBody>
@@ -4118,905 +4163,6 @@
 </file>
 
 <file path=ppt/slides/slide2.xml><?xml version="1.0" encoding="utf-8"?>
-<p:sld xmlns:a="http://schemas.openxmlformats.org/drawingml/2006/main" xmlns:p="http://schemas.openxmlformats.org/presentationml/2006/main" xmlns:r="http://schemas.openxmlformats.org/officeDocument/2006/relationships">
-  <p:cSld>
-    <p:spTree>
-      <p:nvGrpSpPr>
-        <p:cNvPr id="1" name=""/>
-        <p:cNvGrpSpPr/>
-        <p:nvPr/>
-      </p:nvGrpSpPr>
-      <p:grpSpPr/>
-      <p:sp>
-        <p:nvSpPr>
-          <p:cNvPr id="2" name="Rectangle 1"/>
-          <p:cNvSpPr/>
-          <p:nvPr/>
-        </p:nvSpPr>
-        <p:spPr>
-          <a:xfrm>
-            <a:off x="0" y="0"/>
-            <a:ext cx="12191695" cy="91440"/>
-          </a:xfrm>
-          <a:prstGeom prst="rect">
-            <a:avLst/>
-          </a:prstGeom>
-          <a:solidFill>
-            <a:srgbClr val="2A6F97"/>
-          </a:solidFill>
-          <a:ln>
-            <a:noFill/>
-          </a:ln>
-        </p:spPr>
-        <p:style>
-          <a:lnRef idx="1">
-            <a:schemeClr val="accent1"/>
-          </a:lnRef>
-          <a:fillRef idx="3">
-            <a:schemeClr val="accent1"/>
-          </a:fillRef>
-          <a:effectRef idx="2">
-            <a:schemeClr val="accent1"/>
-          </a:effectRef>
-          <a:fontRef idx="minor">
-            <a:schemeClr val="lt1"/>
-          </a:fontRef>
-        </p:style>
-        <p:txBody>
-          <a:bodyPr rtlCol="0" anchor="ctr"/>
-          <a:lstStyle/>
-          <a:p>
-            <a:pPr algn="ctr"/>
-          </a:p>
-        </p:txBody>
-      </p:sp>
-      <p:sp>
-        <p:nvSpPr>
-          <p:cNvPr id="3" name="TextBox 2"/>
-          <p:cNvSpPr txBox="1"/>
-          <p:nvPr/>
-        </p:nvSpPr>
-        <p:spPr>
-          <a:xfrm>
-            <a:off x="411480" y="201168"/>
-            <a:ext cx="11338560" cy="420624"/>
-          </a:xfrm>
-          <a:prstGeom prst="rect">
-            <a:avLst/>
-          </a:prstGeom>
-          <a:noFill/>
-        </p:spPr>
-        <p:txBody>
-          <a:bodyPr wrap="none">
-            <a:spAutoFit/>
-          </a:bodyPr>
-          <a:lstStyle/>
-          <a:p>
-            <a:r>
-              <a:rPr sz="2400" b="1">
-                <a:solidFill>
-                  <a:srgbClr val="1D4E89"/>
-                </a:solidFill>
-                <a:latin typeface="Malgun Gothic"/>
-                <a:ea typeface="Malgun Gothic"/>
-              </a:rPr>
-              <a:t>Dan  GSE283418 — 이미 시트에 넣은 14개</a:t>
-            </a:r>
-          </a:p>
-        </p:txBody>
-      </p:sp>
-      <p:sp>
-        <p:nvSpPr>
-          <p:cNvPr id="4" name="TextBox 3"/>
-          <p:cNvSpPr txBox="1"/>
-          <p:nvPr/>
-        </p:nvSpPr>
-        <p:spPr>
-          <a:xfrm>
-            <a:off x="411480" y="603504"/>
-            <a:ext cx="11338560" cy="292608"/>
-          </a:xfrm>
-          <a:prstGeom prst="rect">
-            <a:avLst/>
-          </a:prstGeom>
-          <a:noFill/>
-        </p:spPr>
-        <p:txBody>
-          <a:bodyPr wrap="none">
-            <a:spAutoFit/>
-          </a:bodyPr>
-          <a:lstStyle/>
-          <a:p>
-            <a:r>
-              <a:rPr sz="1300" b="0">
-                <a:solidFill>
-                  <a:srgbClr val="6B6B6B"/>
-                </a:solidFill>
-                <a:latin typeface="Malgun Gothic"/>
-                <a:ea typeface="Malgun Gothic"/>
-              </a:rPr>
-              <a:t>Resolve 98-gene smFISH. 38개는 원래 패널에 있음. 14개를 MSGS111에 추가 (랭크 145–158).</a:t>
-            </a:r>
-          </a:p>
-        </p:txBody>
-      </p:sp>
-      <p:graphicFrame>
-        <p:nvGraphicFramePr>
-          <p:cNvPr id="5" name="Table 4"/>
-          <p:cNvGraphicFramePr>
-            <a:graphicFrameLocks noGrp="1"/>
-          </p:cNvGraphicFramePr>
-          <p:nvPr/>
-        </p:nvGraphicFramePr>
-        <p:xfrm>
-          <a:off x="365760" y="987552"/>
-          <a:ext cx="11430000" cy="4160520"/>
-        </p:xfrm>
-        <a:graphic>
-          <a:graphicData uri="http://schemas.openxmlformats.org/drawingml/2006/table">
-            <a:tbl>
-              <a:tblPr firstRow="1" bandRow="1">
-                <a:tableStyleId>{5C22544A-7EE6-4342-B048-85BDC9FD1C3A}</a:tableStyleId>
-              </a:tblPr>
-              <a:tblGrid>
-                <a:gridCol w="2377440"/>
-                <a:gridCol w="2926080"/>
-                <a:gridCol w="3200400"/>
-                <a:gridCol w="2926080"/>
-              </a:tblGrid>
-              <a:tr h="594360">
-                <a:tc>
-                  <a:txBody>
-                    <a:bodyPr wrap="square"/>
-                    <a:lstStyle/>
-                    <a:p>
-                      <a:r>
-                        <a:rPr sz="1100" b="1">
-                          <a:solidFill>
-                            <a:srgbClr val="FFFFFF"/>
-                          </a:solidFill>
-                          <a:latin typeface="Malgun Gothic"/>
-                          <a:ea typeface="Malgun Gothic"/>
-                        </a:rPr>
-                        <a:t>유전자</a:t>
-                      </a:r>
-                    </a:p>
-                  </a:txBody>
-                  <a:tcPr>
-                    <a:solidFill>
-                      <a:srgbClr val="1D4E89"/>
-                    </a:solidFill>
-                  </a:tcPr>
-                </a:tc>
-                <a:tc>
-                  <a:txBody>
-                    <a:bodyPr wrap="square"/>
-                    <a:lstStyle/>
-                    <a:p>
-                      <a:r>
-                        <a:rPr sz="1100" b="1">
-                          <a:solidFill>
-                            <a:srgbClr val="FFFFFF"/>
-                          </a:solidFill>
-                          <a:latin typeface="Malgun Gothic"/>
-                          <a:ea typeface="Malgun Gothic"/>
-                        </a:rPr>
-                        <a:t>Allen에서 가장 가까운 타입</a:t>
-                      </a:r>
-                    </a:p>
-                  </a:txBody>
-                  <a:tcPr>
-                    <a:solidFill>
-                      <a:srgbClr val="1D4E89"/>
-                    </a:solidFill>
-                  </a:tcPr>
-                </a:tc>
-                <a:tc>
-                  <a:txBody>
-                    <a:bodyPr wrap="square"/>
-                    <a:lstStyle/>
-                    <a:p>
-                      <a:r>
-                        <a:rPr sz="1100" b="1">
-                          <a:solidFill>
-                            <a:srgbClr val="FFFFFF"/>
-                          </a:solidFill>
-                          <a:latin typeface="Malgun Gothic"/>
-                          <a:ea typeface="Malgun Gothic"/>
-                        </a:rPr>
-                        <a:t>왜 넣었나</a:t>
-                      </a:r>
-                    </a:p>
-                  </a:txBody>
-                  <a:tcPr>
-                    <a:solidFill>
-                      <a:srgbClr val="1D4E89"/>
-                    </a:solidFill>
-                  </a:tcPr>
-                </a:tc>
-                <a:tc>
-                  <a:txBody>
-                    <a:bodyPr wrap="square"/>
-                    <a:lstStyle/>
-                    <a:p>
-                      <a:r>
-                        <a:rPr sz="1100" b="1">
-                          <a:solidFill>
-                            <a:srgbClr val="FFFFFF"/>
-                          </a:solidFill>
-                          <a:latin typeface="Malgun Gothic"/>
-                          <a:ea typeface="Malgun Gothic"/>
-                        </a:rPr>
-                        <a:t>주의</a:t>
-                      </a:r>
-                    </a:p>
-                  </a:txBody>
-                  <a:tcPr>
-                    <a:solidFill>
-                      <a:srgbClr val="1D4E89"/>
-                    </a:solidFill>
-                  </a:tcPr>
-                </a:tc>
-              </a:tr>
-              <a:tr h="594360">
-                <a:tc>
-                  <a:txBody>
-                    <a:bodyPr wrap="square"/>
-                    <a:lstStyle/>
-                    <a:p>
-                      <a:r>
-                        <a:rPr sz="1100" b="0">
-                          <a:solidFill>
-                            <a:srgbClr val="2C2C2C"/>
-                          </a:solidFill>
-                          <a:latin typeface="Malgun Gothic"/>
-                          <a:ea typeface="Malgun Gothic"/>
-                        </a:rPr>
-                        <a:t>Lamb3</a:t>
-                      </a:r>
-                    </a:p>
-                  </a:txBody>
-                  <a:tcPr>
-                    <a:solidFill>
-                      <a:srgbClr val="F4F1EA"/>
-                    </a:solidFill>
-                  </a:tcPr>
-                </a:tc>
-                <a:tc>
-                  <a:txBody>
-                    <a:bodyPr wrap="square"/>
-                    <a:lstStyle/>
-                    <a:p>
-                      <a:r>
-                        <a:rPr sz="1100" b="0">
-                          <a:solidFill>
-                            <a:srgbClr val="2C2C2C"/>
-                          </a:solidFill>
-                          <a:latin typeface="Malgun Gothic"/>
-                          <a:ea typeface="Malgun Gothic"/>
-                        </a:rPr>
-                        <a:t>113 BMA Ccdc42</a:t>
-                      </a:r>
-                    </a:p>
-                  </a:txBody>
-                  <a:tcPr>
-                    <a:solidFill>
-                      <a:srgbClr val="F4F1EA"/>
-                    </a:solidFill>
-                  </a:tcPr>
-                </a:tc>
-                <a:tc>
-                  <a:txBody>
-                    <a:bodyPr wrap="square"/>
-                    <a:lstStyle/>
-                    <a:p>
-                      <a:r>
-                        <a:rPr sz="1100" b="0">
-                          <a:solidFill>
-                            <a:srgbClr val="2C2C2C"/>
-                          </a:solidFill>
-                          <a:latin typeface="Malgun Gothic"/>
-                          <a:ea typeface="Malgun Gothic"/>
-                        </a:rPr>
-                        <a:t>진짜 BMAp에 가장 가까움</a:t>
-                      </a:r>
-                    </a:p>
-                  </a:txBody>
-                  <a:tcPr>
-                    <a:solidFill>
-                      <a:srgbClr val="F4F1EA"/>
-                    </a:solidFill>
-                  </a:tcPr>
-                </a:tc>
-                <a:tc>
-                  <a:txBody>
-                    <a:bodyPr wrap="square"/>
-                    <a:lstStyle/>
-                    <a:p>
-                      <a:r>
-                        <a:rPr sz="1100" b="0">
-                          <a:solidFill>
-                            <a:srgbClr val="2C2C2C"/>
-                          </a:solidFill>
-                          <a:latin typeface="Malgun Gothic"/>
-                          <a:ea typeface="Malgun Gothic"/>
-                        </a:rPr>
-                        <a:t>슬롯 1</a:t>
-                      </a:r>
-                    </a:p>
-                  </a:txBody>
-                  <a:tcPr>
-                    <a:solidFill>
-                      <a:srgbClr val="F4F1EA"/>
-                    </a:solidFill>
-                  </a:tcPr>
-                </a:tc>
-              </a:tr>
-              <a:tr h="594360">
-                <a:tc>
-                  <a:txBody>
-                    <a:bodyPr wrap="square"/>
-                    <a:lstStyle/>
-                    <a:p>
-                      <a:r>
-                        <a:rPr sz="1100" b="0">
-                          <a:solidFill>
-                            <a:srgbClr val="2C2C2C"/>
-                          </a:solidFill>
-                          <a:latin typeface="Malgun Gothic"/>
-                          <a:ea typeface="Malgun Gothic"/>
-                        </a:rPr>
-                        <a:t>Cck  Col23a1  Slc29a4</a:t>
-                      </a:r>
-                    </a:p>
-                  </a:txBody>
-                  <a:tcPr>
-                    <a:solidFill>
-                      <a:srgbClr val="FFFFFF"/>
-                    </a:solidFill>
-                  </a:tcPr>
-                </a:tc>
-                <a:tc>
-                  <a:txBody>
-                    <a:bodyPr wrap="square"/>
-                    <a:lstStyle/>
-                    <a:p>
-                      <a:r>
-                        <a:rPr sz="1100" b="0">
-                          <a:solidFill>
-                            <a:srgbClr val="2C2C2C"/>
-                          </a:solidFill>
-                          <a:latin typeface="Malgun Gothic"/>
-                          <a:ea typeface="Malgun Gothic"/>
-                        </a:rPr>
-                        <a:t>012 VGLUT1 경계</a:t>
-                      </a:r>
-                    </a:p>
-                  </a:txBody>
-                  <a:tcPr>
-                    <a:solidFill>
-                      <a:srgbClr val="FFFFFF"/>
-                    </a:solidFill>
-                  </a:tcPr>
-                </a:tc>
-                <a:tc>
-                  <a:txBody>
-                    <a:bodyPr wrap="square"/>
-                    <a:lstStyle/>
-                    <a:p>
-                      <a:r>
-                        <a:rPr sz="1100" b="0">
-                          <a:solidFill>
-                            <a:srgbClr val="2C2C2C"/>
-                          </a:solidFill>
-                          <a:latin typeface="Malgun Gothic"/>
-                          <a:ea typeface="Malgun Gothic"/>
-                        </a:rPr>
-                        <a:t>BMA/MEA 겹침 공간</a:t>
-                      </a:r>
-                    </a:p>
-                  </a:txBody>
-                  <a:tcPr>
-                    <a:solidFill>
-                      <a:srgbClr val="FFFFFF"/>
-                    </a:solidFill>
-                  </a:tcPr>
-                </a:tc>
-                <a:tc>
-                  <a:txBody>
-                    <a:bodyPr wrap="square"/>
-                    <a:lstStyle/>
-                    <a:p>
-                      <a:r>
-                        <a:rPr sz="1100" b="0">
-                          <a:solidFill>
-                            <a:srgbClr val="2C2C2C"/>
-                          </a:solidFill>
-                          <a:latin typeface="Malgun Gothic"/>
-                          <a:ea typeface="Malgun Gothic"/>
-                        </a:rPr>
-                        <a:t>핵 중심은 아님</a:t>
-                      </a:r>
-                    </a:p>
-                  </a:txBody>
-                  <a:tcPr>
-                    <a:solidFill>
-                      <a:srgbClr val="FFFFFF"/>
-                    </a:solidFill>
-                  </a:tcPr>
-                </a:tc>
-              </a:tr>
-              <a:tr h="594360">
-                <a:tc>
-                  <a:txBody>
-                    <a:bodyPr wrap="square"/>
-                    <a:lstStyle/>
-                    <a:p>
-                      <a:r>
-                        <a:rPr sz="1100" b="0">
-                          <a:solidFill>
-                            <a:srgbClr val="2C2C2C"/>
-                          </a:solidFill>
-                          <a:latin typeface="Malgun Gothic"/>
-                          <a:ea typeface="Malgun Gothic"/>
-                        </a:rPr>
-                        <a:t>Abca8a  Dnah5</a:t>
-                      </a:r>
-                    </a:p>
-                  </a:txBody>
-                  <a:tcPr>
-                    <a:solidFill>
-                      <a:srgbClr val="F4F1EA"/>
-                    </a:solidFill>
-                  </a:tcPr>
-                </a:tc>
-                <a:tc>
-                  <a:txBody>
-                    <a:bodyPr wrap="square"/>
-                    <a:lstStyle/>
-                    <a:p>
-                      <a:r>
-                        <a:rPr sz="1100" b="0">
-                          <a:solidFill>
-                            <a:srgbClr val="2C2C2C"/>
-                          </a:solidFill>
-                          <a:latin typeface="Malgun Gothic"/>
-                          <a:ea typeface="Malgun Gothic"/>
-                        </a:rPr>
-                        <a:t>012 경계</a:t>
-                      </a:r>
-                    </a:p>
-                  </a:txBody>
-                  <a:tcPr>
-                    <a:solidFill>
-                      <a:srgbClr val="F4F1EA"/>
-                    </a:solidFill>
-                  </a:tcPr>
-                </a:tc>
-                <a:tc>
-                  <a:txBody>
-                    <a:bodyPr wrap="square"/>
-                    <a:lstStyle/>
-                    <a:p>
-                      <a:r>
-                        <a:rPr sz="1100" b="0">
-                          <a:solidFill>
-                            <a:srgbClr val="2C2C2C"/>
-                          </a:solidFill>
-                          <a:latin typeface="Malgun Gothic"/>
-                          <a:ea typeface="Malgun Gothic"/>
-                        </a:rPr>
-                        <a:t>같은 VGLUT1 블록</a:t>
-                      </a:r>
-                    </a:p>
-                  </a:txBody>
-                  <a:tcPr>
-                    <a:solidFill>
-                      <a:srgbClr val="F4F1EA"/>
-                    </a:solidFill>
-                  </a:tcPr>
-                </a:tc>
-                <a:tc>
-                  <a:txBody>
-                    <a:bodyPr wrap="square"/>
-                    <a:lstStyle/>
-                    <a:p>
-                      <a:r>
-                        <a:rPr sz="1100" b="0">
-                          <a:solidFill>
-                            <a:srgbClr val="2C2C2C"/>
-                          </a:solidFill>
-                          <a:latin typeface="Malgun Gothic"/>
-                          <a:ea typeface="Malgun Gothic"/>
-                        </a:rPr>
-                        <a:t/>
-                      </a:r>
-                    </a:p>
-                  </a:txBody>
-                  <a:tcPr>
-                    <a:solidFill>
-                      <a:srgbClr val="F4F1EA"/>
-                    </a:solidFill>
-                  </a:tcPr>
-                </a:tc>
-              </a:tr>
-              <a:tr h="594360">
-                <a:tc>
-                  <a:txBody>
-                    <a:bodyPr wrap="square"/>
-                    <a:lstStyle/>
-                    <a:p>
-                      <a:r>
-                        <a:rPr sz="1100" b="0">
-                          <a:solidFill>
-                            <a:srgbClr val="2C2C2C"/>
-                          </a:solidFill>
-                          <a:latin typeface="Malgun Gothic"/>
-                          <a:ea typeface="Malgun Gothic"/>
-                        </a:rPr>
-                        <a:t>Calcrl  Nos1  Oprl1</a:t>
-                      </a:r>
-                    </a:p>
-                  </a:txBody>
-                  <a:tcPr>
-                    <a:solidFill>
-                      <a:srgbClr val="FFFFFF"/>
-                    </a:solidFill>
-                  </a:tcPr>
-                </a:tc>
-                <a:tc>
-                  <a:txBody>
-                    <a:bodyPr wrap="square"/>
-                    <a:lstStyle/>
-                    <a:p>
-                      <a:r>
-                        <a:rPr sz="1100" b="0">
-                          <a:solidFill>
-                            <a:srgbClr val="2C2C2C"/>
-                          </a:solidFill>
-                          <a:latin typeface="Malgun Gothic"/>
-                          <a:ea typeface="Malgun Gothic"/>
-                        </a:rPr>
-                        <a:t>120 MEA Otp Foxp2</a:t>
-                      </a:r>
-                    </a:p>
-                  </a:txBody>
-                  <a:tcPr>
-                    <a:solidFill>
-                      <a:srgbClr val="FFFFFF"/>
-                    </a:solidFill>
-                  </a:tcPr>
-                </a:tc>
-                <a:tc>
-                  <a:txBody>
-                    <a:bodyPr wrap="square"/>
-                    <a:lstStyle/>
-                    <a:p>
-                      <a:r>
-                        <a:rPr sz="1100" b="0">
-                          <a:solidFill>
-                            <a:srgbClr val="2C2C2C"/>
-                          </a:solidFill>
-                          <a:latin typeface="Malgun Gothic"/>
-                          <a:ea typeface="Malgun Gothic"/>
-                        </a:rPr>
-                        <a:t>슬라이드에 MEA가 있으면</a:t>
-                      </a:r>
-                    </a:p>
-                  </a:txBody>
-                  <a:tcPr>
-                    <a:solidFill>
-                      <a:srgbClr val="FFFFFF"/>
-                    </a:solidFill>
-                  </a:tcPr>
-                </a:tc>
-                <a:tc>
-                  <a:txBody>
-                    <a:bodyPr wrap="square"/>
-                    <a:lstStyle/>
-                    <a:p>
-                      <a:r>
-                        <a:rPr sz="1100" b="0">
-                          <a:solidFill>
-                            <a:srgbClr val="2C2C2C"/>
-                          </a:solidFill>
-                          <a:latin typeface="Malgun Gothic"/>
-                          <a:ea typeface="Malgun Gothic"/>
-                        </a:rPr>
-                        <a:t>BMAp 분리용 아님</a:t>
-                      </a:r>
-                    </a:p>
-                  </a:txBody>
-                  <a:tcPr>
-                    <a:solidFill>
-                      <a:srgbClr val="FFFFFF"/>
-                    </a:solidFill>
-                  </a:tcPr>
-                </a:tc>
-              </a:tr>
-              <a:tr h="594360">
-                <a:tc>
-                  <a:txBody>
-                    <a:bodyPr wrap="square"/>
-                    <a:lstStyle/>
-                    <a:p>
-                      <a:r>
-                        <a:rPr sz="1100" b="0">
-                          <a:solidFill>
-                            <a:srgbClr val="2C2C2C"/>
-                          </a:solidFill>
-                          <a:latin typeface="Malgun Gothic"/>
-                          <a:ea typeface="Malgun Gothic"/>
-                        </a:rPr>
-                        <a:t>Gfra1  Sp8</a:t>
-                      </a:r>
-                    </a:p>
-                  </a:txBody>
-                  <a:tcPr>
-                    <a:solidFill>
-                      <a:srgbClr val="F4F1EA"/>
-                    </a:solidFill>
-                  </a:tcPr>
-                </a:tc>
-                <a:tc>
-                  <a:txBody>
-                    <a:bodyPr wrap="square"/>
-                    <a:lstStyle/>
-                    <a:p>
-                      <a:r>
-                        <a:rPr sz="1100" b="0">
-                          <a:solidFill>
-                            <a:srgbClr val="2C2C2C"/>
-                          </a:solidFill>
-                          <a:latin typeface="Malgun Gothic"/>
-                          <a:ea typeface="Malgun Gothic"/>
-                        </a:rPr>
-                        <a:t>MEA–BST</a:t>
-                      </a:r>
-                    </a:p>
-                  </a:txBody>
-                  <a:tcPr>
-                    <a:solidFill>
-                      <a:srgbClr val="F4F1EA"/>
-                    </a:solidFill>
-                  </a:tcPr>
-                </a:tc>
-                <a:tc>
-                  <a:txBody>
-                    <a:bodyPr wrap="square"/>
-                    <a:lstStyle/>
-                    <a:p>
-                      <a:r>
-                        <a:rPr sz="1100" b="0">
-                          <a:solidFill>
-                            <a:srgbClr val="2C2C2C"/>
-                          </a:solidFill>
-                          <a:latin typeface="Malgun Gothic"/>
-                          <a:ea typeface="Malgun Gothic"/>
-                        </a:rPr>
-                        <a:t>이웃핵</a:t>
-                      </a:r>
-                    </a:p>
-                  </a:txBody>
-                  <a:tcPr>
-                    <a:solidFill>
-                      <a:srgbClr val="F4F1EA"/>
-                    </a:solidFill>
-                  </a:tcPr>
-                </a:tc>
-                <a:tc>
-                  <a:txBody>
-                    <a:bodyPr wrap="square"/>
-                    <a:lstStyle/>
-                    <a:p>
-                      <a:r>
-                        <a:rPr sz="1100" b="0">
-                          <a:solidFill>
-                            <a:srgbClr val="2C2C2C"/>
-                          </a:solidFill>
-                          <a:latin typeface="Malgun Gothic"/>
-                          <a:ea typeface="Malgun Gothic"/>
-                        </a:rPr>
-                        <a:t/>
-                      </a:r>
-                    </a:p>
-                  </a:txBody>
-                  <a:tcPr>
-                    <a:solidFill>
-                      <a:srgbClr val="F4F1EA"/>
-                    </a:solidFill>
-                  </a:tcPr>
-                </a:tc>
-              </a:tr>
-              <a:tr h="594360">
-                <a:tc>
-                  <a:txBody>
-                    <a:bodyPr wrap="square"/>
-                    <a:lstStyle/>
-                    <a:p>
-                      <a:r>
-                        <a:rPr sz="1100" b="0">
-                          <a:solidFill>
-                            <a:srgbClr val="2C2C2C"/>
-                          </a:solidFill>
-                          <a:latin typeface="Malgun Gothic"/>
-                          <a:ea typeface="Malgun Gothic"/>
-                        </a:rPr>
-                        <a:t>Syndig1l  Gabre  Tspan18</a:t>
-                      </a:r>
-                    </a:p>
-                  </a:txBody>
-                  <a:tcPr>
-                    <a:solidFill>
-                      <a:srgbClr val="FFFFFF"/>
-                    </a:solidFill>
-                  </a:tcPr>
-                </a:tc>
-                <a:tc>
-                  <a:txBody>
-                    <a:bodyPr wrap="square"/>
-                    <a:lstStyle/>
-                    <a:p>
-                      <a:r>
-                        <a:rPr sz="1100" b="0">
-                          <a:solidFill>
-                            <a:srgbClr val="2C2C2C"/>
-                          </a:solidFill>
-                          <a:latin typeface="Malgun Gothic"/>
-                          <a:ea typeface="Malgun Gothic"/>
-                        </a:rPr>
-                        <a:t>CEA / SI 경계</a:t>
-                      </a:r>
-                    </a:p>
-                  </a:txBody>
-                  <a:tcPr>
-                    <a:solidFill>
-                      <a:srgbClr val="FFFFFF"/>
-                    </a:solidFill>
-                  </a:tcPr>
-                </a:tc>
-                <a:tc>
-                  <a:txBody>
-                    <a:bodyPr wrap="square"/>
-                    <a:lstStyle/>
-                    <a:p>
-                      <a:r>
-                        <a:rPr sz="1100" b="0">
-                          <a:solidFill>
-                            <a:srgbClr val="2C2C2C"/>
-                          </a:solidFill>
-                          <a:latin typeface="Malgun Gothic"/>
-                          <a:ea typeface="Malgun Gothic"/>
-                        </a:rPr>
-                        <a:t>원하면 유지</a:t>
-                      </a:r>
-                    </a:p>
-                  </a:txBody>
-                  <a:tcPr>
-                    <a:solidFill>
-                      <a:srgbClr val="FFFFFF"/>
-                    </a:solidFill>
-                  </a:tcPr>
-                </a:tc>
-                <a:tc>
-                  <a:txBody>
-                    <a:bodyPr wrap="square"/>
-                    <a:lstStyle/>
-                    <a:p>
-                      <a:r>
-                        <a:rPr sz="1100" b="0">
-                          <a:solidFill>
-                            <a:srgbClr val="2C2C2C"/>
-                          </a:solidFill>
-                          <a:latin typeface="Malgun Gothic"/>
-                          <a:ea typeface="Malgun Gothic"/>
-                        </a:rPr>
-                        <a:t>제일 먼저 자를 후보</a:t>
-                      </a:r>
-                    </a:p>
-                  </a:txBody>
-                  <a:tcPr>
-                    <a:solidFill>
-                      <a:srgbClr val="FFFFFF"/>
-                    </a:solidFill>
-                  </a:tcPr>
-                </a:tc>
-              </a:tr>
-            </a:tbl>
-          </a:graphicData>
-        </a:graphic>
-      </p:graphicFrame>
-      <p:sp>
-        <p:nvSpPr>
-          <p:cNvPr id="6" name="TextBox 5"/>
-          <p:cNvSpPr txBox="1"/>
-          <p:nvPr/>
-        </p:nvSpPr>
-        <p:spPr>
-          <a:xfrm>
-            <a:off x="411480" y="5257800"/>
-            <a:ext cx="11338560" cy="1097280"/>
-          </a:xfrm>
-          <a:prstGeom prst="rect">
-            <a:avLst/>
-          </a:prstGeom>
-          <a:noFill/>
-        </p:spPr>
-        <p:txBody>
-          <a:bodyPr wrap="square">
-            <a:spAutoFit/>
-          </a:bodyPr>
-          <a:lstStyle/>
-          <a:p>
-            <a:r>
-              <a:rPr sz="1400" b="0">
-                <a:solidFill>
-                  <a:srgbClr val="2C2C2C"/>
-                </a:solidFill>
-                <a:latin typeface="Malgun Gothic"/>
-                <a:ea typeface="Malgun Gothic"/>
-              </a:rPr>
-              <a:t>Dan은 세포타입을 다시 짜는 데이터가 아니다. 편도 공간 패널을 우리 BMAp ROI에 맞춰 본 것이다.</a:t>
-            </a:r>
-          </a:p>
-          <a:p>
-            <a:r>
-              <a:rPr sz="1400" b="0">
-                <a:solidFill>
-                  <a:srgbClr val="2C2C2C"/>
-                </a:solidFill>
-                <a:latin typeface="Malgun Gothic"/>
-                <a:ea typeface="Malgun Gothic"/>
-              </a:rPr>
-              <a:t>14개 전부 유지하면 커스텀 114 (한도 100). 한도를 지키려면 Lamb3 + 012 경계만 남기고 CEA 쪽을 뺀다.</a:t>
-            </a:r>
-          </a:p>
-        </p:txBody>
-      </p:sp>
-      <p:sp>
-        <p:nvSpPr>
-          <p:cNvPr id="7" name="TextBox 6"/>
-          <p:cNvSpPr txBox="1"/>
-          <p:nvPr/>
-        </p:nvSpPr>
-        <p:spPr>
-          <a:xfrm>
-            <a:off x="411480" y="6565392"/>
-            <a:ext cx="11338560" cy="237744"/>
-          </a:xfrm>
-          <a:prstGeom prst="rect">
-            <a:avLst/>
-          </a:prstGeom>
-          <a:noFill/>
-        </p:spPr>
-        <p:txBody>
-          <a:bodyPr wrap="none">
-            <a:spAutoFit/>
-          </a:bodyPr>
-          <a:lstStyle/>
-          <a:p>
-            <a:r>
-              <a:rPr sz="1100" b="0">
-                <a:solidFill>
-                  <a:srgbClr val="6B6B6B"/>
-                </a:solidFill>
-                <a:latin typeface="Malgun Gothic"/>
-                <a:ea typeface="Malgun Gothic"/>
-              </a:rPr>
-              <a:t>Xenium ORBm + BMAp  |  Dan GSE283418  ·  Jesse PL-ILA-ORB  ·  Allen WMB-10X  |  2/4</a:t>
-            </a:r>
-          </a:p>
-        </p:txBody>
-      </p:sp>
-    </p:spTree>
-  </p:cSld>
-  <p:clrMapOvr>
-    <a:masterClrMapping/>
-  </p:clrMapOvr>
-</p:sld>
-</file>
-
-<file path=ppt/slides/slide3.xml><?xml version="1.0" encoding="utf-8"?>
 <p:sld xmlns:a="http://schemas.openxmlformats.org/drawingml/2006/main" xmlns:p="http://schemas.openxmlformats.org/presentationml/2006/main" xmlns:r="http://schemas.openxmlformats.org/officeDocument/2006/relationships">
   <p:cSld>
     <p:spTree>
@@ -5078,7 +4224,7 @@
         <p:spPr>
           <a:xfrm>
             <a:off x="411480" y="201168"/>
-            <a:ext cx="11338560" cy="420624"/>
+            <a:ext cx="11338560" cy="402336"/>
           </a:xfrm>
           <a:prstGeom prst="rect">
             <a:avLst/>
@@ -5092,14 +4238,13 @@
           <a:lstStyle/>
           <a:p>
             <a:r>
-              <a:rPr sz="2400" b="1">
+              <a:rPr sz="2600" b="1">
                 <a:solidFill>
                   <a:srgbClr val="1D4E89"/>
                 </a:solidFill>
-                <a:latin typeface="Malgun Gothic"/>
-                <a:ea typeface="Malgun Gothic"/>
+                <a:latin typeface="Calibri"/>
               </a:rPr>
-              <a:t>Jesse + Allen — 상대 농축이 아니라 절대량</a:t>
+              <a:t>Jesse  |  genes considered, and why</a:t>
             </a:r>
           </a:p>
         </p:txBody>
@@ -5127,14 +4272,13 @@
           <a:lstStyle/>
           <a:p>
             <a:r>
-              <a:rPr sz="1300" b="0">
+              <a:rPr sz="1400" b="0">
                 <a:solidFill>
                   <a:srgbClr val="6B6B6B"/>
                 </a:solidFill>
-                <a:latin typeface="Malgun Gothic"/>
-                <a:ea typeface="Malgun Gothic"/>
+                <a:latin typeface="Calibri"/>
               </a:rPr>
-              <a:t>Jesse: 5일 모르핀 DEG + ORB vs 나머지 뇌 GPCR 농축. Allen: 같은 유전자를 ORBm 12앵커에서 % expressing.</a:t>
+              <a:t>5-day morphine DEGs in PL–ILA–ORB  +  GPCRs enriched in ORB vs the rest of the Allen atlas. Then checked as % expressing in our 106,122 ORBm cells.</a:t>
             </a:r>
           </a:p>
         </p:txBody>
@@ -5148,8 +4292,8 @@
           <p:nvPr/>
         </p:nvGraphicFramePr>
         <p:xfrm>
-          <a:off x="320040" y="960120"/>
-          <a:ext cx="11521440" cy="5349240"/>
+          <a:off x="365760" y="987552"/>
+          <a:ext cx="11430000" cy="5257800"/>
         </p:xfrm>
         <a:graphic>
           <a:graphicData uri="http://schemas.openxmlformats.org/drawingml/2006/table">
@@ -5158,26 +4302,24 @@
                 <a:tableStyleId>{5C22544A-7EE6-4342-B048-85BDC9FD1C3A}</a:tableStyleId>
               </a:tblPr>
               <a:tblGrid>
-                <a:gridCol w="1965960"/>
-                <a:gridCol w="3063240"/>
-                <a:gridCol w="3931920"/>
-                <a:gridCol w="2560320"/>
+                <a:gridCol w="3017520"/>
+                <a:gridCol w="4114800"/>
+                <a:gridCol w="4297680"/>
               </a:tblGrid>
-              <a:tr h="534924">
+              <a:tr h="657225">
                 <a:tc>
                   <a:txBody>
                     <a:bodyPr wrap="square"/>
                     <a:lstStyle/>
                     <a:p>
                       <a:r>
-                        <a:rPr sz="1100" b="1">
+                        <a:rPr sz="1300" b="1">
                           <a:solidFill>
                             <a:srgbClr val="FFFFFF"/>
                           </a:solidFill>
-                          <a:latin typeface="Malgun Gothic"/>
-                          <a:ea typeface="Malgun Gothic"/>
+                          <a:latin typeface="Calibri"/>
                         </a:rPr>
-                        <a:t>유전자</a:t>
+                        <a:t>Considered</a:t>
                       </a:r>
                     </a:p>
                   </a:txBody>
@@ -5193,14 +4335,13 @@
                     <a:lstStyle/>
                     <a:p>
                       <a:r>
-                        <a:rPr sz="1100" b="1">
+                        <a:rPr sz="1300" b="1">
                           <a:solidFill>
                             <a:srgbClr val="FFFFFF"/>
                           </a:solidFill>
-                          <a:latin typeface="Malgun Gothic"/>
-                          <a:ea typeface="Malgun Gothic"/>
+                          <a:latin typeface="Calibri"/>
                         </a:rPr>
-                        <a:t>Jesse가 말한 것</a:t>
+                        <a:t>Why Jesse flagged it</a:t>
                       </a:r>
                     </a:p>
                   </a:txBody>
@@ -5216,37 +4357,13 @@
                     <a:lstStyle/>
                     <a:p>
                       <a:r>
-                        <a:rPr sz="1100" b="1">
+                        <a:rPr sz="1300" b="1">
                           <a:solidFill>
                             <a:srgbClr val="FFFFFF"/>
                           </a:solidFill>
-                          <a:latin typeface="Malgun Gothic"/>
-                          <a:ea typeface="Malgun Gothic"/>
+                          <a:latin typeface="Calibri"/>
                         </a:rPr>
-                        <a:t>Allen ORBm 최대 %</a:t>
-                      </a:r>
-                    </a:p>
-                  </a:txBody>
-                  <a:tcPr>
-                    <a:solidFill>
-                      <a:srgbClr val="1D4E89"/>
-                    </a:solidFill>
-                  </a:tcPr>
-                </a:tc>
-                <a:tc>
-                  <a:txBody>
-                    <a:bodyPr wrap="square"/>
-                    <a:lstStyle/>
-                    <a:p>
-                      <a:r>
-                        <a:rPr sz="1100" b="1">
-                          <a:solidFill>
-                            <a:srgbClr val="FFFFFF"/>
-                          </a:solidFill>
-                          <a:latin typeface="Malgun Gothic"/>
-                          <a:ea typeface="Malgun Gothic"/>
-                        </a:rPr>
-                        <a:t>결정</a:t>
+                        <a:t>Why it is / is not a panel add</a:t>
                       </a:r>
                     </a:p>
                   </a:txBody>
@@ -5257,21 +4374,20 @@
                   </a:tcPr>
                 </a:tc>
               </a:tr>
-              <a:tr h="534924">
+              <a:tr h="657225">
                 <a:tc>
                   <a:txBody>
                     <a:bodyPr wrap="square"/>
                     <a:lstStyle/>
                     <a:p>
                       <a:r>
-                        <a:rPr sz="1100" b="0">
+                        <a:rPr sz="1200" b="0">
                           <a:solidFill>
                             <a:srgbClr val="2C2C2C"/>
                           </a:solidFill>
-                          <a:latin typeface="Malgun Gothic"/>
-                          <a:ea typeface="Malgun Gothic"/>
+                          <a:latin typeface="Calibri"/>
                         </a:rPr>
-                        <a:t>Chrm1</a:t>
+                        <a:t>Fos  Arc  Egr1  Junb  Nr4a1</a:t>
                       </a:r>
                     </a:p>
                   </a:txBody>
@@ -5287,14 +4403,13 @@
                     <a:lstStyle/>
                     <a:p>
                       <a:r>
-                        <a:rPr sz="1100" b="0">
+                        <a:rPr sz="1200" b="0">
                           <a:solidFill>
                             <a:srgbClr val="2C2C2C"/>
                           </a:solidFill>
-                          <a:latin typeface="Malgun Gothic"/>
-                          <a:ea typeface="Malgun Gothic"/>
+                          <a:latin typeface="Calibri"/>
                         </a:rPr>
-                        <a:t>ORB 흥분성 농축 (7앵커)</a:t>
+                        <a:t>Top activity IEGs after morphine</a:t>
                       </a:r>
                     </a:p>
                   </a:txBody>
@@ -5310,37 +4425,13 @@
                     <a:lstStyle/>
                     <a:p>
                       <a:r>
-                        <a:rPr sz="1100" b="0">
+                        <a:rPr sz="1200" b="0">
                           <a:solidFill>
                             <a:srgbClr val="2C2C2C"/>
                           </a:solidFill>
-                          <a:latin typeface="Malgun Gothic"/>
-                          <a:ea typeface="Malgun Gothic"/>
+                          <a:latin typeface="Calibri"/>
                         </a:rPr>
-                        <a:t>92%  L2/3   ·  9앵커 ≥50%</a:t>
-                      </a:r>
-                    </a:p>
-                  </a:txBody>
-                  <a:tcPr>
-                    <a:solidFill>
-                      <a:srgbClr val="F4F1EA"/>
-                    </a:solidFill>
-                  </a:tcPr>
-                </a:tc>
-                <a:tc>
-                  <a:txBody>
-                    <a:bodyPr wrap="square"/>
-                    <a:lstStyle/>
-                    <a:p>
-                      <a:r>
-                        <a:rPr sz="1100" b="0">
-                          <a:solidFill>
-                            <a:srgbClr val="2C2C2C"/>
-                          </a:solidFill>
-                          <a:latin typeface="Malgun Gothic"/>
-                          <a:ea typeface="Malgun Gothic"/>
-                        </a:rPr>
-                        <a:t>추가  1순위 GPCR</a:t>
+                        <a:t>Already on the 144. Keep. Do not swap.</a:t>
                       </a:r>
                     </a:p>
                   </a:txBody>
@@ -5351,583 +4442,18 @@
                   </a:tcPr>
                 </a:tc>
               </a:tr>
-              <a:tr h="534924">
+              <a:tr h="657225">
                 <a:tc>
                   <a:txBody>
                     <a:bodyPr wrap="square"/>
                     <a:lstStyle/>
                     <a:p>
                       <a:r>
-                        <a:rPr sz="1100" b="0">
+                        <a:rPr sz="1200" b="0">
                           <a:solidFill>
                             <a:srgbClr val="2C2C2C"/>
                           </a:solidFill>
-                          <a:latin typeface="Malgun Gothic"/>
-                          <a:ea typeface="Malgun Gothic"/>
-                        </a:rPr>
-                        <a:t>Grm8</a:t>
-                      </a:r>
-                    </a:p>
-                  </a:txBody>
-                  <a:tcPr>
-                    <a:solidFill>
-                      <a:srgbClr val="FFFFFF"/>
-                    </a:solidFill>
-                  </a:tcPr>
-                </a:tc>
-                <a:tc>
-                  <a:txBody>
-                    <a:bodyPr wrap="square"/>
-                    <a:lstStyle/>
-                    <a:p>
-                      <a:r>
-                        <a:rPr sz="1100" b="0">
-                          <a:solidFill>
-                            <a:srgbClr val="2C2C2C"/>
-                          </a:solidFill>
-                          <a:latin typeface="Malgun Gothic"/>
-                          <a:ea typeface="Malgun Gothic"/>
-                        </a:rPr>
-                        <a:t>ORB 억제성 농축 (7앵커)</a:t>
-                      </a:r>
-                    </a:p>
-                  </a:txBody>
-                  <a:tcPr>
-                    <a:solidFill>
-                      <a:srgbClr val="FFFFFF"/>
-                    </a:solidFill>
-                  </a:tcPr>
-                </a:tc>
-                <a:tc>
-                  <a:txBody>
-                    <a:bodyPr wrap="square"/>
-                    <a:lstStyle/>
-                    <a:p>
-                      <a:r>
-                        <a:rPr sz="1100" b="0">
-                          <a:solidFill>
-                            <a:srgbClr val="2C2C2C"/>
-                          </a:solidFill>
-                          <a:latin typeface="Malgun Gothic"/>
-                          <a:ea typeface="Malgun Gothic"/>
-                        </a:rPr>
-                        <a:t>99%  L5 ET  ·  8앵커 ≥50%</a:t>
-                      </a:r>
-                    </a:p>
-                  </a:txBody>
-                  <a:tcPr>
-                    <a:solidFill>
-                      <a:srgbClr val="FFFFFF"/>
-                    </a:solidFill>
-                  </a:tcPr>
-                </a:tc>
-                <a:tc>
-                  <a:txBody>
-                    <a:bodyPr wrap="square"/>
-                    <a:lstStyle/>
-                    <a:p>
-                      <a:r>
-                        <a:rPr sz="1100" b="0">
-                          <a:solidFill>
-                            <a:srgbClr val="2C2C2C"/>
-                          </a:solidFill>
-                          <a:latin typeface="Malgun Gothic"/>
-                          <a:ea typeface="Malgun Gothic"/>
-                        </a:rPr>
-                        <a:t>추가  1순위 GPCR</a:t>
-                      </a:r>
-                    </a:p>
-                  </a:txBody>
-                  <a:tcPr>
-                    <a:solidFill>
-                      <a:srgbClr val="FFFFFF"/>
-                    </a:solidFill>
-                  </a:tcPr>
-                </a:tc>
-              </a:tr>
-              <a:tr h="534924">
-                <a:tc>
-                  <a:txBody>
-                    <a:bodyPr wrap="square"/>
-                    <a:lstStyle/>
-                    <a:p>
-                      <a:r>
-                        <a:rPr sz="1100" b="0">
-                          <a:solidFill>
-                            <a:srgbClr val="2C2C2C"/>
-                          </a:solidFill>
-                          <a:latin typeface="Malgun Gothic"/>
-                          <a:ea typeface="Malgun Gothic"/>
-                        </a:rPr>
-                        <a:t>Gpr26</a:t>
-                      </a:r>
-                    </a:p>
-                  </a:txBody>
-                  <a:tcPr>
-                    <a:solidFill>
-                      <a:srgbClr val="F4F1EA"/>
-                    </a:solidFill>
-                  </a:tcPr>
-                </a:tc>
-                <a:tc>
-                  <a:txBody>
-                    <a:bodyPr wrap="square"/>
-                    <a:lstStyle/>
-                    <a:p>
-                      <a:r>
-                        <a:rPr sz="1100" b="0">
-                          <a:solidFill>
-                            <a:srgbClr val="2C2C2C"/>
-                          </a:solidFill>
-                          <a:latin typeface="Malgun Gothic"/>
-                          <a:ea typeface="Malgun Gothic"/>
-                        </a:rPr>
-                        <a:t>ORB IT 농축</a:t>
-                      </a:r>
-                    </a:p>
-                  </a:txBody>
-                  <a:tcPr>
-                    <a:solidFill>
-                      <a:srgbClr val="F4F1EA"/>
-                    </a:solidFill>
-                  </a:tcPr>
-                </a:tc>
-                <a:tc>
-                  <a:txBody>
-                    <a:bodyPr wrap="square"/>
-                    <a:lstStyle/>
-                    <a:p>
-                      <a:r>
-                        <a:rPr sz="1100" b="0">
-                          <a:solidFill>
-                            <a:srgbClr val="2C2C2C"/>
-                          </a:solidFill>
-                          <a:latin typeface="Malgun Gothic"/>
-                          <a:ea typeface="Malgun Gothic"/>
-                        </a:rPr>
-                        <a:t>86%  L4/5 IT</a:t>
-                      </a:r>
-                    </a:p>
-                  </a:txBody>
-                  <a:tcPr>
-                    <a:solidFill>
-                      <a:srgbClr val="F4F1EA"/>
-                    </a:solidFill>
-                  </a:tcPr>
-                </a:tc>
-                <a:tc>
-                  <a:txBody>
-                    <a:bodyPr wrap="square"/>
-                    <a:lstStyle/>
-                    <a:p>
-                      <a:r>
-                        <a:rPr sz="1100" b="0">
-                          <a:solidFill>
-                            <a:srgbClr val="2C2C2C"/>
-                          </a:solidFill>
-                          <a:latin typeface="Malgun Gothic"/>
-                          <a:ea typeface="Malgun Gothic"/>
-                        </a:rPr>
-                        <a:t>여유 시</a:t>
-                      </a:r>
-                    </a:p>
-                  </a:txBody>
-                  <a:tcPr>
-                    <a:solidFill>
-                      <a:srgbClr val="F4F1EA"/>
-                    </a:solidFill>
-                  </a:tcPr>
-                </a:tc>
-              </a:tr>
-              <a:tr h="534924">
-                <a:tc>
-                  <a:txBody>
-                    <a:bodyPr wrap="square"/>
-                    <a:lstStyle/>
-                    <a:p>
-                      <a:r>
-                        <a:rPr sz="1100" b="0">
-                          <a:solidFill>
-                            <a:srgbClr val="2C2C2C"/>
-                          </a:solidFill>
-                          <a:latin typeface="Malgun Gothic"/>
-                          <a:ea typeface="Malgun Gothic"/>
-                        </a:rPr>
-                        <a:t>Cckbr  Hcrtr2</a:t>
-                      </a:r>
-                    </a:p>
-                  </a:txBody>
-                  <a:tcPr>
-                    <a:solidFill>
-                      <a:srgbClr val="FFFFFF"/>
-                    </a:solidFill>
-                  </a:tcPr>
-                </a:tc>
-                <a:tc>
-                  <a:txBody>
-                    <a:bodyPr wrap="square"/>
-                    <a:lstStyle/>
-                    <a:p>
-                      <a:r>
-                        <a:rPr sz="1100" b="0">
-                          <a:solidFill>
-                            <a:srgbClr val="2C2C2C"/>
-                          </a:solidFill>
-                          <a:latin typeface="Malgun Gothic"/>
-                          <a:ea typeface="Malgun Gothic"/>
-                        </a:rPr>
-                        <a:t>ORB 농축</a:t>
-                      </a:r>
-                    </a:p>
-                  </a:txBody>
-                  <a:tcPr>
-                    <a:solidFill>
-                      <a:srgbClr val="FFFFFF"/>
-                    </a:solidFill>
-                  </a:tcPr>
-                </a:tc>
-                <a:tc>
-                  <a:txBody>
-                    <a:bodyPr wrap="square"/>
-                    <a:lstStyle/>
-                    <a:p>
-                      <a:r>
-                        <a:rPr sz="1100" b="0">
-                          <a:solidFill>
-                            <a:srgbClr val="2C2C2C"/>
-                          </a:solidFill>
-                          <a:latin typeface="Malgun Gothic"/>
-                          <a:ea typeface="Malgun Gothic"/>
-                        </a:rPr>
-                        <a:t>74% / 67%  Lamp5</a:t>
-                      </a:r>
-                    </a:p>
-                  </a:txBody>
-                  <a:tcPr>
-                    <a:solidFill>
-                      <a:srgbClr val="FFFFFF"/>
-                    </a:solidFill>
-                  </a:tcPr>
-                </a:tc>
-                <a:tc>
-                  <a:txBody>
-                    <a:bodyPr wrap="square"/>
-                    <a:lstStyle/>
-                    <a:p>
-                      <a:r>
-                        <a:rPr sz="1100" b="0">
-                          <a:solidFill>
-                            <a:srgbClr val="2C2C2C"/>
-                          </a:solidFill>
-                          <a:latin typeface="Malgun Gothic"/>
-                          <a:ea typeface="Malgun Gothic"/>
-                        </a:rPr>
-                        <a:t>이미 패널</a:t>
-                      </a:r>
-                    </a:p>
-                  </a:txBody>
-                  <a:tcPr>
-                    <a:solidFill>
-                      <a:srgbClr val="FFFFFF"/>
-                    </a:solidFill>
-                  </a:tcPr>
-                </a:tc>
-              </a:tr>
-              <a:tr h="534924">
-                <a:tc>
-                  <a:txBody>
-                    <a:bodyPr wrap="square"/>
-                    <a:lstStyle/>
-                    <a:p>
-                      <a:r>
-                        <a:rPr sz="1100" b="0">
-                          <a:solidFill>
-                            <a:srgbClr val="2C2C2C"/>
-                          </a:solidFill>
-                          <a:latin typeface="Malgun Gothic"/>
-                          <a:ea typeface="Malgun Gothic"/>
-                        </a:rPr>
-                        <a:t>Rxfp1</a:t>
-                      </a:r>
-                    </a:p>
-                  </a:txBody>
-                  <a:tcPr>
-                    <a:solidFill>
-                      <a:srgbClr val="F4F1EA"/>
-                    </a:solidFill>
-                  </a:tcPr>
-                </a:tc>
-                <a:tc>
-                  <a:txBody>
-                    <a:bodyPr wrap="square"/>
-                    <a:lstStyle/>
-                    <a:p>
-                      <a:r>
-                        <a:rPr sz="1100" b="0">
-                          <a:solidFill>
-                            <a:srgbClr val="2C2C2C"/>
-                          </a:solidFill>
-                          <a:latin typeface="Malgun Gothic"/>
-                          <a:ea typeface="Malgun Gothic"/>
-                        </a:rPr>
-                        <a:t>농축 1–2등 (19 서브클래스)</a:t>
-                      </a:r>
-                    </a:p>
-                  </a:txBody>
-                  <a:tcPr>
-                    <a:solidFill>
-                      <a:srgbClr val="F4F1EA"/>
-                    </a:solidFill>
-                  </a:tcPr>
-                </a:tc>
-                <a:tc>
-                  <a:txBody>
-                    <a:bodyPr wrap="square"/>
-                    <a:lstStyle/>
-                    <a:p>
-                      <a:r>
-                        <a:rPr sz="1100" b="0">
-                          <a:solidFill>
-                            <a:srgbClr val="2C2C2C"/>
-                          </a:solidFill>
-                          <a:latin typeface="Malgun Gothic"/>
-                          <a:ea typeface="Malgun Gothic"/>
-                        </a:rPr>
-                        <a:t>34%  L5 ET   무료 베이스</a:t>
-                      </a:r>
-                    </a:p>
-                  </a:txBody>
-                  <a:tcPr>
-                    <a:solidFill>
-                      <a:srgbClr val="F4F1EA"/>
-                    </a:solidFill>
-                  </a:tcPr>
-                </a:tc>
-                <a:tc>
-                  <a:txBody>
-                    <a:bodyPr wrap="square"/>
-                    <a:lstStyle/>
-                    <a:p>
-                      <a:r>
-                        <a:rPr sz="1100" b="0">
-                          <a:solidFill>
-                            <a:srgbClr val="2C2C2C"/>
-                          </a:solidFill>
-                          <a:latin typeface="Malgun Gothic"/>
-                          <a:ea typeface="Malgun Gothic"/>
-                        </a:rPr>
-                        <a:t>지금 표시</a:t>
-                      </a:r>
-                    </a:p>
-                  </a:txBody>
-                  <a:tcPr>
-                    <a:solidFill>
-                      <a:srgbClr val="F4F1EA"/>
-                    </a:solidFill>
-                  </a:tcPr>
-                </a:tc>
-              </a:tr>
-              <a:tr h="534924">
-                <a:tc>
-                  <a:txBody>
-                    <a:bodyPr wrap="square"/>
-                    <a:lstStyle/>
-                    <a:p>
-                      <a:r>
-                        <a:rPr sz="1100" b="0">
-                          <a:solidFill>
-                            <a:srgbClr val="2C2C2C"/>
-                          </a:solidFill>
-                          <a:latin typeface="Malgun Gothic"/>
-                          <a:ea typeface="Malgun Gothic"/>
-                        </a:rPr>
-                        <a:t>Mas1</a:t>
-                      </a:r>
-                    </a:p>
-                  </a:txBody>
-                  <a:tcPr>
-                    <a:solidFill>
-                      <a:srgbClr val="FFFFFF"/>
-                    </a:solidFill>
-                  </a:tcPr>
-                </a:tc>
-                <a:tc>
-                  <a:txBody>
-                    <a:bodyPr wrap="square"/>
-                    <a:lstStyle/>
-                    <a:p>
-                      <a:r>
-                        <a:rPr sz="1100" b="0">
-                          <a:solidFill>
-                            <a:srgbClr val="2C2C2C"/>
-                          </a:solidFill>
-                          <a:latin typeface="Malgun Gothic"/>
-                          <a:ea typeface="Malgun Gothic"/>
-                        </a:rPr>
-                        <a:t>흥분성 농축 1등 (17)</a:t>
-                      </a:r>
-                    </a:p>
-                  </a:txBody>
-                  <a:tcPr>
-                    <a:solidFill>
-                      <a:srgbClr val="FFFFFF"/>
-                    </a:solidFill>
-                  </a:tcPr>
-                </a:tc>
-                <a:tc>
-                  <a:txBody>
-                    <a:bodyPr wrap="square"/>
-                    <a:lstStyle/>
-                    <a:p>
-                      <a:r>
-                        <a:rPr sz="1100" b="0">
-                          <a:solidFill>
-                            <a:srgbClr val="2C2C2C"/>
-                          </a:solidFill>
-                          <a:latin typeface="Malgun Gothic"/>
-                          <a:ea typeface="Malgun Gothic"/>
-                        </a:rPr>
-                        <a:t>45%  L5 ET  ·  GABA 1–2%</a:t>
-                      </a:r>
-                    </a:p>
-                  </a:txBody>
-                  <a:tcPr>
-                    <a:solidFill>
-                      <a:srgbClr val="FFFFFF"/>
-                    </a:solidFill>
-                  </a:tcPr>
-                </a:tc>
-                <a:tc>
-                  <a:txBody>
-                    <a:bodyPr wrap="square"/>
-                    <a:lstStyle/>
-                    <a:p>
-                      <a:r>
-                        <a:rPr sz="1100" b="0">
-                          <a:solidFill>
-                            <a:srgbClr val="2C2C2C"/>
-                          </a:solidFill>
-                          <a:latin typeface="Malgun Gothic"/>
-                          <a:ea typeface="Malgun Gothic"/>
-                        </a:rPr>
-                        <a:t>선택. 흥분성만</a:t>
-                      </a:r>
-                    </a:p>
-                  </a:txBody>
-                  <a:tcPr>
-                    <a:solidFill>
-                      <a:srgbClr val="FFFFFF"/>
-                    </a:solidFill>
-                  </a:tcPr>
-                </a:tc>
-              </a:tr>
-              <a:tr h="534924">
-                <a:tc>
-                  <a:txBody>
-                    <a:bodyPr wrap="square"/>
-                    <a:lstStyle/>
-                    <a:p>
-                      <a:r>
-                        <a:rPr sz="1100" b="0">
-                          <a:solidFill>
-                            <a:srgbClr val="2C2C2C"/>
-                          </a:solidFill>
-                          <a:latin typeface="Malgun Gothic"/>
-                          <a:ea typeface="Malgun Gothic"/>
-                        </a:rPr>
-                        <a:t>Gpr68  Mchr1</a:t>
-                      </a:r>
-                    </a:p>
-                  </a:txBody>
-                  <a:tcPr>
-                    <a:solidFill>
-                      <a:srgbClr val="F4F1EA"/>
-                    </a:solidFill>
-                  </a:tcPr>
-                </a:tc>
-                <a:tc>
-                  <a:txBody>
-                    <a:bodyPr wrap="square"/>
-                    <a:lstStyle/>
-                    <a:p>
-                      <a:r>
-                        <a:rPr sz="1100" b="0">
-                          <a:solidFill>
-                            <a:srgbClr val="2C2C2C"/>
-                          </a:solidFill>
-                          <a:latin typeface="Malgun Gothic"/>
-                          <a:ea typeface="Malgun Gothic"/>
-                        </a:rPr>
-                        <a:t>농축 3–4등</a:t>
-                      </a:r>
-                    </a:p>
-                  </a:txBody>
-                  <a:tcPr>
-                    <a:solidFill>
-                      <a:srgbClr val="F4F1EA"/>
-                    </a:solidFill>
-                  </a:tcPr>
-                </a:tc>
-                <a:tc>
-                  <a:txBody>
-                    <a:bodyPr wrap="square"/>
-                    <a:lstStyle/>
-                    <a:p>
-                      <a:r>
-                        <a:rPr sz="1100" b="0">
-                          <a:solidFill>
-                            <a:srgbClr val="2C2C2C"/>
-                          </a:solidFill>
-                          <a:latin typeface="Malgun Gothic"/>
-                          <a:ea typeface="Malgun Gothic"/>
-                        </a:rPr>
-                        <a:t>40% IT / 32% ET</a:t>
-                      </a:r>
-                    </a:p>
-                  </a:txBody>
-                  <a:tcPr>
-                    <a:solidFill>
-                      <a:srgbClr val="F4F1EA"/>
-                    </a:solidFill>
-                  </a:tcPr>
-                </a:tc>
-                <a:tc>
-                  <a:txBody>
-                    <a:bodyPr wrap="square"/>
-                    <a:lstStyle/>
-                    <a:p>
-                      <a:r>
-                        <a:rPr sz="1100" b="0">
-                          <a:solidFill>
-                            <a:srgbClr val="2C2C2C"/>
-                          </a:solidFill>
-                          <a:latin typeface="Malgun Gothic"/>
-                          <a:ea typeface="Malgun Gothic"/>
-                        </a:rPr>
-                        <a:t>Mchr1은 보류</a:t>
-                      </a:r>
-                    </a:p>
-                  </a:txBody>
-                  <a:tcPr>
-                    <a:solidFill>
-                      <a:srgbClr val="F4F1EA"/>
-                    </a:solidFill>
-                  </a:tcPr>
-                </a:tc>
-              </a:tr>
-              <a:tr h="534924">
-                <a:tc>
-                  <a:txBody>
-                    <a:bodyPr wrap="square"/>
-                    <a:lstStyle/>
-                    <a:p>
-                      <a:r>
-                        <a:rPr sz="1100" b="0">
-                          <a:solidFill>
-                            <a:srgbClr val="2C2C2C"/>
-                          </a:solidFill>
-                          <a:latin typeface="Malgun Gothic"/>
-                          <a:ea typeface="Malgun Gothic"/>
+                          <a:latin typeface="Calibri"/>
                         </a:rPr>
                         <a:t>Per2  Pcsk1  Per1</a:t>
                       </a:r>
@@ -5945,14 +4471,13 @@
                     <a:lstStyle/>
                     <a:p>
                       <a:r>
-                        <a:rPr sz="1100" b="0">
+                        <a:rPr sz="1200" b="0">
                           <a:solidFill>
                             <a:srgbClr val="2C2C2C"/>
                           </a:solidFill>
-                          <a:latin typeface="Malgun Gothic"/>
-                          <a:ea typeface="Malgun Gothic"/>
+                          <a:latin typeface="Calibri"/>
                         </a:rPr>
-                        <a:t>가장 넓은 새 IEG (13/11/8)</a:t>
+                        <a:t>Widest new IEGs (13 / 11 / 8 clusters). Circadian / peptide program, not acute TRAP.</a:t>
                       </a:r>
                     </a:p>
                   </a:txBody>
@@ -5968,14 +4493,105 @@
                     <a:lstStyle/>
                     <a:p>
                       <a:r>
-                        <a:rPr sz="1100" b="0">
+                        <a:rPr sz="1200" b="0">
                           <a:solidFill>
                             <a:srgbClr val="2C2C2C"/>
                           </a:solidFill>
-                          <a:latin typeface="Malgun Gothic"/>
-                          <a:ea typeface="Malgun Gothic"/>
+                          <a:latin typeface="Calibri"/>
                         </a:rPr>
-                        <a:t>Per1 63%  ·  Per2·Pcsk1은 이번 12유전자에 없음</a:t>
+                        <a:t>Not on the panel. This is the morphine-state layer.</a:t>
+                      </a:r>
+                    </a:p>
+                  </a:txBody>
+                  <a:tcPr>
+                    <a:solidFill>
+                      <a:srgbClr val="FFFFFF"/>
+                    </a:solidFill>
+                  </a:tcPr>
+                </a:tc>
+              </a:tr>
+              <a:tr h="657225">
+                <a:tc>
+                  <a:txBody>
+                    <a:bodyPr wrap="square"/>
+                    <a:lstStyle/>
+                    <a:p>
+                      <a:r>
+                        <a:rPr sz="1200" b="0">
+                          <a:solidFill>
+                            <a:srgbClr val="2C2C2C"/>
+                          </a:solidFill>
+                          <a:latin typeface="Calibri"/>
+                        </a:rPr>
+                        <a:t>Cckbr  Hcrtr2  Chrm2  Grm5</a:t>
+                      </a:r>
+                    </a:p>
+                  </a:txBody>
+                  <a:tcPr>
+                    <a:solidFill>
+                      <a:srgbClr val="F4F1EA"/>
+                    </a:solidFill>
+                  </a:tcPr>
+                </a:tc>
+                <a:tc>
+                  <a:txBody>
+                    <a:bodyPr wrap="square"/>
+                    <a:lstStyle/>
+                    <a:p>
+                      <a:r>
+                        <a:rPr sz="1200" b="0">
+                          <a:solidFill>
+                            <a:srgbClr val="2C2C2C"/>
+                          </a:solidFill>
+                          <a:latin typeface="Calibri"/>
+                        </a:rPr>
+                        <a:t>ORB-enriched or DEG GPCRs</a:t>
+                      </a:r>
+                    </a:p>
+                  </a:txBody>
+                  <a:tcPr>
+                    <a:solidFill>
+                      <a:srgbClr val="F4F1EA"/>
+                    </a:solidFill>
+                  </a:tcPr>
+                </a:tc>
+                <a:tc>
+                  <a:txBody>
+                    <a:bodyPr wrap="square"/>
+                    <a:lstStyle/>
+                    <a:p>
+                      <a:r>
+                        <a:rPr sz="1200" b="0">
+                          <a:solidFill>
+                            <a:srgbClr val="2C2C2C"/>
+                          </a:solidFill>
+                          <a:latin typeface="Calibri"/>
+                        </a:rPr>
+                        <a:t>Already on the 144.</a:t>
+                      </a:r>
+                    </a:p>
+                  </a:txBody>
+                  <a:tcPr>
+                    <a:solidFill>
+                      <a:srgbClr val="F4F1EA"/>
+                    </a:solidFill>
+                  </a:tcPr>
+                </a:tc>
+              </a:tr>
+              <a:tr h="657225">
+                <a:tc>
+                  <a:txBody>
+                    <a:bodyPr wrap="square"/>
+                    <a:lstStyle/>
+                    <a:p>
+                      <a:r>
+                        <a:rPr sz="1200" b="0">
+                          <a:solidFill>
+                            <a:srgbClr val="2C2C2C"/>
+                          </a:solidFill>
+                          <a:latin typeface="Calibri"/>
+                        </a:rPr>
+                        <a:t>Rxfp1</a:t>
                       </a:r>
                     </a:p>
                   </a:txBody>
@@ -5991,14 +4607,35 @@
                     <a:lstStyle/>
                     <a:p>
                       <a:r>
-                        <a:rPr sz="1100" b="0">
+                        <a:rPr sz="1200" b="0">
                           <a:solidFill>
                             <a:srgbClr val="2C2C2C"/>
                           </a:solidFill>
-                          <a:latin typeface="Malgun Gothic"/>
-                          <a:ea typeface="Malgun Gothic"/>
+                          <a:latin typeface="Calibri"/>
                         </a:rPr>
-                        <a:t>상태 패키지</a:t>
+                        <a:t>Top ORB-enriched GPCR (19 subclasses)</a:t>
+                      </a:r>
+                    </a:p>
+                  </a:txBody>
+                  <a:tcPr>
+                    <a:solidFill>
+                      <a:srgbClr val="FFFFFF"/>
+                    </a:solidFill>
+                  </a:tcPr>
+                </a:tc>
+                <a:tc>
+                  <a:txBody>
+                    <a:bodyPr wrap="square"/>
+                    <a:lstStyle/>
+                    <a:p>
+                      <a:r>
+                        <a:rPr sz="1200" b="0">
+                          <a:solidFill>
+                            <a:srgbClr val="2C2C2C"/>
+                          </a:solidFill>
+                          <a:latin typeface="Calibri"/>
+                        </a:rPr>
+                        <a:t>Free on Xenium Mouse Brain v1. Allen 34% in L5 ET.</a:t>
                       </a:r>
                     </a:p>
                   </a:txBody>
@@ -6009,21 +4646,20 @@
                   </a:tcPr>
                 </a:tc>
               </a:tr>
-              <a:tr h="534924">
+              <a:tr h="657225">
                 <a:tc>
                   <a:txBody>
                     <a:bodyPr wrap="square"/>
                     <a:lstStyle/>
                     <a:p>
                       <a:r>
-                        <a:rPr sz="1100" b="0">
+                        <a:rPr sz="1200" b="0">
                           <a:solidFill>
                             <a:srgbClr val="2C2C2C"/>
                           </a:solidFill>
-                          <a:latin typeface="Malgun Gothic"/>
-                          <a:ea typeface="Malgun Gothic"/>
+                          <a:latin typeface="Calibri"/>
                         </a:rPr>
-                        <a:t>Camk2g</a:t>
+                        <a:t>Chrm1  Grm8  Gpr26</a:t>
                       </a:r>
                     </a:p>
                   </a:txBody>
@@ -6039,14 +4675,13 @@
                     <a:lstStyle/>
                     <a:p>
                       <a:r>
-                        <a:rPr sz="1100" b="0">
+                        <a:rPr sz="1200" b="0">
                           <a:solidFill>
                             <a:srgbClr val="2C2C2C"/>
                           </a:solidFill>
-                          <a:latin typeface="Malgun Gothic"/>
-                          <a:ea typeface="Malgun Gothic"/>
+                          <a:latin typeface="Calibri"/>
                         </a:rPr>
-                        <a:t>가소성 Down 7클러스터</a:t>
+                        <a:t>ORB-enriched; missing from our 40-GPCR pull</a:t>
                       </a:r>
                     </a:p>
                   </a:txBody>
@@ -6062,14 +4697,105 @@
                     <a:lstStyle/>
                     <a:p>
                       <a:r>
-                        <a:rPr sz="1100" b="0">
+                        <a:rPr sz="1200" b="0">
                           <a:solidFill>
                             <a:srgbClr val="2C2C2C"/>
                           </a:solidFill>
-                          <a:latin typeface="Malgun Gothic"/>
-                          <a:ea typeface="Malgun Gothic"/>
+                          <a:latin typeface="Calibri"/>
                         </a:rPr>
-                        <a:t>93%  전 앵커 ≥50%</a:t>
+                        <a:t>Allen: 92% / 99% / 86%. High enough for Xenium.</a:t>
+                      </a:r>
+                    </a:p>
+                  </a:txBody>
+                  <a:tcPr>
+                    <a:solidFill>
+                      <a:srgbClr val="F4F1EA"/>
+                    </a:solidFill>
+                  </a:tcPr>
+                </a:tc>
+              </a:tr>
+              <a:tr h="657225">
+                <a:tc>
+                  <a:txBody>
+                    <a:bodyPr wrap="square"/>
+                    <a:lstStyle/>
+                    <a:p>
+                      <a:r>
+                        <a:rPr sz="1200" b="0">
+                          <a:solidFill>
+                            <a:srgbClr val="2C2C2C"/>
+                          </a:solidFill>
+                          <a:latin typeface="Calibri"/>
+                        </a:rPr>
+                        <a:t>Mas1  Gpr68  Mchr1</a:t>
+                      </a:r>
+                    </a:p>
+                  </a:txBody>
+                  <a:tcPr>
+                    <a:solidFill>
+                      <a:srgbClr val="FFFFFF"/>
+                    </a:solidFill>
+                  </a:tcPr>
+                </a:tc>
+                <a:tc>
+                  <a:txBody>
+                    <a:bodyPr wrap="square"/>
+                    <a:lstStyle/>
+                    <a:p>
+                      <a:r>
+                        <a:rPr sz="1200" b="0">
+                          <a:solidFill>
+                            <a:srgbClr val="2C2C2C"/>
+                          </a:solidFill>
+                          <a:latin typeface="Calibri"/>
+                        </a:rPr>
+                        <a:t>Jesse Glut ranks 1, 3, 4 (relative enrichment)</a:t>
+                      </a:r>
+                    </a:p>
+                  </a:txBody>
+                  <a:tcPr>
+                    <a:solidFill>
+                      <a:srgbClr val="FFFFFF"/>
+                    </a:solidFill>
+                  </a:tcPr>
+                </a:tc>
+                <a:tc>
+                  <a:txBody>
+                    <a:bodyPr wrap="square"/>
+                    <a:lstStyle/>
+                    <a:p>
+                      <a:r>
+                        <a:rPr sz="1200" b="0">
+                          <a:solidFill>
+                            <a:srgbClr val="2C2C2C"/>
+                          </a:solidFill>
+                          <a:latin typeface="Calibri"/>
+                        </a:rPr>
+                        <a:t>Allen absolute % is modest (45 / 40 / 32). Mchr1 too weak.</a:t>
+                      </a:r>
+                    </a:p>
+                  </a:txBody>
+                  <a:tcPr>
+                    <a:solidFill>
+                      <a:srgbClr val="FFFFFF"/>
+                    </a:solidFill>
+                  </a:tcPr>
+                </a:tc>
+              </a:tr>
+              <a:tr h="657225">
+                <a:tc>
+                  <a:txBody>
+                    <a:bodyPr wrap="square"/>
+                    <a:lstStyle/>
+                    <a:p>
+                      <a:r>
+                        <a:rPr sz="1200" b="0">
+                          <a:solidFill>
+                            <a:srgbClr val="2C2C2C"/>
+                          </a:solidFill>
+                          <a:latin typeface="Calibri"/>
+                        </a:rPr>
+                        <a:t>~160 TFs; Camk2g  Fxr1</a:t>
                       </a:r>
                     </a:p>
                   </a:txBody>
@@ -6085,14 +4811,35 @@
                     <a:lstStyle/>
                     <a:p>
                       <a:r>
-                        <a:rPr sz="1100" b="0">
+                        <a:rPr sz="1200" b="0">
                           <a:solidFill>
                             <a:srgbClr val="2C2C2C"/>
                           </a:solidFill>
-                          <a:latin typeface="Malgun Gothic"/>
-                          <a:ea typeface="Malgun Gothic"/>
+                          <a:latin typeface="Calibri"/>
                         </a:rPr>
-                        <a:t>Down을 읽을 때만</a:t>
+                        <a:t>Broad chromatin or plasticity DEGs</a:t>
+                      </a:r>
+                    </a:p>
+                  </a:txBody>
+                  <a:tcPr>
+                    <a:solidFill>
+                      <a:srgbClr val="F4F1EA"/>
+                    </a:solidFill>
+                  </a:tcPr>
+                </a:tc>
+                <a:tc>
+                  <a:txBody>
+                    <a:bodyPr wrap="square"/>
+                    <a:lstStyle/>
+                    <a:p>
+                      <a:r>
+                        <a:rPr sz="1200" b="0">
+                          <a:solidFill>
+                            <a:srgbClr val="2C2C2C"/>
+                          </a:solidFill>
+                          <a:latin typeface="Calibri"/>
+                        </a:rPr>
+                        <a:t>TFs skipped. Camk2g is abundant (93%) but not ORB-specific.</a:t>
                       </a:r>
                     </a:p>
                   </a:txBody>
@@ -6134,10 +4881,9 @@
                 <a:solidFill>
                   <a:srgbClr val="6B6B6B"/>
                 </a:solidFill>
-                <a:latin typeface="Malgun Gothic"/>
-                <a:ea typeface="Malgun Gothic"/>
+                <a:latin typeface="Calibri"/>
               </a:rPr>
-              <a:t>Xenium ORBm + BMAp  |  Dan GSE283418  ·  Jesse PL-ILA-ORB  ·  Allen WMB-10X  |  3/4</a:t>
+              <a:t>Xenium ORBm + BMAp add-on  |  Dan GSE283418  ·  Jesse PL-ILA-ORB  ·  Allen WMB-10X  |  2/3</a:t>
             </a:r>
           </a:p>
         </p:txBody>
@@ -6150,7 +4896,7 @@
 </p:sld>
 </file>
 
-<file path=ppt/slides/slide4.xml><?xml version="1.0" encoding="utf-8"?>
+<file path=ppt/slides/slide3.xml><?xml version="1.0" encoding="utf-8"?>
 <p:sld xmlns:a="http://schemas.openxmlformats.org/drawingml/2006/main" xmlns:p="http://schemas.openxmlformats.org/presentationml/2006/main" xmlns:r="http://schemas.openxmlformats.org/officeDocument/2006/relationships">
   <p:cSld>
     <p:spTree>
@@ -6212,7 +4958,7 @@
         <p:spPr>
           <a:xfrm>
             <a:off x="411480" y="201168"/>
-            <a:ext cx="11338560" cy="420624"/>
+            <a:ext cx="11338560" cy="402336"/>
           </a:xfrm>
           <a:prstGeom prst="rect">
             <a:avLst/>
@@ -6226,14 +4972,13 @@
           <a:lstStyle/>
           <a:p>
             <a:r>
-              <a:rPr sz="2400" b="1">
+              <a:rPr sz="2600" b="1">
                 <a:solidFill>
                   <a:srgbClr val="1D4E89"/>
                 </a:solidFill>
-                <a:latin typeface="Malgun Gothic"/>
-                <a:ea typeface="Malgun Gothic"/>
+                <a:latin typeface="Calibri"/>
               </a:rPr>
-              <a:t>권장 주문 — 이 리스트만 시트에 더한다</a:t>
+              <a:t>Final decision  |  genes added to the panel</a:t>
             </a:r>
           </a:p>
         </p:txBody>
@@ -6261,14 +5006,13 @@
           <a:lstStyle/>
           <a:p>
             <a:r>
-              <a:rPr sz="1300" b="0">
+              <a:rPr sz="1400" b="0">
                 <a:solidFill>
                   <a:srgbClr val="6B6B6B"/>
                 </a:solidFill>
-                <a:latin typeface="Malgun Gothic"/>
-                <a:ea typeface="Malgun Gothic"/>
+                <a:latin typeface="Calibri"/>
               </a:rPr>
-              <a:t>144 세포타입 + Dan 14는 그대로. 아래는 Jesse를 Allen으로 걸러 낸 추가분.</a:t>
+              <a:t>Cell-type 144 stays. Dan 14 are already on MSGS111. Below is the Jesse + Allen add.</a:t>
             </a:r>
           </a:p>
         </p:txBody>
@@ -6282,8 +5026,8 @@
           <p:nvPr/>
         </p:nvGraphicFramePr>
         <p:xfrm>
-          <a:off x="320040" y="960120"/>
-          <a:ext cx="11521440" cy="4709160"/>
+          <a:off x="320040" y="987552"/>
+          <a:ext cx="11521440" cy="4434840"/>
         </p:xfrm>
         <a:graphic>
           <a:graphicData uri="http://schemas.openxmlformats.org/drawingml/2006/table">
@@ -6292,27 +5036,25 @@
                 <a:tableStyleId>{5C22544A-7EE6-4342-B048-85BDC9FD1C3A}</a:tableStyleId>
               </a:tblPr>
               <a:tblGrid>
-                <a:gridCol w="731520"/>
-                <a:gridCol w="1280160"/>
-                <a:gridCol w="5760720"/>
-                <a:gridCol w="914400"/>
-                <a:gridCol w="2834640"/>
+                <a:gridCol w="2194560"/>
+                <a:gridCol w="3200400"/>
+                <a:gridCol w="5029200"/>
+                <a:gridCol w="1097280"/>
               </a:tblGrid>
-              <a:tr h="470916">
+              <a:tr h="633548">
                 <a:tc>
                   <a:txBody>
                     <a:bodyPr wrap="square"/>
                     <a:lstStyle/>
                     <a:p>
                       <a:r>
-                        <a:rPr sz="1100" b="1">
+                        <a:rPr sz="1300" b="1">
                           <a:solidFill>
                             <a:srgbClr val="FFFFFF"/>
                           </a:solidFill>
-                          <a:latin typeface="Malgun Gothic"/>
-                          <a:ea typeface="Malgun Gothic"/>
+                          <a:latin typeface="Calibri"/>
                         </a:rPr>
-                        <a:t>순위</a:t>
+                        <a:t>Decision</a:t>
                       </a:r>
                     </a:p>
                   </a:txBody>
@@ -6328,14 +5070,13 @@
                     <a:lstStyle/>
                     <a:p>
                       <a:r>
-                        <a:rPr sz="1100" b="1">
+                        <a:rPr sz="1300" b="1">
                           <a:solidFill>
                             <a:srgbClr val="FFFFFF"/>
                           </a:solidFill>
-                          <a:latin typeface="Malgun Gothic"/>
-                          <a:ea typeface="Malgun Gothic"/>
+                          <a:latin typeface="Calibri"/>
                         </a:rPr>
-                        <a:t>유전자</a:t>
+                        <a:t>Genes</a:t>
                       </a:r>
                     </a:p>
                   </a:txBody>
@@ -6351,14 +5092,13 @@
                     <a:lstStyle/>
                     <a:p>
                       <a:r>
-                        <a:rPr sz="1100" b="1">
+                        <a:rPr sz="1300" b="1">
                           <a:solidFill>
                             <a:srgbClr val="FFFFFF"/>
                           </a:solidFill>
-                          <a:latin typeface="Malgun Gothic"/>
-                          <a:ea typeface="Malgun Gothic"/>
+                          <a:latin typeface="Calibri"/>
                         </a:rPr>
-                        <a:t>근거</a:t>
+                        <a:t>Why this is the final add</a:t>
                       </a:r>
                     </a:p>
                   </a:txBody>
@@ -6374,37 +5114,13 @@
                     <a:lstStyle/>
                     <a:p>
                       <a:r>
-                        <a:rPr sz="1100" b="1">
+                        <a:rPr sz="1300" b="1">
                           <a:solidFill>
                             <a:srgbClr val="FFFFFF"/>
                           </a:solidFill>
-                          <a:latin typeface="Malgun Gothic"/>
-                          <a:ea typeface="Malgun Gothic"/>
+                          <a:latin typeface="Calibri"/>
                         </a:rPr>
-                        <a:t>슬롯</a:t>
-                      </a:r>
-                    </a:p>
-                  </a:txBody>
-                  <a:tcPr>
-                    <a:solidFill>
-                      <a:srgbClr val="1D4E89"/>
-                    </a:solidFill>
-                  </a:tcPr>
-                </a:tc>
-                <a:tc>
-                  <a:txBody>
-                    <a:bodyPr wrap="square"/>
-                    <a:lstStyle/>
-                    <a:p>
-                      <a:r>
-                        <a:rPr sz="1100" b="1">
-                          <a:solidFill>
-                            <a:srgbClr val="FFFFFF"/>
-                          </a:solidFill>
-                          <a:latin typeface="Malgun Gothic"/>
-                          <a:ea typeface="Malgun Gothic"/>
-                        </a:rPr>
-                        <a:t>시트</a:t>
+                        <a:t>Slots</a:t>
                       </a:r>
                     </a:p>
                   </a:txBody>
@@ -6415,21 +5131,20 @@
                   </a:tcPr>
                 </a:tc>
               </a:tr>
-              <a:tr h="470916">
+              <a:tr h="633548">
                 <a:tc>
                   <a:txBody>
                     <a:bodyPr wrap="square"/>
                     <a:lstStyle/>
                     <a:p>
                       <a:r>
-                        <a:rPr sz="1100" b="0">
+                        <a:rPr sz="1200" b="0">
                           <a:solidFill>
                             <a:srgbClr val="2C2C2C"/>
                           </a:solidFill>
-                          <a:latin typeface="Malgun Gothic"/>
-                          <a:ea typeface="Malgun Gothic"/>
+                          <a:latin typeface="Calibri"/>
                         </a:rPr>
-                        <a:t>0</a:t>
+                        <a:t>Already on the sheet</a:t>
                       </a:r>
                     </a:p>
                   </a:txBody>
@@ -6445,14 +5160,13 @@
                     <a:lstStyle/>
                     <a:p>
                       <a:r>
-                        <a:rPr sz="1100" b="0">
+                        <a:rPr sz="1200" b="0">
                           <a:solidFill>
                             <a:srgbClr val="2C2C2C"/>
                           </a:solidFill>
-                          <a:latin typeface="Malgun Gothic"/>
-                          <a:ea typeface="Malgun Gothic"/>
+                          <a:latin typeface="Calibri"/>
                         </a:rPr>
-                        <a:t>Rxfp1</a:t>
+                        <a:t>Dan 14   (Lamb3, Cck, Col23a1, …)</a:t>
                       </a:r>
                     </a:p>
                   </a:txBody>
@@ -6468,14 +5182,13 @@
                     <a:lstStyle/>
                     <a:p>
                       <a:r>
-                        <a:rPr sz="1100" b="0">
+                        <a:rPr sz="1200" b="0">
                           <a:solidFill>
                             <a:srgbClr val="2C2C2C"/>
                           </a:solidFill>
-                          <a:latin typeface="Malgun Gothic"/>
-                          <a:ea typeface="Malgun Gothic"/>
+                          <a:latin typeface="Calibri"/>
                         </a:rPr>
-                        <a:t>Jesse ORB GPCR 상위 + 베이스에 있음 + Allen 34%</a:t>
+                        <a:t>Amygdala spatial genes Dan uses; already ranks 145–158</a:t>
                       </a:r>
                     </a:p>
                   </a:txBody>
@@ -6491,14 +5204,127 @@
                     <a:lstStyle/>
                     <a:p>
                       <a:r>
-                        <a:rPr sz="1100" b="0">
+                        <a:rPr sz="1200" b="0">
                           <a:solidFill>
                             <a:srgbClr val="2C2C2C"/>
                           </a:solidFill>
-                          <a:latin typeface="Malgun Gothic"/>
-                          <a:ea typeface="Malgun Gothic"/>
+                          <a:latin typeface="Calibri"/>
+                        </a:rPr>
+                        <a:t>14 (done)</a:t>
+                      </a:r>
+                    </a:p>
+                  </a:txBody>
+                  <a:tcPr>
+                    <a:solidFill>
+                      <a:srgbClr val="F4F1EA"/>
+                    </a:solidFill>
+                  </a:tcPr>
+                </a:tc>
+              </a:tr>
+              <a:tr h="633548">
+                <a:tc>
+                  <a:txBody>
+                    <a:bodyPr wrap="square"/>
+                    <a:lstStyle/>
+                    <a:p>
+                      <a:r>
+                        <a:rPr sz="1200" b="0">
+                          <a:solidFill>
+                            <a:srgbClr val="2C2C2C"/>
+                          </a:solidFill>
+                          <a:latin typeface="Calibri"/>
+                        </a:rPr>
+                        <a:t>ADD  (free)</a:t>
+                      </a:r>
+                    </a:p>
+                  </a:txBody>
+                  <a:tcPr>
+                    <a:solidFill>
+                      <a:srgbClr val="FFFFFF"/>
+                    </a:solidFill>
+                  </a:tcPr>
+                </a:tc>
+                <a:tc>
+                  <a:txBody>
+                    <a:bodyPr wrap="square"/>
+                    <a:lstStyle/>
+                    <a:p>
+                      <a:r>
+                        <a:rPr sz="1200" b="0">
+                          <a:solidFill>
+                            <a:srgbClr val="2C2C2C"/>
+                          </a:solidFill>
+                          <a:latin typeface="Calibri"/>
+                        </a:rPr>
+                        <a:t>Rxfp1</a:t>
+                      </a:r>
+                    </a:p>
+                  </a:txBody>
+                  <a:tcPr>
+                    <a:solidFill>
+                      <a:srgbClr val="FFFFFF"/>
+                    </a:solidFill>
+                  </a:tcPr>
+                </a:tc>
+                <a:tc>
+                  <a:txBody>
+                    <a:bodyPr wrap="square"/>
+                    <a:lstStyle/>
+                    <a:p>
+                      <a:r>
+                        <a:rPr sz="1200" b="0">
+                          <a:solidFill>
+                            <a:srgbClr val="2C2C2C"/>
+                          </a:solidFill>
+                          <a:latin typeface="Calibri"/>
+                        </a:rPr>
+                        <a:t>Jesse’s top ORB GPCR; already on the Xenium base panel</a:t>
+                      </a:r>
+                    </a:p>
+                  </a:txBody>
+                  <a:tcPr>
+                    <a:solidFill>
+                      <a:srgbClr val="FFFFFF"/>
+                    </a:solidFill>
+                  </a:tcPr>
+                </a:tc>
+                <a:tc>
+                  <a:txBody>
+                    <a:bodyPr wrap="square"/>
+                    <a:lstStyle/>
+                    <a:p>
+                      <a:r>
+                        <a:rPr sz="1200" b="0">
+                          <a:solidFill>
+                            <a:srgbClr val="2C2C2C"/>
+                          </a:solidFill>
+                          <a:latin typeface="Calibri"/>
                         </a:rPr>
                         <a:t>0</a:t>
+                      </a:r>
+                    </a:p>
+                  </a:txBody>
+                  <a:tcPr>
+                    <a:solidFill>
+                      <a:srgbClr val="FFFFFF"/>
+                    </a:solidFill>
+                  </a:tcPr>
+                </a:tc>
+              </a:tr>
+              <a:tr h="633548">
+                <a:tc>
+                  <a:txBody>
+                    <a:bodyPr wrap="square"/>
+                    <a:lstStyle/>
+                    <a:p>
+                      <a:r>
+                        <a:rPr sz="1200" b="0">
+                          <a:solidFill>
+                            <a:srgbClr val="2C2C2C"/>
+                          </a:solidFill>
+                          <a:latin typeface="Calibri"/>
+                        </a:rPr>
+                        <a:t>ADD</a:t>
                       </a:r>
                     </a:p>
                   </a:txBody>
@@ -6514,14 +5340,57 @@
                     <a:lstStyle/>
                     <a:p>
                       <a:r>
-                        <a:rPr sz="1100" b="0">
+                        <a:rPr sz="1200" b="0">
                           <a:solidFill>
                             <a:srgbClr val="2C2C2C"/>
                           </a:solidFill>
-                          <a:latin typeface="Malgun Gothic"/>
-                          <a:ea typeface="Malgun Gothic"/>
+                          <a:latin typeface="Calibri"/>
                         </a:rPr>
-                        <a:t>지금 올려라</a:t>
+                        <a:t>Per2    Pcsk1    Per1</a:t>
+                      </a:r>
+                    </a:p>
+                  </a:txBody>
+                  <a:tcPr>
+                    <a:solidFill>
+                      <a:srgbClr val="F4F1EA"/>
+                    </a:solidFill>
+                  </a:tcPr>
+                </a:tc>
+                <a:tc>
+                  <a:txBody>
+                    <a:bodyPr wrap="square"/>
+                    <a:lstStyle/>
+                    <a:p>
+                      <a:r>
+                        <a:rPr sz="1200" b="0">
+                          <a:solidFill>
+                            <a:srgbClr val="2C2C2C"/>
+                          </a:solidFill>
+                          <a:latin typeface="Calibri"/>
+                        </a:rPr>
+                        <a:t>Jesse’s morphine-state IEG program. Per1 is 63% in Allen ORBm.</a:t>
+                      </a:r>
+                    </a:p>
+                  </a:txBody>
+                  <a:tcPr>
+                    <a:solidFill>
+                      <a:srgbClr val="F4F1EA"/>
+                    </a:solidFill>
+                  </a:tcPr>
+                </a:tc>
+                <a:tc>
+                  <a:txBody>
+                    <a:bodyPr wrap="square"/>
+                    <a:lstStyle/>
+                    <a:p>
+                      <a:r>
+                        <a:rPr sz="1200" b="0">
+                          <a:solidFill>
+                            <a:srgbClr val="2C2C2C"/>
+                          </a:solidFill>
+                          <a:latin typeface="Calibri"/>
+                        </a:rPr>
+                        <a:t>3</a:t>
                       </a:r>
                     </a:p>
                   </a:txBody>
@@ -6532,21 +5401,20 @@
                   </a:tcPr>
                 </a:tc>
               </a:tr>
-              <a:tr h="470916">
+              <a:tr h="633548">
                 <a:tc>
                   <a:txBody>
                     <a:bodyPr wrap="square"/>
                     <a:lstStyle/>
                     <a:p>
                       <a:r>
-                        <a:rPr sz="1100" b="0">
+                        <a:rPr sz="1200" b="0">
                           <a:solidFill>
                             <a:srgbClr val="2C2C2C"/>
                           </a:solidFill>
-                          <a:latin typeface="Malgun Gothic"/>
-                          <a:ea typeface="Malgun Gothic"/>
+                          <a:latin typeface="Calibri"/>
                         </a:rPr>
-                        <a:t>1</a:t>
+                        <a:t>ADD</a:t>
                       </a:r>
                     </a:p>
                   </a:txBody>
@@ -6562,14 +5430,13 @@
                     <a:lstStyle/>
                     <a:p>
                       <a:r>
-                        <a:rPr sz="1100" b="0">
+                        <a:rPr sz="1200" b="0">
                           <a:solidFill>
                             <a:srgbClr val="2C2C2C"/>
                           </a:solidFill>
-                          <a:latin typeface="Malgun Gothic"/>
-                          <a:ea typeface="Malgun Gothic"/>
+                          <a:latin typeface="Calibri"/>
                         </a:rPr>
-                        <a:t>Per2</a:t>
+                        <a:t>Chrm1    Grm8</a:t>
                       </a:r>
                     </a:p>
                   </a:txBody>
@@ -6585,14 +5452,13 @@
                     <a:lstStyle/>
                     <a:p>
                       <a:r>
-                        <a:rPr sz="1100" b="0">
+                        <a:rPr sz="1200" b="0">
                           <a:solidFill>
                             <a:srgbClr val="2C2C2C"/>
                           </a:solidFill>
-                          <a:latin typeface="Malgun Gothic"/>
-                          <a:ea typeface="Malgun Gothic"/>
+                          <a:latin typeface="Calibri"/>
                         </a:rPr>
-                        <a:t>Jesse 최광역 IEG (13 클러스터). Fos보다 넓다</a:t>
+                        <a:t>ORB-enriched in Jesse; highest Allen abundance (92%, 99%)</a:t>
                       </a:r>
                     </a:p>
                   </a:txBody>
@@ -6608,14 +5474,127 @@
                     <a:lstStyle/>
                     <a:p>
                       <a:r>
-                        <a:rPr sz="1100" b="0">
+                        <a:rPr sz="1200" b="0">
                           <a:solidFill>
                             <a:srgbClr val="2C2C2C"/>
                           </a:solidFill>
-                          <a:latin typeface="Malgun Gothic"/>
-                          <a:ea typeface="Malgun Gothic"/>
+                          <a:latin typeface="Calibri"/>
                         </a:rPr>
-                        <a:t>1</a:t>
+                        <a:t>2</a:t>
+                      </a:r>
+                    </a:p>
+                  </a:txBody>
+                  <a:tcPr>
+                    <a:solidFill>
+                      <a:srgbClr val="FFFFFF"/>
+                    </a:solidFill>
+                  </a:tcPr>
+                </a:tc>
+              </a:tr>
+              <a:tr h="633548">
+                <a:tc>
+                  <a:txBody>
+                    <a:bodyPr wrap="square"/>
+                    <a:lstStyle/>
+                    <a:p>
+                      <a:r>
+                        <a:rPr sz="1200" b="0">
+                          <a:solidFill>
+                            <a:srgbClr val="2C2C2C"/>
+                          </a:solidFill>
+                          <a:latin typeface="Calibri"/>
+                        </a:rPr>
+                        <a:t>Not added</a:t>
+                      </a:r>
+                    </a:p>
+                  </a:txBody>
+                  <a:tcPr>
+                    <a:solidFill>
+                      <a:srgbClr val="F4F1EA"/>
+                    </a:solidFill>
+                  </a:tcPr>
+                </a:tc>
+                <a:tc>
+                  <a:txBody>
+                    <a:bodyPr wrap="square"/>
+                    <a:lstStyle/>
+                    <a:p>
+                      <a:r>
+                        <a:rPr sz="1200" b="0">
+                          <a:solidFill>
+                            <a:srgbClr val="2C2C2C"/>
+                          </a:solidFill>
+                          <a:latin typeface="Calibri"/>
+                        </a:rPr>
+                        <a:t>Mas1   Gpr68   Mchr1</a:t>
+                      </a:r>
+                    </a:p>
+                  </a:txBody>
+                  <a:tcPr>
+                    <a:solidFill>
+                      <a:srgbClr val="F4F1EA"/>
+                    </a:solidFill>
+                  </a:tcPr>
+                </a:tc>
+                <a:tc>
+                  <a:txBody>
+                    <a:bodyPr wrap="square"/>
+                    <a:lstStyle/>
+                    <a:p>
+                      <a:r>
+                        <a:rPr sz="1200" b="0">
+                          <a:solidFill>
+                            <a:srgbClr val="2C2C2C"/>
+                          </a:solidFill>
+                          <a:latin typeface="Calibri"/>
+                        </a:rPr>
+                        <a:t>Relative ORB hits, but Allen % is too low vs Chrm1/Grm8</a:t>
+                      </a:r>
+                    </a:p>
+                  </a:txBody>
+                  <a:tcPr>
+                    <a:solidFill>
+                      <a:srgbClr val="F4F1EA"/>
+                    </a:solidFill>
+                  </a:tcPr>
+                </a:tc>
+                <a:tc>
+                  <a:txBody>
+                    <a:bodyPr wrap="square"/>
+                    <a:lstStyle/>
+                    <a:p>
+                      <a:r>
+                        <a:rPr sz="1200" b="0">
+                          <a:solidFill>
+                            <a:srgbClr val="2C2C2C"/>
+                          </a:solidFill>
+                          <a:latin typeface="Calibri"/>
+                        </a:rPr>
+                        <a:t>—</a:t>
+                      </a:r>
+                    </a:p>
+                  </a:txBody>
+                  <a:tcPr>
+                    <a:solidFill>
+                      <a:srgbClr val="F4F1EA"/>
+                    </a:solidFill>
+                  </a:tcPr>
+                </a:tc>
+              </a:tr>
+              <a:tr h="633552">
+                <a:tc>
+                  <a:txBody>
+                    <a:bodyPr wrap="square"/>
+                    <a:lstStyle/>
+                    <a:p>
+                      <a:r>
+                        <a:rPr sz="1200" b="0">
+                          <a:solidFill>
+                            <a:srgbClr val="2C2C2C"/>
+                          </a:solidFill>
+                          <a:latin typeface="Calibri"/>
+                        </a:rPr>
+                        <a:t>Not added</a:t>
                       </a:r>
                     </a:p>
                   </a:txBody>
@@ -6631,156 +5610,13 @@
                     <a:lstStyle/>
                     <a:p>
                       <a:r>
-                        <a:rPr sz="1100" b="0">
+                        <a:rPr sz="1200" b="0">
                           <a:solidFill>
                             <a:srgbClr val="2C2C2C"/>
                           </a:solidFill>
-                          <a:latin typeface="Malgun Gothic"/>
-                          <a:ea typeface="Malgun Gothic"/>
+                          <a:latin typeface="Calibri"/>
                         </a:rPr>
-                        <a:t>지금</a:t>
-                      </a:r>
-                    </a:p>
-                  </a:txBody>
-                  <a:tcPr>
-                    <a:solidFill>
-                      <a:srgbClr val="FFFFFF"/>
-                    </a:solidFill>
-                  </a:tcPr>
-                </a:tc>
-              </a:tr>
-              <a:tr h="470916">
-                <a:tc>
-                  <a:txBody>
-                    <a:bodyPr wrap="square"/>
-                    <a:lstStyle/>
-                    <a:p>
-                      <a:r>
-                        <a:rPr sz="1100" b="0">
-                          <a:solidFill>
-                            <a:srgbClr val="2C2C2C"/>
-                          </a:solidFill>
-                          <a:latin typeface="Malgun Gothic"/>
-                          <a:ea typeface="Malgun Gothic"/>
-                        </a:rPr>
-                        <a:t>2</a:t>
-                      </a:r>
-                    </a:p>
-                  </a:txBody>
-                  <a:tcPr>
-                    <a:solidFill>
-                      <a:srgbClr val="F4F1EA"/>
-                    </a:solidFill>
-                  </a:tcPr>
-                </a:tc>
-                <a:tc>
-                  <a:txBody>
-                    <a:bodyPr wrap="square"/>
-                    <a:lstStyle/>
-                    <a:p>
-                      <a:r>
-                        <a:rPr sz="1100" b="0">
-                          <a:solidFill>
-                            <a:srgbClr val="2C2C2C"/>
-                          </a:solidFill>
-                          <a:latin typeface="Malgun Gothic"/>
-                          <a:ea typeface="Malgun Gothic"/>
-                        </a:rPr>
-                        <a:t>Pcsk1</a:t>
-                      </a:r>
-                    </a:p>
-                  </a:txBody>
-                  <a:tcPr>
-                    <a:solidFill>
-                      <a:srgbClr val="F4F1EA"/>
-                    </a:solidFill>
-                  </a:tcPr>
-                </a:tc>
-                <a:tc>
-                  <a:txBody>
-                    <a:bodyPr wrap="square"/>
-                    <a:lstStyle/>
-                    <a:p>
-                      <a:r>
-                        <a:rPr sz="1100" b="0">
-                          <a:solidFill>
-                            <a:srgbClr val="2C2C2C"/>
-                          </a:solidFill>
-                          <a:latin typeface="Malgun Gothic"/>
-                          <a:ea typeface="Malgun Gothic"/>
-                        </a:rPr>
-                        <a:t>두 번째 광역 IEG. 펩타이드 가공</a:t>
-                      </a:r>
-                    </a:p>
-                  </a:txBody>
-                  <a:tcPr>
-                    <a:solidFill>
-                      <a:srgbClr val="F4F1EA"/>
-                    </a:solidFill>
-                  </a:tcPr>
-                </a:tc>
-                <a:tc>
-                  <a:txBody>
-                    <a:bodyPr wrap="square"/>
-                    <a:lstStyle/>
-                    <a:p>
-                      <a:r>
-                        <a:rPr sz="1100" b="0">
-                          <a:solidFill>
-                            <a:srgbClr val="2C2C2C"/>
-                          </a:solidFill>
-                          <a:latin typeface="Malgun Gothic"/>
-                          <a:ea typeface="Malgun Gothic"/>
-                        </a:rPr>
-                        <a:t>1</a:t>
-                      </a:r>
-                    </a:p>
-                  </a:txBody>
-                  <a:tcPr>
-                    <a:solidFill>
-                      <a:srgbClr val="F4F1EA"/>
-                    </a:solidFill>
-                  </a:tcPr>
-                </a:tc>
-                <a:tc>
-                  <a:txBody>
-                    <a:bodyPr wrap="square"/>
-                    <a:lstStyle/>
-                    <a:p>
-                      <a:r>
-                        <a:rPr sz="1100" b="0">
-                          <a:solidFill>
-                            <a:srgbClr val="2C2C2C"/>
-                          </a:solidFill>
-                          <a:latin typeface="Malgun Gothic"/>
-                          <a:ea typeface="Malgun Gothic"/>
-                        </a:rPr>
-                        <a:t>지금</a:t>
-                      </a:r>
-                    </a:p>
-                  </a:txBody>
-                  <a:tcPr>
-                    <a:solidFill>
-                      <a:srgbClr val="F4F1EA"/>
-                    </a:solidFill>
-                  </a:tcPr>
-                </a:tc>
-              </a:tr>
-              <a:tr h="470916">
-                <a:tc>
-                  <a:txBody>
-                    <a:bodyPr wrap="square"/>
-                    <a:lstStyle/>
-                    <a:p>
-                      <a:r>
-                        <a:rPr sz="1100" b="0">
-                          <a:solidFill>
-                            <a:srgbClr val="2C2C2C"/>
-                          </a:solidFill>
-                          <a:latin typeface="Malgun Gothic"/>
-                          <a:ea typeface="Malgun Gothic"/>
-                        </a:rPr>
-                        <a:t>3</a:t>
+                        <a:t>160 TFs   Fxr1   Vps13a</a:t>
                       </a:r>
                     </a:p>
                   </a:txBody>
@@ -6796,14 +5632,13 @@
                     <a:lstStyle/>
                     <a:p>
                       <a:r>
-                        <a:rPr sz="1100" b="0">
+                        <a:rPr sz="1200" b="0">
                           <a:solidFill>
                             <a:srgbClr val="2C2C2C"/>
                           </a:solidFill>
-                          <a:latin typeface="Malgun Gothic"/>
-                          <a:ea typeface="Malgun Gothic"/>
+                          <a:latin typeface="Calibri"/>
                         </a:rPr>
-                        <a:t>Per1</a:t>
+                        <a:t>Not cell-type or ORB-specific. Fos/Arc already cover activity.</a:t>
                       </a:r>
                     </a:p>
                   </a:txBody>
@@ -6819,60 +5654,13 @@
                     <a:lstStyle/>
                     <a:p>
                       <a:r>
-                        <a:rPr sz="1100" b="0">
+                        <a:rPr sz="1200" b="0">
                           <a:solidFill>
                             <a:srgbClr val="2C2C2C"/>
                           </a:solidFill>
-                          <a:latin typeface="Malgun Gothic"/>
-                          <a:ea typeface="Malgun Gothic"/>
+                          <a:latin typeface="Calibri"/>
                         </a:rPr>
-                        <a:t>시계 짝. Allen 63%</a:t>
-                      </a:r>
-                    </a:p>
-                  </a:txBody>
-                  <a:tcPr>
-                    <a:solidFill>
-                      <a:srgbClr val="FFFFFF"/>
-                    </a:solidFill>
-                  </a:tcPr>
-                </a:tc>
-                <a:tc>
-                  <a:txBody>
-                    <a:bodyPr wrap="square"/>
-                    <a:lstStyle/>
-                    <a:p>
-                      <a:r>
-                        <a:rPr sz="1100" b="0">
-                          <a:solidFill>
-                            <a:srgbClr val="2C2C2C"/>
-                          </a:solidFill>
-                          <a:latin typeface="Malgun Gothic"/>
-                          <a:ea typeface="Malgun Gothic"/>
-                        </a:rPr>
-                        <a:t>1</a:t>
-                      </a:r>
-                    </a:p>
-                  </a:txBody>
-                  <a:tcPr>
-                    <a:solidFill>
-                      <a:srgbClr val="FFFFFF"/>
-                    </a:solidFill>
-                  </a:tcPr>
-                </a:tc>
-                <a:tc>
-                  <a:txBody>
-                    <a:bodyPr wrap="square"/>
-                    <a:lstStyle/>
-                    <a:p>
-                      <a:r>
-                        <a:rPr sz="1100" b="0">
-                          <a:solidFill>
-                            <a:srgbClr val="2C2C2C"/>
-                          </a:solidFill>
-                          <a:latin typeface="Malgun Gothic"/>
-                          <a:ea typeface="Malgun Gothic"/>
-                        </a:rPr>
-                        <a:t>지금</a:t>
+                        <a:t>—</a:t>
                       </a:r>
                     </a:p>
                   </a:txBody>
@@ -6883,591 +5671,6 @@
                   </a:tcPr>
                 </a:tc>
               </a:tr>
-              <a:tr h="470916">
-                <a:tc>
-                  <a:txBody>
-                    <a:bodyPr wrap="square"/>
-                    <a:lstStyle/>
-                    <a:p>
-                      <a:r>
-                        <a:rPr sz="1100" b="0">
-                          <a:solidFill>
-                            <a:srgbClr val="2C2C2C"/>
-                          </a:solidFill>
-                          <a:latin typeface="Malgun Gothic"/>
-                          <a:ea typeface="Malgun Gothic"/>
-                        </a:rPr>
-                        <a:t>4</a:t>
-                      </a:r>
-                    </a:p>
-                  </a:txBody>
-                  <a:tcPr>
-                    <a:solidFill>
-                      <a:srgbClr val="F4F1EA"/>
-                    </a:solidFill>
-                  </a:tcPr>
-                </a:tc>
-                <a:tc>
-                  <a:txBody>
-                    <a:bodyPr wrap="square"/>
-                    <a:lstStyle/>
-                    <a:p>
-                      <a:r>
-                        <a:rPr sz="1100" b="0">
-                          <a:solidFill>
-                            <a:srgbClr val="2C2C2C"/>
-                          </a:solidFill>
-                          <a:latin typeface="Malgun Gothic"/>
-                          <a:ea typeface="Malgun Gothic"/>
-                        </a:rPr>
-                        <a:t>Chrm1</a:t>
-                      </a:r>
-                    </a:p>
-                  </a:txBody>
-                  <a:tcPr>
-                    <a:solidFill>
-                      <a:srgbClr val="F4F1EA"/>
-                    </a:solidFill>
-                  </a:tcPr>
-                </a:tc>
-                <a:tc>
-                  <a:txBody>
-                    <a:bodyPr wrap="square"/>
-                    <a:lstStyle/>
-                    <a:p>
-                      <a:r>
-                        <a:rPr sz="1100" b="0">
-                          <a:solidFill>
-                            <a:srgbClr val="2C2C2C"/>
-                          </a:solidFill>
-                          <a:latin typeface="Malgun Gothic"/>
-                          <a:ea typeface="Malgun Gothic"/>
-                        </a:rPr>
-                        <a:t>Allen 92%. Jesse ORB 농축. Chrm2는 이미 있음</a:t>
-                      </a:r>
-                    </a:p>
-                  </a:txBody>
-                  <a:tcPr>
-                    <a:solidFill>
-                      <a:srgbClr val="F4F1EA"/>
-                    </a:solidFill>
-                  </a:tcPr>
-                </a:tc>
-                <a:tc>
-                  <a:txBody>
-                    <a:bodyPr wrap="square"/>
-                    <a:lstStyle/>
-                    <a:p>
-                      <a:r>
-                        <a:rPr sz="1100" b="0">
-                          <a:solidFill>
-                            <a:srgbClr val="2C2C2C"/>
-                          </a:solidFill>
-                          <a:latin typeface="Malgun Gothic"/>
-                          <a:ea typeface="Malgun Gothic"/>
-                        </a:rPr>
-                        <a:t>1</a:t>
-                      </a:r>
-                    </a:p>
-                  </a:txBody>
-                  <a:tcPr>
-                    <a:solidFill>
-                      <a:srgbClr val="F4F1EA"/>
-                    </a:solidFill>
-                  </a:tcPr>
-                </a:tc>
-                <a:tc>
-                  <a:txBody>
-                    <a:bodyPr wrap="square"/>
-                    <a:lstStyle/>
-                    <a:p>
-                      <a:r>
-                        <a:rPr sz="1100" b="0">
-                          <a:solidFill>
-                            <a:srgbClr val="2C2C2C"/>
-                          </a:solidFill>
-                          <a:latin typeface="Malgun Gothic"/>
-                          <a:ea typeface="Malgun Gothic"/>
-                        </a:rPr>
-                        <a:t>지금</a:t>
-                      </a:r>
-                    </a:p>
-                  </a:txBody>
-                  <a:tcPr>
-                    <a:solidFill>
-                      <a:srgbClr val="F4F1EA"/>
-                    </a:solidFill>
-                  </a:tcPr>
-                </a:tc>
-              </a:tr>
-              <a:tr h="470916">
-                <a:tc>
-                  <a:txBody>
-                    <a:bodyPr wrap="square"/>
-                    <a:lstStyle/>
-                    <a:p>
-                      <a:r>
-                        <a:rPr sz="1100" b="0">
-                          <a:solidFill>
-                            <a:srgbClr val="2C2C2C"/>
-                          </a:solidFill>
-                          <a:latin typeface="Malgun Gothic"/>
-                          <a:ea typeface="Malgun Gothic"/>
-                        </a:rPr>
-                        <a:t>5</a:t>
-                      </a:r>
-                    </a:p>
-                  </a:txBody>
-                  <a:tcPr>
-                    <a:solidFill>
-                      <a:srgbClr val="FFFFFF"/>
-                    </a:solidFill>
-                  </a:tcPr>
-                </a:tc>
-                <a:tc>
-                  <a:txBody>
-                    <a:bodyPr wrap="square"/>
-                    <a:lstStyle/>
-                    <a:p>
-                      <a:r>
-                        <a:rPr sz="1100" b="0">
-                          <a:solidFill>
-                            <a:srgbClr val="2C2C2C"/>
-                          </a:solidFill>
-                          <a:latin typeface="Malgun Gothic"/>
-                          <a:ea typeface="Malgun Gothic"/>
-                        </a:rPr>
-                        <a:t>Grm8</a:t>
-                      </a:r>
-                    </a:p>
-                  </a:txBody>
-                  <a:tcPr>
-                    <a:solidFill>
-                      <a:srgbClr val="FFFFFF"/>
-                    </a:solidFill>
-                  </a:tcPr>
-                </a:tc>
-                <a:tc>
-                  <a:txBody>
-                    <a:bodyPr wrap="square"/>
-                    <a:lstStyle/>
-                    <a:p>
-                      <a:r>
-                        <a:rPr sz="1100" b="0">
-                          <a:solidFill>
-                            <a:srgbClr val="2C2C2C"/>
-                          </a:solidFill>
-                          <a:latin typeface="Malgun Gothic"/>
-                          <a:ea typeface="Malgun Gothic"/>
-                        </a:rPr>
-                        <a:t>Allen 99%. Jesse ORB 농축. Grm5는 이미 있음</a:t>
-                      </a:r>
-                    </a:p>
-                  </a:txBody>
-                  <a:tcPr>
-                    <a:solidFill>
-                      <a:srgbClr val="FFFFFF"/>
-                    </a:solidFill>
-                  </a:tcPr>
-                </a:tc>
-                <a:tc>
-                  <a:txBody>
-                    <a:bodyPr wrap="square"/>
-                    <a:lstStyle/>
-                    <a:p>
-                      <a:r>
-                        <a:rPr sz="1100" b="0">
-                          <a:solidFill>
-                            <a:srgbClr val="2C2C2C"/>
-                          </a:solidFill>
-                          <a:latin typeface="Malgun Gothic"/>
-                          <a:ea typeface="Malgun Gothic"/>
-                        </a:rPr>
-                        <a:t>1</a:t>
-                      </a:r>
-                    </a:p>
-                  </a:txBody>
-                  <a:tcPr>
-                    <a:solidFill>
-                      <a:srgbClr val="FFFFFF"/>
-                    </a:solidFill>
-                  </a:tcPr>
-                </a:tc>
-                <a:tc>
-                  <a:txBody>
-                    <a:bodyPr wrap="square"/>
-                    <a:lstStyle/>
-                    <a:p>
-                      <a:r>
-                        <a:rPr sz="1100" b="0">
-                          <a:solidFill>
-                            <a:srgbClr val="2C2C2C"/>
-                          </a:solidFill>
-                          <a:latin typeface="Malgun Gothic"/>
-                          <a:ea typeface="Malgun Gothic"/>
-                        </a:rPr>
-                        <a:t>지금</a:t>
-                      </a:r>
-                    </a:p>
-                  </a:txBody>
-                  <a:tcPr>
-                    <a:solidFill>
-                      <a:srgbClr val="FFFFFF"/>
-                    </a:solidFill>
-                  </a:tcPr>
-                </a:tc>
-              </a:tr>
-              <a:tr h="470916">
-                <a:tc>
-                  <a:txBody>
-                    <a:bodyPr wrap="square"/>
-                    <a:lstStyle/>
-                    <a:p>
-                      <a:r>
-                        <a:rPr sz="1100" b="0">
-                          <a:solidFill>
-                            <a:srgbClr val="2C2C2C"/>
-                          </a:solidFill>
-                          <a:latin typeface="Malgun Gothic"/>
-                          <a:ea typeface="Malgun Gothic"/>
-                        </a:rPr>
-                        <a:t>6</a:t>
-                      </a:r>
-                    </a:p>
-                  </a:txBody>
-                  <a:tcPr>
-                    <a:solidFill>
-                      <a:srgbClr val="F4F1EA"/>
-                    </a:solidFill>
-                  </a:tcPr>
-                </a:tc>
-                <a:tc>
-                  <a:txBody>
-                    <a:bodyPr wrap="square"/>
-                    <a:lstStyle/>
-                    <a:p>
-                      <a:r>
-                        <a:rPr sz="1100" b="0">
-                          <a:solidFill>
-                            <a:srgbClr val="2C2C2C"/>
-                          </a:solidFill>
-                          <a:latin typeface="Malgun Gothic"/>
-                          <a:ea typeface="Malgun Gothic"/>
-                        </a:rPr>
-                        <a:t>Gpr26</a:t>
-                      </a:r>
-                    </a:p>
-                  </a:txBody>
-                  <a:tcPr>
-                    <a:solidFill>
-                      <a:srgbClr val="F4F1EA"/>
-                    </a:solidFill>
-                  </a:tcPr>
-                </a:tc>
-                <a:tc>
-                  <a:txBody>
-                    <a:bodyPr wrap="square"/>
-                    <a:lstStyle/>
-                    <a:p>
-                      <a:r>
-                        <a:rPr sz="1100" b="0">
-                          <a:solidFill>
-                            <a:srgbClr val="2C2C2C"/>
-                          </a:solidFill>
-                          <a:latin typeface="Malgun Gothic"/>
-                          <a:ea typeface="Malgun Gothic"/>
-                        </a:rPr>
-                        <a:t>Allen 86% IT</a:t>
-                      </a:r>
-                    </a:p>
-                  </a:txBody>
-                  <a:tcPr>
-                    <a:solidFill>
-                      <a:srgbClr val="F4F1EA"/>
-                    </a:solidFill>
-                  </a:tcPr>
-                </a:tc>
-                <a:tc>
-                  <a:txBody>
-                    <a:bodyPr wrap="square"/>
-                    <a:lstStyle/>
-                    <a:p>
-                      <a:r>
-                        <a:rPr sz="1100" b="0">
-                          <a:solidFill>
-                            <a:srgbClr val="2C2C2C"/>
-                          </a:solidFill>
-                          <a:latin typeface="Malgun Gothic"/>
-                          <a:ea typeface="Malgun Gothic"/>
-                        </a:rPr>
-                        <a:t>1</a:t>
-                      </a:r>
-                    </a:p>
-                  </a:txBody>
-                  <a:tcPr>
-                    <a:solidFill>
-                      <a:srgbClr val="F4F1EA"/>
-                    </a:solidFill>
-                  </a:tcPr>
-                </a:tc>
-                <a:tc>
-                  <a:txBody>
-                    <a:bodyPr wrap="square"/>
-                    <a:lstStyle/>
-                    <a:p>
-                      <a:r>
-                        <a:rPr sz="1100" b="0">
-                          <a:solidFill>
-                            <a:srgbClr val="2C2C2C"/>
-                          </a:solidFill>
-                          <a:latin typeface="Malgun Gothic"/>
-                          <a:ea typeface="Malgun Gothic"/>
-                        </a:rPr>
-                        <a:t>여유 시</a:t>
-                      </a:r>
-                    </a:p>
-                  </a:txBody>
-                  <a:tcPr>
-                    <a:solidFill>
-                      <a:srgbClr val="F4F1EA"/>
-                    </a:solidFill>
-                  </a:tcPr>
-                </a:tc>
-              </a:tr>
-              <a:tr h="470916">
-                <a:tc>
-                  <a:txBody>
-                    <a:bodyPr wrap="square"/>
-                    <a:lstStyle/>
-                    <a:p>
-                      <a:r>
-                        <a:rPr sz="1100" b="0">
-                          <a:solidFill>
-                            <a:srgbClr val="2C2C2C"/>
-                          </a:solidFill>
-                          <a:latin typeface="Malgun Gothic"/>
-                          <a:ea typeface="Malgun Gothic"/>
-                        </a:rPr>
-                        <a:t>7</a:t>
-                      </a:r>
-                    </a:p>
-                  </a:txBody>
-                  <a:tcPr>
-                    <a:solidFill>
-                      <a:srgbClr val="FFFFFF"/>
-                    </a:solidFill>
-                  </a:tcPr>
-                </a:tc>
-                <a:tc>
-                  <a:txBody>
-                    <a:bodyPr wrap="square"/>
-                    <a:lstStyle/>
-                    <a:p>
-                      <a:r>
-                        <a:rPr sz="1100" b="0">
-                          <a:solidFill>
-                            <a:srgbClr val="2C2C2C"/>
-                          </a:solidFill>
-                          <a:latin typeface="Malgun Gothic"/>
-                          <a:ea typeface="Malgun Gothic"/>
-                        </a:rPr>
-                        <a:t>Mas1</a:t>
-                      </a:r>
-                    </a:p>
-                  </a:txBody>
-                  <a:tcPr>
-                    <a:solidFill>
-                      <a:srgbClr val="FFFFFF"/>
-                    </a:solidFill>
-                  </a:tcPr>
-                </a:tc>
-                <a:tc>
-                  <a:txBody>
-                    <a:bodyPr wrap="square"/>
-                    <a:lstStyle/>
-                    <a:p>
-                      <a:r>
-                        <a:rPr sz="1100" b="0">
-                          <a:solidFill>
-                            <a:srgbClr val="2C2C2C"/>
-                          </a:solidFill>
-                          <a:latin typeface="Malgun Gothic"/>
-                          <a:ea typeface="Malgun Gothic"/>
-                        </a:rPr>
-                        <a:t>Jesse 1등. Allen 45% ET, GABA 없음</a:t>
-                      </a:r>
-                    </a:p>
-                  </a:txBody>
-                  <a:tcPr>
-                    <a:solidFill>
-                      <a:srgbClr val="FFFFFF"/>
-                    </a:solidFill>
-                  </a:tcPr>
-                </a:tc>
-                <a:tc>
-                  <a:txBody>
-                    <a:bodyPr wrap="square"/>
-                    <a:lstStyle/>
-                    <a:p>
-                      <a:r>
-                        <a:rPr sz="1100" b="0">
-                          <a:solidFill>
-                            <a:srgbClr val="2C2C2C"/>
-                          </a:solidFill>
-                          <a:latin typeface="Malgun Gothic"/>
-                          <a:ea typeface="Malgun Gothic"/>
-                        </a:rPr>
-                        <a:t>1</a:t>
-                      </a:r>
-                    </a:p>
-                  </a:txBody>
-                  <a:tcPr>
-                    <a:solidFill>
-                      <a:srgbClr val="FFFFFF"/>
-                    </a:solidFill>
-                  </a:tcPr>
-                </a:tc>
-                <a:tc>
-                  <a:txBody>
-                    <a:bodyPr wrap="square"/>
-                    <a:lstStyle/>
-                    <a:p>
-                      <a:r>
-                        <a:rPr sz="1100" b="0">
-                          <a:solidFill>
-                            <a:srgbClr val="2C2C2C"/>
-                          </a:solidFill>
-                          <a:latin typeface="Malgun Gothic"/>
-                          <a:ea typeface="Malgun Gothic"/>
-                        </a:rPr>
-                        <a:t>여유 시</a:t>
-                      </a:r>
-                    </a:p>
-                  </a:txBody>
-                  <a:tcPr>
-                    <a:solidFill>
-                      <a:srgbClr val="FFFFFF"/>
-                    </a:solidFill>
-                  </a:tcPr>
-                </a:tc>
-              </a:tr>
-              <a:tr h="470916">
-                <a:tc>
-                  <a:txBody>
-                    <a:bodyPr wrap="square"/>
-                    <a:lstStyle/>
-                    <a:p>
-                      <a:r>
-                        <a:rPr sz="1100" b="0">
-                          <a:solidFill>
-                            <a:srgbClr val="2C2C2C"/>
-                          </a:solidFill>
-                          <a:latin typeface="Malgun Gothic"/>
-                          <a:ea typeface="Malgun Gothic"/>
-                        </a:rPr>
-                        <a:t>8</a:t>
-                      </a:r>
-                    </a:p>
-                  </a:txBody>
-                  <a:tcPr>
-                    <a:solidFill>
-                      <a:srgbClr val="F4F1EA"/>
-                    </a:solidFill>
-                  </a:tcPr>
-                </a:tc>
-                <a:tc>
-                  <a:txBody>
-                    <a:bodyPr wrap="square"/>
-                    <a:lstStyle/>
-                    <a:p>
-                      <a:r>
-                        <a:rPr sz="1100" b="0">
-                          <a:solidFill>
-                            <a:srgbClr val="2C2C2C"/>
-                          </a:solidFill>
-                          <a:latin typeface="Malgun Gothic"/>
-                          <a:ea typeface="Malgun Gothic"/>
-                        </a:rPr>
-                        <a:t>Camk2g</a:t>
-                      </a:r>
-                    </a:p>
-                  </a:txBody>
-                  <a:tcPr>
-                    <a:solidFill>
-                      <a:srgbClr val="F4F1EA"/>
-                    </a:solidFill>
-                  </a:tcPr>
-                </a:tc>
-                <a:tc>
-                  <a:txBody>
-                    <a:bodyPr wrap="square"/>
-                    <a:lstStyle/>
-                    <a:p>
-                      <a:r>
-                        <a:rPr sz="1100" b="0">
-                          <a:solidFill>
-                            <a:srgbClr val="2C2C2C"/>
-                          </a:solidFill>
-                          <a:latin typeface="Malgun Gothic"/>
-                          <a:ea typeface="Malgun Gothic"/>
-                        </a:rPr>
-                        <a:t>Allen 93%. 모르핀 Down</a:t>
-                      </a:r>
-                    </a:p>
-                  </a:txBody>
-                  <a:tcPr>
-                    <a:solidFill>
-                      <a:srgbClr val="F4F1EA"/>
-                    </a:solidFill>
-                  </a:tcPr>
-                </a:tc>
-                <a:tc>
-                  <a:txBody>
-                    <a:bodyPr wrap="square"/>
-                    <a:lstStyle/>
-                    <a:p>
-                      <a:r>
-                        <a:rPr sz="1100" b="0">
-                          <a:solidFill>
-                            <a:srgbClr val="2C2C2C"/>
-                          </a:solidFill>
-                          <a:latin typeface="Malgun Gothic"/>
-                          <a:ea typeface="Malgun Gothic"/>
-                        </a:rPr>
-                        <a:t>1</a:t>
-                      </a:r>
-                    </a:p>
-                  </a:txBody>
-                  <a:tcPr>
-                    <a:solidFill>
-                      <a:srgbClr val="F4F1EA"/>
-                    </a:solidFill>
-                  </a:tcPr>
-                </a:tc>
-                <a:tc>
-                  <a:txBody>
-                    <a:bodyPr wrap="square"/>
-                    <a:lstStyle/>
-                    <a:p>
-                      <a:r>
-                        <a:rPr sz="1100" b="0">
-                          <a:solidFill>
-                            <a:srgbClr val="2C2C2C"/>
-                          </a:solidFill>
-                          <a:latin typeface="Malgun Gothic"/>
-                          <a:ea typeface="Malgun Gothic"/>
-                        </a:rPr>
-                        <a:t>상태 읽을 때</a:t>
-                      </a:r>
-                    </a:p>
-                  </a:txBody>
-                  <a:tcPr>
-                    <a:solidFill>
-                      <a:srgbClr val="F4F1EA"/>
-                    </a:solidFill>
-                  </a:tcPr>
-                </a:tc>
-              </a:tr>
             </a:tbl>
           </a:graphicData>
         </a:graphic>
@@ -7480,8 +5683,8 @@
         </p:nvSpPr>
         <p:spPr>
           <a:xfrm>
-            <a:off x="365760" y="5742432"/>
-            <a:ext cx="11430000" cy="685800"/>
+            <a:off x="365760" y="5577840"/>
+            <a:ext cx="11430000" cy="822960"/>
           </a:xfrm>
           <a:prstGeom prst="rect">
             <a:avLst/>
@@ -7495,14 +5698,24 @@
           <a:lstStyle/>
           <a:p>
             <a:r>
-              <a:rPr sz="1400" b="1">
+              <a:rPr sz="2000" b="1">
+                <a:solidFill>
+                  <a:srgbClr val="C44536"/>
+                </a:solidFill>
+                <a:latin typeface="Calibri"/>
+              </a:rPr>
+              <a:t>Final new genes:    Rxfp1   +   Per2   Pcsk1   Per1   +   Chrm1   Grm8</a:t>
+            </a:r>
+          </a:p>
+          <a:p>
+            <a:r>
+              <a:rPr sz="1400" b="0">
                 <a:solidFill>
                   <a:srgbClr val="2C2C2C"/>
                 </a:solidFill>
-                <a:latin typeface="Malgun Gothic"/>
-                <a:ea typeface="Malgun Gothic"/>
+                <a:latin typeface="Calibri"/>
               </a:rPr>
-              <a:t>기본안  슬롯 +5 (Rxfp1 무료 + Per2 Pcsk1 Per1 Chrm1 Grm8).  Dan 14 유지 시 커스텀 119.  한도 100이면 Dan CEA 쪽과 스왑.</a:t>
+              <a:t>Five custom slots on top of Dan 14  →  119 custom if every Dan gene is kept.  Cap is 100; swap CEA-border Dan genes if 10x will not exceed it.</a:t>
             </a:r>
           </a:p>
         </p:txBody>
@@ -7534,10 +5747,9 @@
                 <a:solidFill>
                   <a:srgbClr val="6B6B6B"/>
                 </a:solidFill>
-                <a:latin typeface="Malgun Gothic"/>
-                <a:ea typeface="Malgun Gothic"/>
+                <a:latin typeface="Calibri"/>
               </a:rPr>
-              <a:t>Xenium ORBm + BMAp  |  Dan GSE283418  ·  Jesse PL-ILA-ORB  ·  Allen WMB-10X  |  4/4</a:t>
+              <a:t>Xenium ORBm + BMAp add-on  |  Dan GSE283418  ·  Jesse PL-ILA-ORB  ·  Allen WMB-10X  |  3/3</a:t>
             </a:r>
           </a:p>
         </p:txBody>

</xml_diff>

<commit_message>
Rebuild the add-gene deck with Jesse and Dan result figures, then the final list.
Co-authored-by: Cursor <cursoragent@cursor.com>
</commit_message>
<xml_diff>
--- a/v3/outputs/Add_genes_Jesse_Allen_Dan_4slides.pptx
+++ b/v3/outputs/Add_genes_Jesse_Allen_Dan_4slides.pptx
@@ -8,6 +8,7 @@
     <p:sldId id="256" r:id="rId7"/>
     <p:sldId id="257" r:id="rId8"/>
     <p:sldId id="258" r:id="rId9"/>
+    <p:sldId id="259" r:id="rId10"/>
   </p:sldIdLst>
   <p:sldSz cx="12191695" cy="6858000" type="screen4x3"/>
   <p:notesSz cx="6858000" cy="9144000"/>
@@ -3105,7 +3106,7 @@
             <a:avLst/>
           </a:prstGeom>
           <a:solidFill>
-            <a:srgbClr val="2A6F97"/>
+            <a:srgbClr val="1D4E89"/>
           </a:solidFill>
           <a:ln>
             <a:noFill/>
@@ -3141,8 +3142,8 @@
         </p:nvSpPr>
         <p:spPr>
           <a:xfrm>
-            <a:off x="411480" y="201168"/>
-            <a:ext cx="11338560" cy="402336"/>
+            <a:off x="365760" y="164592"/>
+            <a:ext cx="11430000" cy="384048"/>
           </a:xfrm>
           <a:prstGeom prst="rect">
             <a:avLst/>
@@ -3156,13 +3157,13 @@
           <a:lstStyle/>
           <a:p>
             <a:r>
-              <a:rPr sz="2600" b="1">
+              <a:rPr sz="2400" b="1">
                 <a:solidFill>
                   <a:srgbClr val="1D4E89"/>
                 </a:solidFill>
                 <a:latin typeface="Calibri"/>
               </a:rPr>
-              <a:t>Dan  |  genes considered, and why</a:t>
+              <a:t>Jesse  |  how the morphine DEGs look</a:t>
             </a:r>
           </a:p>
         </p:txBody>
@@ -3175,8 +3176,8 @@
         </p:nvSpPr>
         <p:spPr>
           <a:xfrm>
-            <a:off x="411480" y="603504"/>
-            <a:ext cx="11338560" cy="292608"/>
+            <a:off x="365760" y="530352"/>
+            <a:ext cx="11430000" cy="292608"/>
           </a:xfrm>
           <a:prstGeom prst="rect">
             <a:avLst/>
@@ -3190,105 +3191,65 @@
           <a:lstStyle/>
           <a:p>
             <a:r>
-              <a:rPr sz="1400" b="0">
+              <a:rPr sz="1300" b="0">
                 <a:solidFill>
                   <a:srgbClr val="6B6B6B"/>
                 </a:solidFill>
                 <a:latin typeface="Calibri"/>
               </a:rPr>
-              <a:t>GSE283418  ·  Berg / Scherrer  ·  Resolve 98-gene smFISH in amygdala  ·  re-scored in our Allen BMAp ROI</a:t>
-            </a:r>
-          </a:p>
-        </p:txBody>
-      </p:sp>
-      <p:sp>
-        <p:nvSpPr>
-          <p:cNvPr id="5" name="Rounded Rectangle 4"/>
-          <p:cNvSpPr/>
+              <a:t>5-day escalating morphine  ·  DESeq2 subclass pseudobulk, padj 0.1  ·  PL–ILA–ORB.  Left: widest IEGs.  Right: which cell types change.</a:t>
+            </a:r>
+          </a:p>
+        </p:txBody>
+      </p:sp>
+      <p:pic>
+        <p:nvPicPr>
+          <p:cNvPr id="5" name="Picture 4" descr="Jesse_Fig2_top_IEG_plasticity.png"/>
+          <p:cNvPicPr>
+            <a:picLocks noChangeAspect="1"/>
+          </p:cNvPicPr>
           <p:nvPr/>
-        </p:nvSpPr>
+        </p:nvPicPr>
+        <p:blipFill>
+          <a:blip r:embed="rId2"/>
+          <a:stretch>
+            <a:fillRect/>
+          </a:stretch>
+        </p:blipFill>
         <p:spPr>
           <a:xfrm>
-            <a:off x="365760" y="1005840"/>
-            <a:ext cx="3840480" cy="5212080"/>
-          </a:xfrm>
-          <a:prstGeom prst="roundRect">
-            <a:avLst/>
-          </a:prstGeom>
-          <a:solidFill>
-            <a:srgbClr val="FFFFFF"/>
-          </a:solidFill>
-          <a:ln>
-            <a:solidFill>
-              <a:srgbClr val="2A6F97"/>
-            </a:solidFill>
-          </a:ln>
-        </p:spPr>
-        <p:style>
-          <a:lnRef idx="1">
-            <a:schemeClr val="accent1"/>
-          </a:lnRef>
-          <a:fillRef idx="3">
-            <a:schemeClr val="accent1"/>
-          </a:fillRef>
-          <a:effectRef idx="2">
-            <a:schemeClr val="accent1"/>
-          </a:effectRef>
-          <a:fontRef idx="minor">
-            <a:schemeClr val="lt1"/>
-          </a:fontRef>
-        </p:style>
-        <p:txBody>
-          <a:bodyPr rtlCol="0" anchor="ctr"/>
-          <a:lstStyle/>
-          <a:p>
-            <a:pPr algn="ctr"/>
-          </a:p>
-        </p:txBody>
-      </p:sp>
-      <p:sp>
-        <p:nvSpPr>
-          <p:cNvPr id="6" name="Rectangle 5"/>
-          <p:cNvSpPr/>
-          <p:nvPr/>
-        </p:nvSpPr>
-        <p:spPr>
-          <a:xfrm>
-            <a:off x="365760" y="1005840"/>
-            <a:ext cx="3840480" cy="365760"/>
+            <a:off x="228600" y="896112"/>
+            <a:ext cx="6537960" cy="5440680"/>
           </a:xfrm>
           <a:prstGeom prst="rect">
             <a:avLst/>
           </a:prstGeom>
-          <a:solidFill>
-            <a:srgbClr val="2A6F97"/>
-          </a:solidFill>
-          <a:ln>
-            <a:noFill/>
-          </a:ln>
         </p:spPr>
-        <p:style>
-          <a:lnRef idx="1">
-            <a:schemeClr val="accent1"/>
-          </a:lnRef>
-          <a:fillRef idx="3">
-            <a:schemeClr val="accent1"/>
-          </a:fillRef>
-          <a:effectRef idx="2">
-            <a:schemeClr val="accent1"/>
-          </a:effectRef>
-          <a:fontRef idx="minor">
-            <a:schemeClr val="lt1"/>
-          </a:fontRef>
-        </p:style>
-        <p:txBody>
-          <a:bodyPr rtlCol="0" anchor="ctr"/>
-          <a:lstStyle/>
-          <a:p>
-            <a:pPr algn="ctr"/>
-          </a:p>
-        </p:txBody>
-      </p:sp>
+      </p:pic>
+      <p:pic>
+        <p:nvPicPr>
+          <p:cNvPr id="6" name="Picture 5" descr="Jesse_Fig3_IEG_by_subclass.png"/>
+          <p:cNvPicPr>
+            <a:picLocks noChangeAspect="1"/>
+          </p:cNvPicPr>
+          <p:nvPr/>
+        </p:nvPicPr>
+        <p:blipFill>
+          <a:blip r:embed="rId3"/>
+          <a:stretch>
+            <a:fillRect/>
+          </a:stretch>
+        </p:blipFill>
+        <p:spPr>
+          <a:xfrm>
+            <a:off x="6812280" y="896112"/>
+            <a:ext cx="5074920" cy="5440680"/>
+          </a:xfrm>
+          <a:prstGeom prst="rect">
+            <a:avLst/>
+          </a:prstGeom>
+        </p:spPr>
+      </p:pic>
       <p:sp>
         <p:nvSpPr>
           <p:cNvPr id="7" name="TextBox 6"/>
@@ -3297,8 +3258,8 @@
         </p:nvSpPr>
         <p:spPr>
           <a:xfrm>
-            <a:off x="475488" y="1060704"/>
-            <a:ext cx="3657600" cy="274320"/>
+            <a:off x="365760" y="6565392"/>
+            <a:ext cx="11430000" cy="237744"/>
           </a:xfrm>
           <a:prstGeom prst="rect">
             <a:avLst/>
@@ -3312,844 +3273,13 @@
           <a:lstStyle/>
           <a:p>
             <a:r>
-              <a:rPr sz="1300" b="1">
-                <a:solidFill>
-                  <a:srgbClr val="FFFFFF"/>
-                </a:solidFill>
-                <a:latin typeface="Calibri"/>
-              </a:rPr>
-              <a:t>What the data are</a:t>
-            </a:r>
-          </a:p>
-        </p:txBody>
-      </p:sp>
-      <p:sp>
-        <p:nvSpPr>
-          <p:cNvPr id="8" name="TextBox 7"/>
-          <p:cNvSpPr txBox="1"/>
-          <p:nvPr/>
-        </p:nvSpPr>
-        <p:spPr>
-          <a:xfrm>
-            <a:off x="493776" y="1463040"/>
-            <a:ext cx="3584448" cy="4663440"/>
-          </a:xfrm>
-          <a:prstGeom prst="rect">
-            <a:avLst/>
-          </a:prstGeom>
-          <a:noFill/>
-        </p:spPr>
-        <p:txBody>
-          <a:bodyPr wrap="square">
-            <a:spAutoFit/>
-          </a:bodyPr>
-          <a:lstStyle/>
-          <a:p>
-            <a:r>
-              <a:rPr sz="1300" b="0">
-                <a:solidFill>
-                  <a:srgbClr val="2C2C2C"/>
-                </a:solidFill>
-                <a:latin typeface="Calibri"/>
-              </a:rPr>
-              <a:t>Not a cell-type atlas.</a:t>
-            </a:r>
-          </a:p>
-          <a:p>
-            <a:r>
-              <a:rPr sz="1300" b="0">
-                <a:solidFill>
-                  <a:srgbClr val="2C2C2C"/>
-                </a:solidFill>
-                <a:latin typeface="Calibri"/>
-              </a:rPr>
-              <a:t>A spatial 98-gene panel from</a:t>
-            </a:r>
-          </a:p>
-          <a:p>
-            <a:r>
-              <a:rPr sz="1300" b="0">
-                <a:solidFill>
-                  <a:srgbClr val="2C2C2C"/>
-                </a:solidFill>
-                <a:latin typeface="Calibri"/>
-              </a:rPr>
-              <a:t>amygdala sections.</a:t>
-            </a:r>
-          </a:p>
-          <a:p>
-            <a:r>
-              <a:rPr sz="1300" b="0">
-                <a:solidFill>
-                  <a:srgbClr val="2C2C2C"/>
-                </a:solidFill>
-                <a:latin typeface="Calibri"/>
-              </a:rPr>
-              <a:t/>
-            </a:r>
-          </a:p>
-          <a:p>
-            <a:r>
-              <a:rPr sz="1300" b="0">
-                <a:solidFill>
-                  <a:srgbClr val="2C2C2C"/>
-                </a:solidFill>
-                <a:latin typeface="Calibri"/>
-              </a:rPr>
-              <a:t>38 / 98 were already on our</a:t>
-            </a:r>
-          </a:p>
-          <a:p>
-            <a:r>
-              <a:rPr sz="1300" b="0">
-                <a:solidFill>
-                  <a:srgbClr val="2C2C2C"/>
-                </a:solidFill>
-                <a:latin typeface="Calibri"/>
-              </a:rPr>
-              <a:t>shared 144 (Foxp2, Cartpt,</a:t>
-            </a:r>
-          </a:p>
-          <a:p>
-            <a:r>
-              <a:rPr sz="1300" b="0">
-                <a:solidFill>
-                  <a:srgbClr val="2C2C2C"/>
-                </a:solidFill>
-                <a:latin typeface="Calibri"/>
-              </a:rPr>
-              <a:t>Pdyn, Oprm1, Slc17a7…).</a:t>
-            </a:r>
-          </a:p>
-          <a:p>
-            <a:r>
-              <a:rPr sz="1300" b="0">
-                <a:solidFill>
-                  <a:srgbClr val="2C2C2C"/>
-                </a:solidFill>
-                <a:latin typeface="Calibri"/>
-              </a:rPr>
-              <a:t/>
-            </a:r>
-          </a:p>
-          <a:p>
-            <a:r>
-              <a:rPr sz="1300" b="0">
-                <a:solidFill>
-                  <a:srgbClr val="2C2C2C"/>
-                </a:solidFill>
-                <a:latin typeface="Calibri"/>
-              </a:rPr>
-              <a:t>We asked: which of the</a:t>
-            </a:r>
-          </a:p>
-          <a:p>
-            <a:r>
-              <a:rPr sz="1300" b="0">
-                <a:solidFill>
-                  <a:srgbClr val="2C2C2C"/>
-                </a:solidFill>
-                <a:latin typeface="Calibri"/>
-              </a:rPr>
-              <a:t>remaining genes are still</a:t>
-            </a:r>
-          </a:p>
-          <a:p>
-            <a:r>
-              <a:rPr sz="1300" b="0">
-                <a:solidFill>
-                  <a:srgbClr val="2C2C2C"/>
-                </a:solidFill>
-                <a:latin typeface="Calibri"/>
-              </a:rPr>
-              <a:t>informative in our BMAp</a:t>
-            </a:r>
-          </a:p>
-          <a:p>
-            <a:r>
-              <a:rPr sz="1300" b="0">
-                <a:solidFill>
-                  <a:srgbClr val="2C2C2C"/>
-                </a:solidFill>
-                <a:latin typeface="Calibri"/>
-              </a:rPr>
-              <a:t>mapped cells?</a:t>
-            </a:r>
-          </a:p>
-        </p:txBody>
-      </p:sp>
-      <p:sp>
-        <p:nvSpPr>
-          <p:cNvPr id="9" name="Rounded Rectangle 8"/>
-          <p:cNvSpPr/>
-          <p:nvPr/>
-        </p:nvSpPr>
-        <p:spPr>
-          <a:xfrm>
-            <a:off x="4343400" y="1005840"/>
-            <a:ext cx="3840480" cy="5212080"/>
-          </a:xfrm>
-          <a:prstGeom prst="roundRect">
-            <a:avLst/>
-          </a:prstGeom>
-          <a:solidFill>
-            <a:srgbClr val="FFFFFF"/>
-          </a:solidFill>
-          <a:ln>
-            <a:solidFill>
-              <a:srgbClr val="2A6F97"/>
-            </a:solidFill>
-          </a:ln>
-        </p:spPr>
-        <p:style>
-          <a:lnRef idx="1">
-            <a:schemeClr val="accent1"/>
-          </a:lnRef>
-          <a:fillRef idx="3">
-            <a:schemeClr val="accent1"/>
-          </a:fillRef>
-          <a:effectRef idx="2">
-            <a:schemeClr val="accent1"/>
-          </a:effectRef>
-          <a:fontRef idx="minor">
-            <a:schemeClr val="lt1"/>
-          </a:fontRef>
-        </p:style>
-        <p:txBody>
-          <a:bodyPr rtlCol="0" anchor="ctr"/>
-          <a:lstStyle/>
-          <a:p>
-            <a:pPr algn="ctr"/>
-          </a:p>
-        </p:txBody>
-      </p:sp>
-      <p:sp>
-        <p:nvSpPr>
-          <p:cNvPr id="10" name="Rectangle 9"/>
-          <p:cNvSpPr/>
-          <p:nvPr/>
-        </p:nvSpPr>
-        <p:spPr>
-          <a:xfrm>
-            <a:off x="4343400" y="1005840"/>
-            <a:ext cx="3840480" cy="365760"/>
-          </a:xfrm>
-          <a:prstGeom prst="rect">
-            <a:avLst/>
-          </a:prstGeom>
-          <a:solidFill>
-            <a:srgbClr val="2A6F97"/>
-          </a:solidFill>
-          <a:ln>
-            <a:noFill/>
-          </a:ln>
-        </p:spPr>
-        <p:style>
-          <a:lnRef idx="1">
-            <a:schemeClr val="accent1"/>
-          </a:lnRef>
-          <a:fillRef idx="3">
-            <a:schemeClr val="accent1"/>
-          </a:fillRef>
-          <a:effectRef idx="2">
-            <a:schemeClr val="accent1"/>
-          </a:effectRef>
-          <a:fontRef idx="minor">
-            <a:schemeClr val="lt1"/>
-          </a:fontRef>
-        </p:style>
-        <p:txBody>
-          <a:bodyPr rtlCol="0" anchor="ctr"/>
-          <a:lstStyle/>
-          <a:p>
-            <a:pPr algn="ctr"/>
-          </a:p>
-        </p:txBody>
-      </p:sp>
-      <p:sp>
-        <p:nvSpPr>
-          <p:cNvPr id="11" name="TextBox 10"/>
-          <p:cNvSpPr txBox="1"/>
-          <p:nvPr/>
-        </p:nvSpPr>
-        <p:spPr>
-          <a:xfrm>
-            <a:off x="4453128" y="1060704"/>
-            <a:ext cx="3657600" cy="274320"/>
-          </a:xfrm>
-          <a:prstGeom prst="rect">
-            <a:avLst/>
-          </a:prstGeom>
-          <a:noFill/>
-        </p:spPr>
-        <p:txBody>
-          <a:bodyPr wrap="none">
-            <a:spAutoFit/>
-          </a:bodyPr>
-          <a:lstStyle/>
-          <a:p>
-            <a:r>
-              <a:rPr sz="1300" b="1">
-                <a:solidFill>
-                  <a:srgbClr val="FFFFFF"/>
-                </a:solidFill>
-                <a:latin typeface="Calibri"/>
-              </a:rPr>
-              <a:t>Why these 14 were considered</a:t>
-            </a:r>
-          </a:p>
-        </p:txBody>
-      </p:sp>
-      <p:sp>
-        <p:nvSpPr>
-          <p:cNvPr id="12" name="TextBox 11"/>
-          <p:cNvSpPr txBox="1"/>
-          <p:nvPr/>
-        </p:nvSpPr>
-        <p:spPr>
-          <a:xfrm>
-            <a:off x="4471416" y="1463040"/>
-            <a:ext cx="3584448" cy="4663440"/>
-          </a:xfrm>
-          <a:prstGeom prst="rect">
-            <a:avLst/>
-          </a:prstGeom>
-          <a:noFill/>
-        </p:spPr>
-        <p:txBody>
-          <a:bodyPr wrap="square">
-            <a:spAutoFit/>
-          </a:bodyPr>
-          <a:lstStyle/>
-          <a:p>
-            <a:r>
-              <a:rPr sz="1300" b="0">
-                <a:solidFill>
-                  <a:srgbClr val="2C2C2C"/>
-                </a:solidFill>
-                <a:latin typeface="Calibri"/>
-              </a:rPr>
-              <a:t>They were missing from the</a:t>
-            </a:r>
-          </a:p>
-          <a:p>
-            <a:r>
-              <a:rPr sz="1300" b="0">
-                <a:solidFill>
-                  <a:srgbClr val="2C2C2C"/>
-                </a:solidFill>
-                <a:latin typeface="Calibri"/>
-              </a:rPr>
-              <a:t>144 and detectable in the</a:t>
-            </a:r>
-          </a:p>
-          <a:p>
-            <a:r>
-              <a:rPr sz="1300" b="0">
-                <a:solidFill>
-                  <a:srgbClr val="2C2C2C"/>
-                </a:solidFill>
-                <a:latin typeface="Calibri"/>
-              </a:rPr>
-              <a:t>Allen BMAp-mapped ROI.</a:t>
-            </a:r>
-          </a:p>
-          <a:p>
-            <a:r>
-              <a:rPr sz="1300" b="0">
-                <a:solidFill>
-                  <a:srgbClr val="2C2C2C"/>
-                </a:solidFill>
-                <a:latin typeface="Calibri"/>
-              </a:rPr>
-              <a:t/>
-            </a:r>
-          </a:p>
-          <a:p>
-            <a:r>
-              <a:rPr sz="1300" b="0">
-                <a:solidFill>
-                  <a:srgbClr val="2C2C2C"/>
-                </a:solidFill>
-                <a:latin typeface="Calibri"/>
-              </a:rPr>
-              <a:t>Closest to true BMAp</a:t>
-            </a:r>
-          </a:p>
-          <a:p>
-            <a:r>
-              <a:rPr sz="1300" b="0">
-                <a:solidFill>
-                  <a:srgbClr val="2C2C2C"/>
-                </a:solidFill>
-                <a:latin typeface="Calibri"/>
-              </a:rPr>
-              <a:t>  Lamb3   (113 Ccdc42)</a:t>
-            </a:r>
-          </a:p>
-          <a:p>
-            <a:r>
-              <a:rPr sz="1300" b="0">
-                <a:solidFill>
-                  <a:srgbClr val="2C2C2C"/>
-                </a:solidFill>
-                <a:latin typeface="Calibri"/>
-              </a:rPr>
-              <a:t/>
-            </a:r>
-          </a:p>
-          <a:p>
-            <a:r>
-              <a:rPr sz="1300" b="0">
-                <a:solidFill>
-                  <a:srgbClr val="2C2C2C"/>
-                </a:solidFill>
-                <a:latin typeface="Calibri"/>
-              </a:rPr>
-              <a:t>BMA / MEA VGLUT1 border</a:t>
-            </a:r>
-          </a:p>
-          <a:p>
-            <a:r>
-              <a:rPr sz="1300" b="0">
-                <a:solidFill>
-                  <a:srgbClr val="2C2C2C"/>
-                </a:solidFill>
-                <a:latin typeface="Calibri"/>
-              </a:rPr>
-              <a:t>  Cck  Col23a1  Slc29a4</a:t>
-            </a:r>
-          </a:p>
-          <a:p>
-            <a:r>
-              <a:rPr sz="1300" b="0">
-                <a:solidFill>
-                  <a:srgbClr val="2C2C2C"/>
-                </a:solidFill>
-                <a:latin typeface="Calibri"/>
-              </a:rPr>
-              <a:t>  Abca8a  Dnah5</a:t>
-            </a:r>
-          </a:p>
-          <a:p>
-            <a:r>
-              <a:rPr sz="1300" b="0">
-                <a:solidFill>
-                  <a:srgbClr val="2C2C2C"/>
-                </a:solidFill>
-                <a:latin typeface="Calibri"/>
-              </a:rPr>
-              <a:t/>
-            </a:r>
-          </a:p>
-          <a:p>
-            <a:r>
-              <a:rPr sz="1300" b="0">
-                <a:solidFill>
-                  <a:srgbClr val="2C2C2C"/>
-                </a:solidFill>
-                <a:latin typeface="Calibri"/>
-              </a:rPr>
-              <a:t>MEA / BST neighbors</a:t>
-            </a:r>
-          </a:p>
-          <a:p>
-            <a:r>
-              <a:rPr sz="1300" b="0">
-                <a:solidFill>
-                  <a:srgbClr val="2C2C2C"/>
-                </a:solidFill>
-                <a:latin typeface="Calibri"/>
-              </a:rPr>
-              <a:t>  Calcrl  Nos1  Oprl1</a:t>
-            </a:r>
-          </a:p>
-          <a:p>
-            <a:r>
-              <a:rPr sz="1300" b="0">
-                <a:solidFill>
-                  <a:srgbClr val="2C2C2C"/>
-                </a:solidFill>
-                <a:latin typeface="Calibri"/>
-              </a:rPr>
-              <a:t>  Gfra1  Sp8</a:t>
-            </a:r>
-          </a:p>
-          <a:p>
-            <a:r>
-              <a:rPr sz="1300" b="0">
-                <a:solidFill>
-                  <a:srgbClr val="2C2C2C"/>
-                </a:solidFill>
-                <a:latin typeface="Calibri"/>
-              </a:rPr>
-              <a:t/>
-            </a:r>
-          </a:p>
-          <a:p>
-            <a:r>
-              <a:rPr sz="1300" b="0">
-                <a:solidFill>
-                  <a:srgbClr val="2C2C2C"/>
-                </a:solidFill>
-                <a:latin typeface="Calibri"/>
-              </a:rPr>
-              <a:t>CEA / other  (weakest)</a:t>
-            </a:r>
-          </a:p>
-          <a:p>
-            <a:r>
-              <a:rPr sz="1300" b="0">
-                <a:solidFill>
-                  <a:srgbClr val="2C2C2C"/>
-                </a:solidFill>
-                <a:latin typeface="Calibri"/>
-              </a:rPr>
-              <a:t>  Syndig1l  Gabre  Tspan18</a:t>
-            </a:r>
-          </a:p>
-        </p:txBody>
-      </p:sp>
-      <p:sp>
-        <p:nvSpPr>
-          <p:cNvPr id="13" name="Rounded Rectangle 12"/>
-          <p:cNvSpPr/>
-          <p:nvPr/>
-        </p:nvSpPr>
-        <p:spPr>
-          <a:xfrm>
-            <a:off x="8321040" y="1005840"/>
-            <a:ext cx="3474720" cy="5212080"/>
-          </a:xfrm>
-          <a:prstGeom prst="roundRect">
-            <a:avLst/>
-          </a:prstGeom>
-          <a:solidFill>
-            <a:srgbClr val="FFFFFF"/>
-          </a:solidFill>
-          <a:ln>
-            <a:solidFill>
-              <a:srgbClr val="B08968"/>
-            </a:solidFill>
-          </a:ln>
-        </p:spPr>
-        <p:style>
-          <a:lnRef idx="1">
-            <a:schemeClr val="accent1"/>
-          </a:lnRef>
-          <a:fillRef idx="3">
-            <a:schemeClr val="accent1"/>
-          </a:fillRef>
-          <a:effectRef idx="2">
-            <a:schemeClr val="accent1"/>
-          </a:effectRef>
-          <a:fontRef idx="minor">
-            <a:schemeClr val="lt1"/>
-          </a:fontRef>
-        </p:style>
-        <p:txBody>
-          <a:bodyPr rtlCol="0" anchor="ctr"/>
-          <a:lstStyle/>
-          <a:p>
-            <a:pPr algn="ctr"/>
-          </a:p>
-        </p:txBody>
-      </p:sp>
-      <p:sp>
-        <p:nvSpPr>
-          <p:cNvPr id="14" name="Rectangle 13"/>
-          <p:cNvSpPr/>
-          <p:nvPr/>
-        </p:nvSpPr>
-        <p:spPr>
-          <a:xfrm>
-            <a:off x="8321040" y="1005840"/>
-            <a:ext cx="3474720" cy="365760"/>
-          </a:xfrm>
-          <a:prstGeom prst="rect">
-            <a:avLst/>
-          </a:prstGeom>
-          <a:solidFill>
-            <a:srgbClr val="B08968"/>
-          </a:solidFill>
-          <a:ln>
-            <a:noFill/>
-          </a:ln>
-        </p:spPr>
-        <p:style>
-          <a:lnRef idx="1">
-            <a:schemeClr val="accent1"/>
-          </a:lnRef>
-          <a:fillRef idx="3">
-            <a:schemeClr val="accent1"/>
-          </a:fillRef>
-          <a:effectRef idx="2">
-            <a:schemeClr val="accent1"/>
-          </a:effectRef>
-          <a:fontRef idx="minor">
-            <a:schemeClr val="lt1"/>
-          </a:fontRef>
-        </p:style>
-        <p:txBody>
-          <a:bodyPr rtlCol="0" anchor="ctr"/>
-          <a:lstStyle/>
-          <a:p>
-            <a:pPr algn="ctr"/>
-          </a:p>
-        </p:txBody>
-      </p:sp>
-      <p:sp>
-        <p:nvSpPr>
-          <p:cNvPr id="15" name="TextBox 14"/>
-          <p:cNvSpPr txBox="1"/>
-          <p:nvPr/>
-        </p:nvSpPr>
-        <p:spPr>
-          <a:xfrm>
-            <a:off x="8430767" y="1060704"/>
-            <a:ext cx="3291839" cy="274320"/>
-          </a:xfrm>
-          <a:prstGeom prst="rect">
-            <a:avLst/>
-          </a:prstGeom>
-          <a:noFill/>
-        </p:spPr>
-        <p:txBody>
-          <a:bodyPr wrap="none">
-            <a:spAutoFit/>
-          </a:bodyPr>
-          <a:lstStyle/>
-          <a:p>
-            <a:r>
-              <a:rPr sz="1300" b="1">
-                <a:solidFill>
-                  <a:srgbClr val="FFFFFF"/>
-                </a:solidFill>
-                <a:latin typeface="Calibri"/>
-              </a:rPr>
-              <a:t>Status</a:t>
-            </a:r>
-          </a:p>
-        </p:txBody>
-      </p:sp>
-      <p:sp>
-        <p:nvSpPr>
-          <p:cNvPr id="16" name="TextBox 15"/>
-          <p:cNvSpPr txBox="1"/>
-          <p:nvPr/>
-        </p:nvSpPr>
-        <p:spPr>
-          <a:xfrm>
-            <a:off x="8449056" y="1463040"/>
-            <a:ext cx="3218687" cy="4663440"/>
-          </a:xfrm>
-          <a:prstGeom prst="rect">
-            <a:avLst/>
-          </a:prstGeom>
-          <a:noFill/>
-        </p:spPr>
-        <p:txBody>
-          <a:bodyPr wrap="square">
-            <a:spAutoFit/>
-          </a:bodyPr>
-          <a:lstStyle/>
-          <a:p>
-            <a:r>
-              <a:rPr sz="1300" b="0">
-                <a:solidFill>
-                  <a:srgbClr val="2C2C2C"/>
-                </a:solidFill>
-                <a:latin typeface="Calibri"/>
-              </a:rPr>
-              <a:t>Already added to</a:t>
-            </a:r>
-          </a:p>
-          <a:p>
-            <a:r>
-              <a:rPr sz="1300" b="0">
-                <a:solidFill>
-                  <a:srgbClr val="2C2C2C"/>
-                </a:solidFill>
-                <a:latin typeface="Calibri"/>
-              </a:rPr>
-              <a:t>MSGS111</a:t>
-            </a:r>
-          </a:p>
-          <a:p>
-            <a:r>
-              <a:rPr sz="1300" b="0">
-                <a:solidFill>
-                  <a:srgbClr val="2C2C2C"/>
-                </a:solidFill>
-                <a:latin typeface="Calibri"/>
-              </a:rPr>
-              <a:t>ranks 145–158.</a:t>
-            </a:r>
-          </a:p>
-          <a:p>
-            <a:r>
-              <a:rPr sz="1300" b="0">
-                <a:solidFill>
-                  <a:srgbClr val="2C2C2C"/>
-                </a:solidFill>
-                <a:latin typeface="Calibri"/>
-              </a:rPr>
-              <a:t/>
-            </a:r>
-          </a:p>
-          <a:p>
-            <a:r>
-              <a:rPr sz="1300" b="0">
-                <a:solidFill>
-                  <a:srgbClr val="2C2C2C"/>
-                </a:solidFill>
-                <a:latin typeface="Calibri"/>
-              </a:rPr>
-              <a:t>They do not redo</a:t>
-            </a:r>
-          </a:p>
-          <a:p>
-            <a:r>
-              <a:rPr sz="1300" b="0">
-                <a:solidFill>
-                  <a:srgbClr val="2C2C2C"/>
-                </a:solidFill>
-                <a:latin typeface="Calibri"/>
-              </a:rPr>
-              <a:t>cell-type ID.</a:t>
-            </a:r>
-          </a:p>
-          <a:p>
-            <a:r>
-              <a:rPr sz="1300" b="0">
-                <a:solidFill>
-                  <a:srgbClr val="2C2C2C"/>
-                </a:solidFill>
-                <a:latin typeface="Calibri"/>
-              </a:rPr>
-              <a:t>They add amygdala</a:t>
-            </a:r>
-          </a:p>
-          <a:p>
-            <a:r>
-              <a:rPr sz="1300" b="0">
-                <a:solidFill>
-                  <a:srgbClr val="2C2C2C"/>
-                </a:solidFill>
-                <a:latin typeface="Calibri"/>
-              </a:rPr>
-              <a:t>spatial genes Dan</a:t>
-            </a:r>
-          </a:p>
-          <a:p>
-            <a:r>
-              <a:rPr sz="1300" b="0">
-                <a:solidFill>
-                  <a:srgbClr val="2C2C2C"/>
-                </a:solidFill>
-                <a:latin typeface="Calibri"/>
-              </a:rPr>
-              <a:t>already uses.</a:t>
-            </a:r>
-          </a:p>
-          <a:p>
-            <a:r>
-              <a:rPr sz="1300" b="0">
-                <a:solidFill>
-                  <a:srgbClr val="2C2C2C"/>
-                </a:solidFill>
-                <a:latin typeface="Calibri"/>
-              </a:rPr>
-              <a:t/>
-            </a:r>
-          </a:p>
-          <a:p>
-            <a:r>
-              <a:rPr sz="1300" b="0">
-                <a:solidFill>
-                  <a:srgbClr val="2C2C2C"/>
-                </a:solidFill>
-                <a:latin typeface="Calibri"/>
-              </a:rPr>
-              <a:t>If the 100-slot cap</a:t>
-            </a:r>
-          </a:p>
-          <a:p>
-            <a:r>
-              <a:rPr sz="1300" b="0">
-                <a:solidFill>
-                  <a:srgbClr val="2C2C2C"/>
-                </a:solidFill>
-                <a:latin typeface="Calibri"/>
-              </a:rPr>
-              <a:t>is hard: keep Lamb3</a:t>
-            </a:r>
-          </a:p>
-          <a:p>
-            <a:r>
-              <a:rPr sz="1300" b="0">
-                <a:solidFill>
-                  <a:srgbClr val="2C2C2C"/>
-                </a:solidFill>
-                <a:latin typeface="Calibri"/>
-              </a:rPr>
-              <a:t>+ the 012-border set;</a:t>
-            </a:r>
-          </a:p>
-          <a:p>
-            <a:r>
-              <a:rPr sz="1300" b="0">
-                <a:solidFill>
-                  <a:srgbClr val="2C2C2C"/>
-                </a:solidFill>
-                <a:latin typeface="Calibri"/>
-              </a:rPr>
-              <a:t>cut the CEA genes</a:t>
-            </a:r>
-          </a:p>
-          <a:p>
-            <a:r>
-              <a:rPr sz="1300" b="0">
-                <a:solidFill>
-                  <a:srgbClr val="2C2C2C"/>
-                </a:solidFill>
-                <a:latin typeface="Calibri"/>
-              </a:rPr>
-              <a:t>first.</a:t>
-            </a:r>
-          </a:p>
-        </p:txBody>
-      </p:sp>
-      <p:sp>
-        <p:nvSpPr>
-          <p:cNvPr id="17" name="TextBox 16"/>
-          <p:cNvSpPr txBox="1"/>
-          <p:nvPr/>
-        </p:nvSpPr>
-        <p:spPr>
-          <a:xfrm>
-            <a:off x="411480" y="6565392"/>
-            <a:ext cx="11338560" cy="237744"/>
-          </a:xfrm>
-          <a:prstGeom prst="rect">
-            <a:avLst/>
-          </a:prstGeom>
-          <a:noFill/>
-        </p:spPr>
-        <p:txBody>
-          <a:bodyPr wrap="none">
-            <a:spAutoFit/>
-          </a:bodyPr>
-          <a:lstStyle/>
-          <a:p>
-            <a:r>
               <a:rPr sz="1100" b="0">
                 <a:solidFill>
                   <a:srgbClr val="6B6B6B"/>
                 </a:solidFill>
                 <a:latin typeface="Calibri"/>
               </a:rPr>
-              <a:t>Xenium ORBm + BMAp add-on  |  Dan GSE283418  ·  Jesse PL-ILA-ORB  ·  Allen WMB-10X  |  1/3</a:t>
+              <a:t>Xenium ORBm + BMAp  |  same figures as the long collaborator deck  |  1/4</a:t>
             </a:r>
           </a:p>
         </p:txBody>
@@ -4223,8 +3353,8 @@
         </p:nvSpPr>
         <p:spPr>
           <a:xfrm>
-            <a:off x="411480" y="201168"/>
-            <a:ext cx="11338560" cy="402336"/>
+            <a:off x="365760" y="164592"/>
+            <a:ext cx="11430000" cy="384048"/>
           </a:xfrm>
           <a:prstGeom prst="rect">
             <a:avLst/>
@@ -4238,13 +3368,13 @@
           <a:lstStyle/>
           <a:p>
             <a:r>
-              <a:rPr sz="2600" b="1">
+              <a:rPr sz="2400" b="1">
                 <a:solidFill>
                   <a:srgbClr val="1D4E89"/>
                 </a:solidFill>
                 <a:latin typeface="Calibri"/>
               </a:rPr>
-              <a:t>Jesse  |  genes considered, and why</a:t>
+              <a:t>Jesse  |  how the ORB GPCRs and IEG matrix look</a:t>
             </a:r>
           </a:p>
         </p:txBody>
@@ -4257,8 +3387,8 @@
         </p:nvSpPr>
         <p:spPr>
           <a:xfrm>
-            <a:off x="411480" y="603504"/>
-            <a:ext cx="11338560" cy="292608"/>
+            <a:off x="365760" y="530352"/>
+            <a:ext cx="11430000" cy="292608"/>
           </a:xfrm>
           <a:prstGeom prst="rect">
             <a:avLst/>
@@ -4272,598 +3402,75 @@
           <a:lstStyle/>
           <a:p>
             <a:r>
-              <a:rPr sz="1400" b="0">
+              <a:rPr sz="1300" b="0">
                 <a:solidFill>
                   <a:srgbClr val="6B6B6B"/>
                 </a:solidFill>
                 <a:latin typeface="Calibri"/>
               </a:rPr>
-              <a:t>5-day morphine DEGs in PL–ILA–ORB  +  GPCRs enriched in ORB vs the rest of the Allen atlas. Then checked as % expressing in our 106,122 ORBm cells.</a:t>
-            </a:r>
-          </a:p>
-        </p:txBody>
-      </p:sp>
-      <p:graphicFrame>
-        <p:nvGraphicFramePr>
-          <p:cNvPr id="5" name="Table 4"/>
-          <p:cNvGraphicFramePr>
-            <a:graphicFrameLocks noGrp="1"/>
-          </p:cNvGraphicFramePr>
+              <a:t>Left: GPCRs enriched in PL–ILA–ORB vs the rest of the atlas (anatomy, not morphine).  Right: top IEG DEGs × subclass.</a:t>
+            </a:r>
+          </a:p>
+        </p:txBody>
+      </p:sp>
+      <p:pic>
+        <p:nvPicPr>
+          <p:cNvPr id="5" name="Picture 4" descr="Jesse_Fig4_enriched_GPCRs.png"/>
+          <p:cNvPicPr>
+            <a:picLocks noChangeAspect="1"/>
+          </p:cNvPicPr>
           <p:nvPr/>
-        </p:nvGraphicFramePr>
-        <p:xfrm>
-          <a:off x="365760" y="987552"/>
-          <a:ext cx="11430000" cy="5257800"/>
-        </p:xfrm>
-        <a:graphic>
-          <a:graphicData uri="http://schemas.openxmlformats.org/drawingml/2006/table">
-            <a:tbl>
-              <a:tblPr firstRow="1" bandRow="1">
-                <a:tableStyleId>{5C22544A-7EE6-4342-B048-85BDC9FD1C3A}</a:tableStyleId>
-              </a:tblPr>
-              <a:tblGrid>
-                <a:gridCol w="3017520"/>
-                <a:gridCol w="4114800"/>
-                <a:gridCol w="4297680"/>
-              </a:tblGrid>
-              <a:tr h="657225">
-                <a:tc>
-                  <a:txBody>
-                    <a:bodyPr wrap="square"/>
-                    <a:lstStyle/>
-                    <a:p>
-                      <a:r>
-                        <a:rPr sz="1300" b="1">
-                          <a:solidFill>
-                            <a:srgbClr val="FFFFFF"/>
-                          </a:solidFill>
-                          <a:latin typeface="Calibri"/>
-                        </a:rPr>
-                        <a:t>Considered</a:t>
-                      </a:r>
-                    </a:p>
-                  </a:txBody>
-                  <a:tcPr>
-                    <a:solidFill>
-                      <a:srgbClr val="1D4E89"/>
-                    </a:solidFill>
-                  </a:tcPr>
-                </a:tc>
-                <a:tc>
-                  <a:txBody>
-                    <a:bodyPr wrap="square"/>
-                    <a:lstStyle/>
-                    <a:p>
-                      <a:r>
-                        <a:rPr sz="1300" b="1">
-                          <a:solidFill>
-                            <a:srgbClr val="FFFFFF"/>
-                          </a:solidFill>
-                          <a:latin typeface="Calibri"/>
-                        </a:rPr>
-                        <a:t>Why Jesse flagged it</a:t>
-                      </a:r>
-                    </a:p>
-                  </a:txBody>
-                  <a:tcPr>
-                    <a:solidFill>
-                      <a:srgbClr val="1D4E89"/>
-                    </a:solidFill>
-                  </a:tcPr>
-                </a:tc>
-                <a:tc>
-                  <a:txBody>
-                    <a:bodyPr wrap="square"/>
-                    <a:lstStyle/>
-                    <a:p>
-                      <a:r>
-                        <a:rPr sz="1300" b="1">
-                          <a:solidFill>
-                            <a:srgbClr val="FFFFFF"/>
-                          </a:solidFill>
-                          <a:latin typeface="Calibri"/>
-                        </a:rPr>
-                        <a:t>Why it is / is not a panel add</a:t>
-                      </a:r>
-                    </a:p>
-                  </a:txBody>
-                  <a:tcPr>
-                    <a:solidFill>
-                      <a:srgbClr val="1D4E89"/>
-                    </a:solidFill>
-                  </a:tcPr>
-                </a:tc>
-              </a:tr>
-              <a:tr h="657225">
-                <a:tc>
-                  <a:txBody>
-                    <a:bodyPr wrap="square"/>
-                    <a:lstStyle/>
-                    <a:p>
-                      <a:r>
-                        <a:rPr sz="1200" b="0">
-                          <a:solidFill>
-                            <a:srgbClr val="2C2C2C"/>
-                          </a:solidFill>
-                          <a:latin typeface="Calibri"/>
-                        </a:rPr>
-                        <a:t>Fos  Arc  Egr1  Junb  Nr4a1</a:t>
-                      </a:r>
-                    </a:p>
-                  </a:txBody>
-                  <a:tcPr>
-                    <a:solidFill>
-                      <a:srgbClr val="F4F1EA"/>
-                    </a:solidFill>
-                  </a:tcPr>
-                </a:tc>
-                <a:tc>
-                  <a:txBody>
-                    <a:bodyPr wrap="square"/>
-                    <a:lstStyle/>
-                    <a:p>
-                      <a:r>
-                        <a:rPr sz="1200" b="0">
-                          <a:solidFill>
-                            <a:srgbClr val="2C2C2C"/>
-                          </a:solidFill>
-                          <a:latin typeface="Calibri"/>
-                        </a:rPr>
-                        <a:t>Top activity IEGs after morphine</a:t>
-                      </a:r>
-                    </a:p>
-                  </a:txBody>
-                  <a:tcPr>
-                    <a:solidFill>
-                      <a:srgbClr val="F4F1EA"/>
-                    </a:solidFill>
-                  </a:tcPr>
-                </a:tc>
-                <a:tc>
-                  <a:txBody>
-                    <a:bodyPr wrap="square"/>
-                    <a:lstStyle/>
-                    <a:p>
-                      <a:r>
-                        <a:rPr sz="1200" b="0">
-                          <a:solidFill>
-                            <a:srgbClr val="2C2C2C"/>
-                          </a:solidFill>
-                          <a:latin typeface="Calibri"/>
-                        </a:rPr>
-                        <a:t>Already on the 144. Keep. Do not swap.</a:t>
-                      </a:r>
-                    </a:p>
-                  </a:txBody>
-                  <a:tcPr>
-                    <a:solidFill>
-                      <a:srgbClr val="F4F1EA"/>
-                    </a:solidFill>
-                  </a:tcPr>
-                </a:tc>
-              </a:tr>
-              <a:tr h="657225">
-                <a:tc>
-                  <a:txBody>
-                    <a:bodyPr wrap="square"/>
-                    <a:lstStyle/>
-                    <a:p>
-                      <a:r>
-                        <a:rPr sz="1200" b="0">
-                          <a:solidFill>
-                            <a:srgbClr val="2C2C2C"/>
-                          </a:solidFill>
-                          <a:latin typeface="Calibri"/>
-                        </a:rPr>
-                        <a:t>Per2  Pcsk1  Per1</a:t>
-                      </a:r>
-                    </a:p>
-                  </a:txBody>
-                  <a:tcPr>
-                    <a:solidFill>
-                      <a:srgbClr val="FFFFFF"/>
-                    </a:solidFill>
-                  </a:tcPr>
-                </a:tc>
-                <a:tc>
-                  <a:txBody>
-                    <a:bodyPr wrap="square"/>
-                    <a:lstStyle/>
-                    <a:p>
-                      <a:r>
-                        <a:rPr sz="1200" b="0">
-                          <a:solidFill>
-                            <a:srgbClr val="2C2C2C"/>
-                          </a:solidFill>
-                          <a:latin typeface="Calibri"/>
-                        </a:rPr>
-                        <a:t>Widest new IEGs (13 / 11 / 8 clusters). Circadian / peptide program, not acute TRAP.</a:t>
-                      </a:r>
-                    </a:p>
-                  </a:txBody>
-                  <a:tcPr>
-                    <a:solidFill>
-                      <a:srgbClr val="FFFFFF"/>
-                    </a:solidFill>
-                  </a:tcPr>
-                </a:tc>
-                <a:tc>
-                  <a:txBody>
-                    <a:bodyPr wrap="square"/>
-                    <a:lstStyle/>
-                    <a:p>
-                      <a:r>
-                        <a:rPr sz="1200" b="0">
-                          <a:solidFill>
-                            <a:srgbClr val="2C2C2C"/>
-                          </a:solidFill>
-                          <a:latin typeface="Calibri"/>
-                        </a:rPr>
-                        <a:t>Not on the panel. This is the morphine-state layer.</a:t>
-                      </a:r>
-                    </a:p>
-                  </a:txBody>
-                  <a:tcPr>
-                    <a:solidFill>
-                      <a:srgbClr val="FFFFFF"/>
-                    </a:solidFill>
-                  </a:tcPr>
-                </a:tc>
-              </a:tr>
-              <a:tr h="657225">
-                <a:tc>
-                  <a:txBody>
-                    <a:bodyPr wrap="square"/>
-                    <a:lstStyle/>
-                    <a:p>
-                      <a:r>
-                        <a:rPr sz="1200" b="0">
-                          <a:solidFill>
-                            <a:srgbClr val="2C2C2C"/>
-                          </a:solidFill>
-                          <a:latin typeface="Calibri"/>
-                        </a:rPr>
-                        <a:t>Cckbr  Hcrtr2  Chrm2  Grm5</a:t>
-                      </a:r>
-                    </a:p>
-                  </a:txBody>
-                  <a:tcPr>
-                    <a:solidFill>
-                      <a:srgbClr val="F4F1EA"/>
-                    </a:solidFill>
-                  </a:tcPr>
-                </a:tc>
-                <a:tc>
-                  <a:txBody>
-                    <a:bodyPr wrap="square"/>
-                    <a:lstStyle/>
-                    <a:p>
-                      <a:r>
-                        <a:rPr sz="1200" b="0">
-                          <a:solidFill>
-                            <a:srgbClr val="2C2C2C"/>
-                          </a:solidFill>
-                          <a:latin typeface="Calibri"/>
-                        </a:rPr>
-                        <a:t>ORB-enriched or DEG GPCRs</a:t>
-                      </a:r>
-                    </a:p>
-                  </a:txBody>
-                  <a:tcPr>
-                    <a:solidFill>
-                      <a:srgbClr val="F4F1EA"/>
-                    </a:solidFill>
-                  </a:tcPr>
-                </a:tc>
-                <a:tc>
-                  <a:txBody>
-                    <a:bodyPr wrap="square"/>
-                    <a:lstStyle/>
-                    <a:p>
-                      <a:r>
-                        <a:rPr sz="1200" b="0">
-                          <a:solidFill>
-                            <a:srgbClr val="2C2C2C"/>
-                          </a:solidFill>
-                          <a:latin typeface="Calibri"/>
-                        </a:rPr>
-                        <a:t>Already on the 144.</a:t>
-                      </a:r>
-                    </a:p>
-                  </a:txBody>
-                  <a:tcPr>
-                    <a:solidFill>
-                      <a:srgbClr val="F4F1EA"/>
-                    </a:solidFill>
-                  </a:tcPr>
-                </a:tc>
-              </a:tr>
-              <a:tr h="657225">
-                <a:tc>
-                  <a:txBody>
-                    <a:bodyPr wrap="square"/>
-                    <a:lstStyle/>
-                    <a:p>
-                      <a:r>
-                        <a:rPr sz="1200" b="0">
-                          <a:solidFill>
-                            <a:srgbClr val="2C2C2C"/>
-                          </a:solidFill>
-                          <a:latin typeface="Calibri"/>
-                        </a:rPr>
-                        <a:t>Rxfp1</a:t>
-                      </a:r>
-                    </a:p>
-                  </a:txBody>
-                  <a:tcPr>
-                    <a:solidFill>
-                      <a:srgbClr val="FFFFFF"/>
-                    </a:solidFill>
-                  </a:tcPr>
-                </a:tc>
-                <a:tc>
-                  <a:txBody>
-                    <a:bodyPr wrap="square"/>
-                    <a:lstStyle/>
-                    <a:p>
-                      <a:r>
-                        <a:rPr sz="1200" b="0">
-                          <a:solidFill>
-                            <a:srgbClr val="2C2C2C"/>
-                          </a:solidFill>
-                          <a:latin typeface="Calibri"/>
-                        </a:rPr>
-                        <a:t>Top ORB-enriched GPCR (19 subclasses)</a:t>
-                      </a:r>
-                    </a:p>
-                  </a:txBody>
-                  <a:tcPr>
-                    <a:solidFill>
-                      <a:srgbClr val="FFFFFF"/>
-                    </a:solidFill>
-                  </a:tcPr>
-                </a:tc>
-                <a:tc>
-                  <a:txBody>
-                    <a:bodyPr wrap="square"/>
-                    <a:lstStyle/>
-                    <a:p>
-                      <a:r>
-                        <a:rPr sz="1200" b="0">
-                          <a:solidFill>
-                            <a:srgbClr val="2C2C2C"/>
-                          </a:solidFill>
-                          <a:latin typeface="Calibri"/>
-                        </a:rPr>
-                        <a:t>Free on Xenium Mouse Brain v1. Allen 34% in L5 ET.</a:t>
-                      </a:r>
-                    </a:p>
-                  </a:txBody>
-                  <a:tcPr>
-                    <a:solidFill>
-                      <a:srgbClr val="FFFFFF"/>
-                    </a:solidFill>
-                  </a:tcPr>
-                </a:tc>
-              </a:tr>
-              <a:tr h="657225">
-                <a:tc>
-                  <a:txBody>
-                    <a:bodyPr wrap="square"/>
-                    <a:lstStyle/>
-                    <a:p>
-                      <a:r>
-                        <a:rPr sz="1200" b="0">
-                          <a:solidFill>
-                            <a:srgbClr val="2C2C2C"/>
-                          </a:solidFill>
-                          <a:latin typeface="Calibri"/>
-                        </a:rPr>
-                        <a:t>Chrm1  Grm8  Gpr26</a:t>
-                      </a:r>
-                    </a:p>
-                  </a:txBody>
-                  <a:tcPr>
-                    <a:solidFill>
-                      <a:srgbClr val="F4F1EA"/>
-                    </a:solidFill>
-                  </a:tcPr>
-                </a:tc>
-                <a:tc>
-                  <a:txBody>
-                    <a:bodyPr wrap="square"/>
-                    <a:lstStyle/>
-                    <a:p>
-                      <a:r>
-                        <a:rPr sz="1200" b="0">
-                          <a:solidFill>
-                            <a:srgbClr val="2C2C2C"/>
-                          </a:solidFill>
-                          <a:latin typeface="Calibri"/>
-                        </a:rPr>
-                        <a:t>ORB-enriched; missing from our 40-GPCR pull</a:t>
-                      </a:r>
-                    </a:p>
-                  </a:txBody>
-                  <a:tcPr>
-                    <a:solidFill>
-                      <a:srgbClr val="F4F1EA"/>
-                    </a:solidFill>
-                  </a:tcPr>
-                </a:tc>
-                <a:tc>
-                  <a:txBody>
-                    <a:bodyPr wrap="square"/>
-                    <a:lstStyle/>
-                    <a:p>
-                      <a:r>
-                        <a:rPr sz="1200" b="0">
-                          <a:solidFill>
-                            <a:srgbClr val="2C2C2C"/>
-                          </a:solidFill>
-                          <a:latin typeface="Calibri"/>
-                        </a:rPr>
-                        <a:t>Allen: 92% / 99% / 86%. High enough for Xenium.</a:t>
-                      </a:r>
-                    </a:p>
-                  </a:txBody>
-                  <a:tcPr>
-                    <a:solidFill>
-                      <a:srgbClr val="F4F1EA"/>
-                    </a:solidFill>
-                  </a:tcPr>
-                </a:tc>
-              </a:tr>
-              <a:tr h="657225">
-                <a:tc>
-                  <a:txBody>
-                    <a:bodyPr wrap="square"/>
-                    <a:lstStyle/>
-                    <a:p>
-                      <a:r>
-                        <a:rPr sz="1200" b="0">
-                          <a:solidFill>
-                            <a:srgbClr val="2C2C2C"/>
-                          </a:solidFill>
-                          <a:latin typeface="Calibri"/>
-                        </a:rPr>
-                        <a:t>Mas1  Gpr68  Mchr1</a:t>
-                      </a:r>
-                    </a:p>
-                  </a:txBody>
-                  <a:tcPr>
-                    <a:solidFill>
-                      <a:srgbClr val="FFFFFF"/>
-                    </a:solidFill>
-                  </a:tcPr>
-                </a:tc>
-                <a:tc>
-                  <a:txBody>
-                    <a:bodyPr wrap="square"/>
-                    <a:lstStyle/>
-                    <a:p>
-                      <a:r>
-                        <a:rPr sz="1200" b="0">
-                          <a:solidFill>
-                            <a:srgbClr val="2C2C2C"/>
-                          </a:solidFill>
-                          <a:latin typeface="Calibri"/>
-                        </a:rPr>
-                        <a:t>Jesse Glut ranks 1, 3, 4 (relative enrichment)</a:t>
-                      </a:r>
-                    </a:p>
-                  </a:txBody>
-                  <a:tcPr>
-                    <a:solidFill>
-                      <a:srgbClr val="FFFFFF"/>
-                    </a:solidFill>
-                  </a:tcPr>
-                </a:tc>
-                <a:tc>
-                  <a:txBody>
-                    <a:bodyPr wrap="square"/>
-                    <a:lstStyle/>
-                    <a:p>
-                      <a:r>
-                        <a:rPr sz="1200" b="0">
-                          <a:solidFill>
-                            <a:srgbClr val="2C2C2C"/>
-                          </a:solidFill>
-                          <a:latin typeface="Calibri"/>
-                        </a:rPr>
-                        <a:t>Allen absolute % is modest (45 / 40 / 32). Mchr1 too weak.</a:t>
-                      </a:r>
-                    </a:p>
-                  </a:txBody>
-                  <a:tcPr>
-                    <a:solidFill>
-                      <a:srgbClr val="FFFFFF"/>
-                    </a:solidFill>
-                  </a:tcPr>
-                </a:tc>
-              </a:tr>
-              <a:tr h="657225">
-                <a:tc>
-                  <a:txBody>
-                    <a:bodyPr wrap="square"/>
-                    <a:lstStyle/>
-                    <a:p>
-                      <a:r>
-                        <a:rPr sz="1200" b="0">
-                          <a:solidFill>
-                            <a:srgbClr val="2C2C2C"/>
-                          </a:solidFill>
-                          <a:latin typeface="Calibri"/>
-                        </a:rPr>
-                        <a:t>~160 TFs; Camk2g  Fxr1</a:t>
-                      </a:r>
-                    </a:p>
-                  </a:txBody>
-                  <a:tcPr>
-                    <a:solidFill>
-                      <a:srgbClr val="F4F1EA"/>
-                    </a:solidFill>
-                  </a:tcPr>
-                </a:tc>
-                <a:tc>
-                  <a:txBody>
-                    <a:bodyPr wrap="square"/>
-                    <a:lstStyle/>
-                    <a:p>
-                      <a:r>
-                        <a:rPr sz="1200" b="0">
-                          <a:solidFill>
-                            <a:srgbClr val="2C2C2C"/>
-                          </a:solidFill>
-                          <a:latin typeface="Calibri"/>
-                        </a:rPr>
-                        <a:t>Broad chromatin or plasticity DEGs</a:t>
-                      </a:r>
-                    </a:p>
-                  </a:txBody>
-                  <a:tcPr>
-                    <a:solidFill>
-                      <a:srgbClr val="F4F1EA"/>
-                    </a:solidFill>
-                  </a:tcPr>
-                </a:tc>
-                <a:tc>
-                  <a:txBody>
-                    <a:bodyPr wrap="square"/>
-                    <a:lstStyle/>
-                    <a:p>
-                      <a:r>
-                        <a:rPr sz="1200" b="0">
-                          <a:solidFill>
-                            <a:srgbClr val="2C2C2C"/>
-                          </a:solidFill>
-                          <a:latin typeface="Calibri"/>
-                        </a:rPr>
-                        <a:t>TFs skipped. Camk2g is abundant (93%) but not ORB-specific.</a:t>
-                      </a:r>
-                    </a:p>
-                  </a:txBody>
-                  <a:tcPr>
-                    <a:solidFill>
-                      <a:srgbClr val="F4F1EA"/>
-                    </a:solidFill>
-                  </a:tcPr>
-                </a:tc>
-              </a:tr>
-            </a:tbl>
-          </a:graphicData>
-        </a:graphic>
-      </p:graphicFrame>
-      <p:sp>
-        <p:nvSpPr>
-          <p:cNvPr id="6" name="TextBox 5"/>
+        </p:nvPicPr>
+        <p:blipFill>
+          <a:blip r:embed="rId2"/>
+          <a:stretch>
+            <a:fillRect/>
+          </a:stretch>
+        </p:blipFill>
+        <p:spPr>
+          <a:xfrm>
+            <a:off x="228600" y="896112"/>
+            <a:ext cx="5852160" cy="5440680"/>
+          </a:xfrm>
+          <a:prstGeom prst="rect">
+            <a:avLst/>
+          </a:prstGeom>
+        </p:spPr>
+      </p:pic>
+      <p:pic>
+        <p:nvPicPr>
+          <p:cNvPr id="6" name="Picture 5" descr="Jesse_Fig5_IEG_subclass_matrix.png"/>
+          <p:cNvPicPr>
+            <a:picLocks noChangeAspect="1"/>
+          </p:cNvPicPr>
+          <p:nvPr/>
+        </p:nvPicPr>
+        <p:blipFill>
+          <a:blip r:embed="rId3"/>
+          <a:stretch>
+            <a:fillRect/>
+          </a:stretch>
+        </p:blipFill>
+        <p:spPr>
+          <a:xfrm>
+            <a:off x="6172200" y="896112"/>
+            <a:ext cx="5715000" cy="5440680"/>
+          </a:xfrm>
+          <a:prstGeom prst="rect">
+            <a:avLst/>
+          </a:prstGeom>
+        </p:spPr>
+      </p:pic>
+      <p:sp>
+        <p:nvSpPr>
+          <p:cNvPr id="7" name="TextBox 6"/>
           <p:cNvSpPr txBox="1"/>
           <p:nvPr/>
         </p:nvSpPr>
         <p:spPr>
           <a:xfrm>
-            <a:off x="411480" y="6565392"/>
-            <a:ext cx="11338560" cy="237744"/>
+            <a:off x="365760" y="6565392"/>
+            <a:ext cx="11430000" cy="237744"/>
           </a:xfrm>
           <a:prstGeom prst="rect">
             <a:avLst/>
@@ -4883,7 +3490,7 @@
                 </a:solidFill>
                 <a:latin typeface="Calibri"/>
               </a:rPr>
-              <a:t>Xenium ORBm + BMAp add-on  |  Dan GSE283418  ·  Jesse PL-ILA-ORB  ·  Allen WMB-10X  |  2/3</a:t>
+              <a:t>Xenium ORBm + BMAp  |  same figures as the long collaborator deck  |  2/4</a:t>
             </a:r>
           </a:p>
         </p:txBody>
@@ -4897,6 +3504,217 @@
 </file>
 
 <file path=ppt/slides/slide3.xml><?xml version="1.0" encoding="utf-8"?>
+<p:sld xmlns:a="http://schemas.openxmlformats.org/drawingml/2006/main" xmlns:p="http://schemas.openxmlformats.org/presentationml/2006/main" xmlns:r="http://schemas.openxmlformats.org/officeDocument/2006/relationships">
+  <p:cSld>
+    <p:spTree>
+      <p:nvGrpSpPr>
+        <p:cNvPr id="1" name=""/>
+        <p:cNvGrpSpPr/>
+        <p:nvPr/>
+      </p:nvGrpSpPr>
+      <p:grpSpPr/>
+      <p:sp>
+        <p:nvSpPr>
+          <p:cNvPr id="2" name="Rectangle 1"/>
+          <p:cNvSpPr/>
+          <p:nvPr/>
+        </p:nvSpPr>
+        <p:spPr>
+          <a:xfrm>
+            <a:off x="0" y="0"/>
+            <a:ext cx="12191695" cy="91440"/>
+          </a:xfrm>
+          <a:prstGeom prst="rect">
+            <a:avLst/>
+          </a:prstGeom>
+          <a:solidFill>
+            <a:srgbClr val="2A6F97"/>
+          </a:solidFill>
+          <a:ln>
+            <a:noFill/>
+          </a:ln>
+        </p:spPr>
+        <p:style>
+          <a:lnRef idx="1">
+            <a:schemeClr val="accent1"/>
+          </a:lnRef>
+          <a:fillRef idx="3">
+            <a:schemeClr val="accent1"/>
+          </a:fillRef>
+          <a:effectRef idx="2">
+            <a:schemeClr val="accent1"/>
+          </a:effectRef>
+          <a:fontRef idx="minor">
+            <a:schemeClr val="lt1"/>
+          </a:fontRef>
+        </p:style>
+        <p:txBody>
+          <a:bodyPr rtlCol="0" anchor="ctr"/>
+          <a:lstStyle/>
+          <a:p>
+            <a:pPr algn="ctr"/>
+          </a:p>
+        </p:txBody>
+      </p:sp>
+      <p:sp>
+        <p:nvSpPr>
+          <p:cNvPr id="3" name="TextBox 2"/>
+          <p:cNvSpPr txBox="1"/>
+          <p:nvPr/>
+        </p:nvSpPr>
+        <p:spPr>
+          <a:xfrm>
+            <a:off x="365760" y="164592"/>
+            <a:ext cx="11430000" cy="384048"/>
+          </a:xfrm>
+          <a:prstGeom prst="rect">
+            <a:avLst/>
+          </a:prstGeom>
+          <a:noFill/>
+        </p:spPr>
+        <p:txBody>
+          <a:bodyPr wrap="none">
+            <a:spAutoFit/>
+          </a:bodyPr>
+          <a:lstStyle/>
+          <a:p>
+            <a:r>
+              <a:rPr sz="2400" b="1">
+                <a:solidFill>
+                  <a:srgbClr val="2A6F97"/>
+                </a:solidFill>
+                <a:latin typeface="Calibri"/>
+              </a:rPr>
+              <a:t>Dan  |  how the 98-gene spatial panel looks</a:t>
+            </a:r>
+          </a:p>
+        </p:txBody>
+      </p:sp>
+      <p:sp>
+        <p:nvSpPr>
+          <p:cNvPr id="4" name="TextBox 3"/>
+          <p:cNvSpPr txBox="1"/>
+          <p:nvPr/>
+        </p:nvSpPr>
+        <p:spPr>
+          <a:xfrm>
+            <a:off x="365760" y="530352"/>
+            <a:ext cx="11430000" cy="292608"/>
+          </a:xfrm>
+          <a:prstGeom prst="rect">
+            <a:avLst/>
+          </a:prstGeom>
+          <a:noFill/>
+        </p:spPr>
+        <p:txBody>
+          <a:bodyPr wrap="none">
+            <a:spAutoFit/>
+          </a:bodyPr>
+          <a:lstStyle/>
+          <a:p>
+            <a:r>
+              <a:rPr sz="1300" b="0">
+                <a:solidFill>
+                  <a:srgbClr val="6B6B6B"/>
+                </a:solidFill>
+                <a:latin typeface="Calibri"/>
+              </a:rPr>
+              <a:t>GSE283418 Resolve smFISH  ·  98 amygdala genes vs our shared panel, re-scored in Allen BMAp.  Left: fate of 98.  Right: the 14 extras.</a:t>
+            </a:r>
+          </a:p>
+        </p:txBody>
+      </p:sp>
+      <p:pic>
+        <p:nvPicPr>
+          <p:cNvPr id="5" name="Picture 4" descr="Dan_Fig1_98gene_fate.png"/>
+          <p:cNvPicPr>
+            <a:picLocks noChangeAspect="1"/>
+          </p:cNvPicPr>
+          <p:nvPr/>
+        </p:nvPicPr>
+        <p:blipFill>
+          <a:blip r:embed="rId2"/>
+          <a:stretch>
+            <a:fillRect/>
+          </a:stretch>
+        </p:blipFill>
+        <p:spPr>
+          <a:xfrm>
+            <a:off x="228600" y="896112"/>
+            <a:ext cx="5212080" cy="5440680"/>
+          </a:xfrm>
+          <a:prstGeom prst="rect">
+            <a:avLst/>
+          </a:prstGeom>
+        </p:spPr>
+      </p:pic>
+      <p:pic>
+        <p:nvPicPr>
+          <p:cNvPr id="6" name="Picture 5" descr="Dan_Fig2_14added_pct.png"/>
+          <p:cNvPicPr>
+            <a:picLocks noChangeAspect="1"/>
+          </p:cNvPicPr>
+          <p:nvPr/>
+        </p:nvPicPr>
+        <p:blipFill>
+          <a:blip r:embed="rId3"/>
+          <a:stretch>
+            <a:fillRect/>
+          </a:stretch>
+        </p:blipFill>
+        <p:spPr>
+          <a:xfrm>
+            <a:off x="5532120" y="896112"/>
+            <a:ext cx="6355080" cy="5440680"/>
+          </a:xfrm>
+          <a:prstGeom prst="rect">
+            <a:avLst/>
+          </a:prstGeom>
+        </p:spPr>
+      </p:pic>
+      <p:sp>
+        <p:nvSpPr>
+          <p:cNvPr id="7" name="TextBox 6"/>
+          <p:cNvSpPr txBox="1"/>
+          <p:nvPr/>
+        </p:nvSpPr>
+        <p:spPr>
+          <a:xfrm>
+            <a:off x="365760" y="6565392"/>
+            <a:ext cx="11430000" cy="237744"/>
+          </a:xfrm>
+          <a:prstGeom prst="rect">
+            <a:avLst/>
+          </a:prstGeom>
+          <a:noFill/>
+        </p:spPr>
+        <p:txBody>
+          <a:bodyPr wrap="none">
+            <a:spAutoFit/>
+          </a:bodyPr>
+          <a:lstStyle/>
+          <a:p>
+            <a:r>
+              <a:rPr sz="1100" b="0">
+                <a:solidFill>
+                  <a:srgbClr val="6B6B6B"/>
+                </a:solidFill>
+                <a:latin typeface="Calibri"/>
+              </a:rPr>
+              <a:t>Xenium ORBm + BMAp  |  same figures as the long collaborator deck  |  3/4</a:t>
+            </a:r>
+          </a:p>
+        </p:txBody>
+      </p:sp>
+    </p:spTree>
+  </p:cSld>
+  <p:clrMapOvr>
+    <a:masterClrMapping/>
+  </p:clrMapOvr>
+</p:sld>
+</file>
+
+<file path=ppt/slides/slide4.xml><?xml version="1.0" encoding="utf-8"?>
 <p:sld xmlns:a="http://schemas.openxmlformats.org/drawingml/2006/main" xmlns:p="http://schemas.openxmlformats.org/presentationml/2006/main" xmlns:r="http://schemas.openxmlformats.org/officeDocument/2006/relationships">
   <p:cSld>
     <p:spTree>
@@ -4957,8 +3775,8 @@
         </p:nvSpPr>
         <p:spPr>
           <a:xfrm>
-            <a:off x="411480" y="201168"/>
-            <a:ext cx="11338560" cy="402336"/>
+            <a:off x="365760" y="164592"/>
+            <a:ext cx="11430000" cy="384048"/>
           </a:xfrm>
           <a:prstGeom prst="rect">
             <a:avLst/>
@@ -4972,9 +3790,9 @@
           <a:lstStyle/>
           <a:p>
             <a:r>
-              <a:rPr sz="2600" b="1">
+              <a:rPr sz="2400" b="1">
                 <a:solidFill>
-                  <a:srgbClr val="1D4E89"/>
+                  <a:srgbClr val="C44536"/>
                 </a:solidFill>
                 <a:latin typeface="Calibri"/>
               </a:rPr>
@@ -4991,8 +3809,8 @@
         </p:nvSpPr>
         <p:spPr>
           <a:xfrm>
-            <a:off x="411480" y="603504"/>
-            <a:ext cx="11338560" cy="292608"/>
+            <a:off x="365760" y="530352"/>
+            <a:ext cx="11430000" cy="292608"/>
           </a:xfrm>
           <a:prstGeom prst="rect">
             <a:avLst/>
@@ -5006,13 +3824,13 @@
           <a:lstStyle/>
           <a:p>
             <a:r>
-              <a:rPr sz="1400" b="0">
+              <a:rPr sz="1300" b="0">
                 <a:solidFill>
                   <a:srgbClr val="6B6B6B"/>
                 </a:solidFill>
                 <a:latin typeface="Calibri"/>
               </a:rPr>
-              <a:t>Cell-type 144 stays. Dan 14 are already on MSGS111. Below is the Jesse + Allen add.</a:t>
+              <a:t>Read from the figures: Jesse’s new IEG program + high-abundance ORB GPCRs. Dan’s 14 are already on MSGS111.</a:t>
             </a:r>
           </a:p>
         </p:txBody>
@@ -5026,8 +3844,8 @@
           <p:nvPr/>
         </p:nvGraphicFramePr>
         <p:xfrm>
-          <a:off x="320040" y="987552"/>
-          <a:ext cx="11521440" cy="4434840"/>
+          <a:off x="320040" y="932688"/>
+          <a:ext cx="11521440" cy="4709160"/>
         </p:xfrm>
         <a:graphic>
           <a:graphicData uri="http://schemas.openxmlformats.org/drawingml/2006/table">
@@ -5036,12 +3854,12 @@
                 <a:tableStyleId>{5C22544A-7EE6-4342-B048-85BDC9FD1C3A}</a:tableStyleId>
               </a:tblPr>
               <a:tblGrid>
-                <a:gridCol w="2194560"/>
-                <a:gridCol w="3200400"/>
-                <a:gridCol w="5029200"/>
+                <a:gridCol w="1965960"/>
+                <a:gridCol w="2606040"/>
+                <a:gridCol w="5852160"/>
                 <a:gridCol w="1097280"/>
               </a:tblGrid>
-              <a:tr h="633548">
+              <a:tr h="784860">
                 <a:tc>
                   <a:txBody>
                     <a:bodyPr wrap="square"/>
@@ -5060,7 +3878,7 @@
                   </a:txBody>
                   <a:tcPr>
                     <a:solidFill>
-                      <a:srgbClr val="1D4E89"/>
+                      <a:srgbClr val="C44536"/>
                     </a:solidFill>
                   </a:tcPr>
                 </a:tc>
@@ -5082,7 +3900,7 @@
                   </a:txBody>
                   <a:tcPr>
                     <a:solidFill>
-                      <a:srgbClr val="1D4E89"/>
+                      <a:srgbClr val="C44536"/>
                     </a:solidFill>
                   </a:tcPr>
                 </a:tc>
@@ -5098,13 +3916,13 @@
                           </a:solidFill>
                           <a:latin typeface="Calibri"/>
                         </a:rPr>
-                        <a:t>Why this is the final add</a:t>
+                        <a:t>Why  (from the data on slides 1–3)</a:t>
                       </a:r>
                     </a:p>
                   </a:txBody>
                   <a:tcPr>
                     <a:solidFill>
-                      <a:srgbClr val="1D4E89"/>
+                      <a:srgbClr val="C44536"/>
                     </a:solidFill>
                   </a:tcPr>
                 </a:tc>
@@ -5126,19 +3944,19 @@
                   </a:txBody>
                   <a:tcPr>
                     <a:solidFill>
-                      <a:srgbClr val="1D4E89"/>
+                      <a:srgbClr val="C44536"/>
                     </a:solidFill>
                   </a:tcPr>
                 </a:tc>
               </a:tr>
-              <a:tr h="633548">
+              <a:tr h="784860">
                 <a:tc>
                   <a:txBody>
                     <a:bodyPr wrap="square"/>
                     <a:lstStyle/>
                     <a:p>
                       <a:r>
-                        <a:rPr sz="1200" b="0">
+                        <a:rPr sz="1300" b="0">
                           <a:solidFill>
                             <a:srgbClr val="2C2C2C"/>
                           </a:solidFill>
@@ -5160,13 +3978,13 @@
                     <a:lstStyle/>
                     <a:p>
                       <a:r>
-                        <a:rPr sz="1200" b="0">
+                        <a:rPr sz="1300" b="0">
                           <a:solidFill>
                             <a:srgbClr val="2C2C2C"/>
                           </a:solidFill>
                           <a:latin typeface="Calibri"/>
                         </a:rPr>
-                        <a:t>Dan 14   (Lamb3, Cck, Col23a1, …)</a:t>
+                        <a:t>Dan 14   Lamb3  Cck  Col23a1 …</a:t>
                       </a:r>
                     </a:p>
                   </a:txBody>
@@ -5182,13 +4000,13 @@
                     <a:lstStyle/>
                     <a:p>
                       <a:r>
-                        <a:rPr sz="1200" b="0">
+                        <a:rPr sz="1300" b="0">
                           <a:solidFill>
                             <a:srgbClr val="2C2C2C"/>
                           </a:solidFill>
                           <a:latin typeface="Calibri"/>
                         </a:rPr>
-                        <a:t>Amygdala spatial genes Dan uses; already ranks 145–158</a:t>
+                        <a:t>38/98 already on the 144. These 14 were the remaining BMAp-informative genes (right plot, slide 3).</a:t>
                       </a:r>
                     </a:p>
                   </a:txBody>
@@ -5204,13 +4022,13 @@
                     <a:lstStyle/>
                     <a:p>
                       <a:r>
-                        <a:rPr sz="1200" b="0">
+                        <a:rPr sz="1300" b="0">
                           <a:solidFill>
                             <a:srgbClr val="2C2C2C"/>
                           </a:solidFill>
                           <a:latin typeface="Calibri"/>
                         </a:rPr>
-                        <a:t>14 (done)</a:t>
+                        <a:t>14  done</a:t>
                       </a:r>
                     </a:p>
                   </a:txBody>
@@ -5221,20 +4039,20 @@
                   </a:tcPr>
                 </a:tc>
               </a:tr>
-              <a:tr h="633548">
+              <a:tr h="784860">
                 <a:tc>
                   <a:txBody>
                     <a:bodyPr wrap="square"/>
                     <a:lstStyle/>
                     <a:p>
                       <a:r>
-                        <a:rPr sz="1200" b="0">
+                        <a:rPr sz="1300" b="0">
                           <a:solidFill>
                             <a:srgbClr val="2C2C2C"/>
                           </a:solidFill>
                           <a:latin typeface="Calibri"/>
                         </a:rPr>
-                        <a:t>ADD  (free)</a:t>
+                        <a:t>ADD  free</a:t>
                       </a:r>
                     </a:p>
                   </a:txBody>
@@ -5250,7 +4068,7 @@
                     <a:lstStyle/>
                     <a:p>
                       <a:r>
-                        <a:rPr sz="1200" b="0">
+                        <a:rPr sz="1300" b="0">
                           <a:solidFill>
                             <a:srgbClr val="2C2C2C"/>
                           </a:solidFill>
@@ -5272,13 +4090,13 @@
                     <a:lstStyle/>
                     <a:p>
                       <a:r>
-                        <a:rPr sz="1200" b="0">
+                        <a:rPr sz="1300" b="0">
                           <a:solidFill>
                             <a:srgbClr val="2C2C2C"/>
                           </a:solidFill>
                           <a:latin typeface="Calibri"/>
                         </a:rPr>
-                        <a:t>Jesse’s top ORB GPCR; already on the Xenium base panel</a:t>
+                        <a:t>Jesse’s top ORB-enriched GPCR (slide 2, left). Already on Xenium Mouse Brain v1. Allen 34% in L5 ET.</a:t>
                       </a:r>
                     </a:p>
                   </a:txBody>
@@ -5294,7 +4112,7 @@
                     <a:lstStyle/>
                     <a:p>
                       <a:r>
-                        <a:rPr sz="1200" b="0">
+                        <a:rPr sz="1300" b="0">
                           <a:solidFill>
                             <a:srgbClr val="2C2C2C"/>
                           </a:solidFill>
@@ -5311,14 +4129,14 @@
                   </a:tcPr>
                 </a:tc>
               </a:tr>
-              <a:tr h="633548">
+              <a:tr h="784860">
                 <a:tc>
                   <a:txBody>
                     <a:bodyPr wrap="square"/>
                     <a:lstStyle/>
                     <a:p>
                       <a:r>
-                        <a:rPr sz="1200" b="0">
+                        <a:rPr sz="1300" b="0">
                           <a:solidFill>
                             <a:srgbClr val="2C2C2C"/>
                           </a:solidFill>
@@ -5340,7 +4158,7 @@
                     <a:lstStyle/>
                     <a:p>
                       <a:r>
-                        <a:rPr sz="1200" b="0">
+                        <a:rPr sz="1300" b="0">
                           <a:solidFill>
                             <a:srgbClr val="2C2C2C"/>
                           </a:solidFill>
@@ -5362,13 +4180,13 @@
                     <a:lstStyle/>
                     <a:p>
                       <a:r>
-                        <a:rPr sz="1200" b="0">
+                        <a:rPr sz="1300" b="0">
                           <a:solidFill>
                             <a:srgbClr val="2C2C2C"/>
                           </a:solidFill>
                           <a:latin typeface="Calibri"/>
                         </a:rPr>
-                        <a:t>Jesse’s morphine-state IEG program. Per1 is 63% in Allen ORBm.</a:t>
+                        <a:t>Widest new IEGs on slide 1 — broader than Fos/Arc. Slide 2 matrix: they cut across ORBm excitatory types.</a:t>
                       </a:r>
                     </a:p>
                   </a:txBody>
@@ -5384,7 +4202,7 @@
                     <a:lstStyle/>
                     <a:p>
                       <a:r>
-                        <a:rPr sz="1200" b="0">
+                        <a:rPr sz="1300" b="0">
                           <a:solidFill>
                             <a:srgbClr val="2C2C2C"/>
                           </a:solidFill>
@@ -5401,14 +4219,14 @@
                   </a:tcPr>
                 </a:tc>
               </a:tr>
-              <a:tr h="633548">
+              <a:tr h="784860">
                 <a:tc>
                   <a:txBody>
                     <a:bodyPr wrap="square"/>
                     <a:lstStyle/>
                     <a:p>
                       <a:r>
-                        <a:rPr sz="1200" b="0">
+                        <a:rPr sz="1300" b="0">
                           <a:solidFill>
                             <a:srgbClr val="2C2C2C"/>
                           </a:solidFill>
@@ -5430,7 +4248,7 @@
                     <a:lstStyle/>
                     <a:p>
                       <a:r>
-                        <a:rPr sz="1200" b="0">
+                        <a:rPr sz="1300" b="0">
                           <a:solidFill>
                             <a:srgbClr val="2C2C2C"/>
                           </a:solidFill>
@@ -5452,13 +4270,13 @@
                     <a:lstStyle/>
                     <a:p>
                       <a:r>
-                        <a:rPr sz="1200" b="0">
+                        <a:rPr sz="1300" b="0">
                           <a:solidFill>
                             <a:srgbClr val="2C2C2C"/>
                           </a:solidFill>
                           <a:latin typeface="Calibri"/>
                         </a:rPr>
-                        <a:t>ORB-enriched in Jesse; highest Allen abundance (92%, 99%)</a:t>
+                        <a:t>ORB-enriched on slide 2. Allen absolute % is 92% and 99% — unlike Mas1 / Gpr68 / Mchr1 (45 / 40 / 32%).</a:t>
                       </a:r>
                     </a:p>
                   </a:txBody>
@@ -5474,7 +4292,7 @@
                     <a:lstStyle/>
                     <a:p>
                       <a:r>
-                        <a:rPr sz="1200" b="0">
+                        <a:rPr sz="1300" b="0">
                           <a:solidFill>
                             <a:srgbClr val="2C2C2C"/>
                           </a:solidFill>
@@ -5491,14 +4309,14 @@
                   </a:tcPr>
                 </a:tc>
               </a:tr>
-              <a:tr h="633548">
+              <a:tr h="784860">
                 <a:tc>
                   <a:txBody>
                     <a:bodyPr wrap="square"/>
                     <a:lstStyle/>
                     <a:p>
                       <a:r>
-                        <a:rPr sz="1200" b="0">
+                        <a:rPr sz="1300" b="0">
                           <a:solidFill>
                             <a:srgbClr val="2C2C2C"/>
                           </a:solidFill>
@@ -5520,13 +4338,13 @@
                     <a:lstStyle/>
                     <a:p>
                       <a:r>
-                        <a:rPr sz="1200" b="0">
+                        <a:rPr sz="1300" b="0">
                           <a:solidFill>
                             <a:srgbClr val="2C2C2C"/>
                           </a:solidFill>
                           <a:latin typeface="Calibri"/>
                         </a:rPr>
-                        <a:t>Mas1   Gpr68   Mchr1</a:t>
+                        <a:t>Mas1   Gpr68   Mchr1    160 TFs</a:t>
                       </a:r>
                     </a:p>
                   </a:txBody>
@@ -5542,13 +4360,13 @@
                     <a:lstStyle/>
                     <a:p>
                       <a:r>
-                        <a:rPr sz="1200" b="0">
+                        <a:rPr sz="1300" b="0">
                           <a:solidFill>
                             <a:srgbClr val="2C2C2C"/>
                           </a:solidFill>
                           <a:latin typeface="Calibri"/>
                         </a:rPr>
-                        <a:t>Relative ORB hits, but Allen % is too low vs Chrm1/Grm8</a:t>
+                        <a:t>High on Jesse’s relative-enrichment bar, but too low or too generic for a scarce Xenium slot.</a:t>
                       </a:r>
                     </a:p>
                   </a:txBody>
@@ -5564,7 +4382,7 @@
                     <a:lstStyle/>
                     <a:p>
                       <a:r>
-                        <a:rPr sz="1200" b="0">
+                        <a:rPr sz="1300" b="0">
                           <a:solidFill>
                             <a:srgbClr val="2C2C2C"/>
                           </a:solidFill>
@@ -5581,96 +4399,6 @@
                   </a:tcPr>
                 </a:tc>
               </a:tr>
-              <a:tr h="633552">
-                <a:tc>
-                  <a:txBody>
-                    <a:bodyPr wrap="square"/>
-                    <a:lstStyle/>
-                    <a:p>
-                      <a:r>
-                        <a:rPr sz="1200" b="0">
-                          <a:solidFill>
-                            <a:srgbClr val="2C2C2C"/>
-                          </a:solidFill>
-                          <a:latin typeface="Calibri"/>
-                        </a:rPr>
-                        <a:t>Not added</a:t>
-                      </a:r>
-                    </a:p>
-                  </a:txBody>
-                  <a:tcPr>
-                    <a:solidFill>
-                      <a:srgbClr val="FFFFFF"/>
-                    </a:solidFill>
-                  </a:tcPr>
-                </a:tc>
-                <a:tc>
-                  <a:txBody>
-                    <a:bodyPr wrap="square"/>
-                    <a:lstStyle/>
-                    <a:p>
-                      <a:r>
-                        <a:rPr sz="1200" b="0">
-                          <a:solidFill>
-                            <a:srgbClr val="2C2C2C"/>
-                          </a:solidFill>
-                          <a:latin typeface="Calibri"/>
-                        </a:rPr>
-                        <a:t>160 TFs   Fxr1   Vps13a</a:t>
-                      </a:r>
-                    </a:p>
-                  </a:txBody>
-                  <a:tcPr>
-                    <a:solidFill>
-                      <a:srgbClr val="FFFFFF"/>
-                    </a:solidFill>
-                  </a:tcPr>
-                </a:tc>
-                <a:tc>
-                  <a:txBody>
-                    <a:bodyPr wrap="square"/>
-                    <a:lstStyle/>
-                    <a:p>
-                      <a:r>
-                        <a:rPr sz="1200" b="0">
-                          <a:solidFill>
-                            <a:srgbClr val="2C2C2C"/>
-                          </a:solidFill>
-                          <a:latin typeface="Calibri"/>
-                        </a:rPr>
-                        <a:t>Not cell-type or ORB-specific. Fos/Arc already cover activity.</a:t>
-                      </a:r>
-                    </a:p>
-                  </a:txBody>
-                  <a:tcPr>
-                    <a:solidFill>
-                      <a:srgbClr val="FFFFFF"/>
-                    </a:solidFill>
-                  </a:tcPr>
-                </a:tc>
-                <a:tc>
-                  <a:txBody>
-                    <a:bodyPr wrap="square"/>
-                    <a:lstStyle/>
-                    <a:p>
-                      <a:r>
-                        <a:rPr sz="1200" b="0">
-                          <a:solidFill>
-                            <a:srgbClr val="2C2C2C"/>
-                          </a:solidFill>
-                          <a:latin typeface="Calibri"/>
-                        </a:rPr>
-                        <a:t>—</a:t>
-                      </a:r>
-                    </a:p>
-                  </a:txBody>
-                  <a:tcPr>
-                    <a:solidFill>
-                      <a:srgbClr val="FFFFFF"/>
-                    </a:solidFill>
-                  </a:tcPr>
-                </a:tc>
-              </a:tr>
             </a:tbl>
           </a:graphicData>
         </a:graphic>
@@ -5683,8 +4411,8 @@
         </p:nvSpPr>
         <p:spPr>
           <a:xfrm>
-            <a:off x="365760" y="5577840"/>
-            <a:ext cx="11430000" cy="822960"/>
+            <a:off x="365760" y="5742432"/>
+            <a:ext cx="11430000" cy="685800"/>
           </a:xfrm>
           <a:prstGeom prst="rect">
             <a:avLst/>
@@ -5704,7 +4432,7 @@
                 </a:solidFill>
                 <a:latin typeface="Calibri"/>
               </a:rPr>
-              <a:t>Final new genes:    Rxfp1   +   Per2   Pcsk1   Per1   +   Chrm1   Grm8</a:t>
+              <a:t>Final new add:    Rxfp1   +   Per2  Pcsk1  Per1   +   Chrm1  Grm8</a:t>
             </a:r>
           </a:p>
           <a:p>
@@ -5715,7 +4443,7 @@
                 </a:solidFill>
                 <a:latin typeface="Calibri"/>
               </a:rPr>
-              <a:t>Five custom slots on top of Dan 14  →  119 custom if every Dan gene is kept.  Cap is 100; swap CEA-border Dan genes if 10x will not exceed it.</a:t>
+              <a:t>Five custom slots on top of Dan 14  →  119 if every Dan gene is kept.  If the cap stays 100, drop CEA-border Dan genes first.</a:t>
             </a:r>
           </a:p>
         </p:txBody>
@@ -5728,8 +4456,8 @@
         </p:nvSpPr>
         <p:spPr>
           <a:xfrm>
-            <a:off x="411480" y="6565392"/>
-            <a:ext cx="11338560" cy="237744"/>
+            <a:off x="365760" y="6565392"/>
+            <a:ext cx="11430000" cy="237744"/>
           </a:xfrm>
           <a:prstGeom prst="rect">
             <a:avLst/>
@@ -5749,7 +4477,7 @@
                 </a:solidFill>
                 <a:latin typeface="Calibri"/>
               </a:rPr>
-              <a:t>Xenium ORBm + BMAp add-on  |  Dan GSE283418  ·  Jesse PL-ILA-ORB  ·  Allen WMB-10X  |  3/3</a:t>
+              <a:t>Xenium ORBm + BMAp  |  same figures as the long collaborator deck  |  4/4</a:t>
             </a:r>
           </a:p>
         </p:txBody>

</xml_diff>